<commit_message>
build(pptx): 제품 축 ④ 재설계: Samsung Blue 단일 액센트 + 3컬럼 (v2.46.8)
- 스킬 컬러 토큰 적용(#1428A0), 3컬럼: 플라이휠·약자 풀네임 / SCA+Micron 선례 / FDP·FDE 기술·채용·양성·운영
- FDP 슬라이드 헤더 제목 em-dash를 콜론으로 교체, pptx 재생성·다운로드 미러

Co-Authored-By: Claude Fable 5 <noreply@anthropic.com>
Claude-Session: https://claude.ai/code/session_01P75FajBNDiW5p24ay2HU9V
</commit_message>
<xml_diff>
--- a/dashboard/public/downloads/dev-transformation-summary-fdp-eco.pptx
+++ b/dashboard/public/downloads/dev-transformation-summary-fdp-eco.pptx
@@ -901,7 +901,7 @@
                 <a:ea typeface="Malgun Gothic" pitchFamily="34" charset="-122"/>
                 <a:cs typeface="Malgun Gothic" pitchFamily="34" charset="-120"/>
               </a:rPr>
-              <a:t>제품·기술 축 — FDP Host–SSD 통합 플랫폼</a:t>
+              <a:t>제품·기술 축: FDP Host–SSD 통합 플랫폼</a:t>
             </a:r>
             <a:endParaRPr lang="en-US" sz="3200" dirty="0"/>
           </a:p>
@@ -1055,7 +1055,7 @@
             <a:r>
               <a:rPr lang="en-US" sz="1300" b="1" dirty="0">
                 <a:solidFill>
-                  <a:srgbClr val="028090"/>
+                  <a:srgbClr val="1428A0"/>
                 </a:solidFill>
                 <a:latin typeface="Malgun Gothic" pitchFamily="34" charset="0"/>
                 <a:ea typeface="Malgun Gothic" pitchFamily="34" charset="-122"/>
@@ -1067,15 +1067,15 @@
               <a:buNone/>
             </a:pPr>
             <a:r>
-              <a:rPr lang="en-US" sz="1300" i="1" dirty="0">
-                <a:solidFill>
-                  <a:srgbClr val="5A7184"/>
-                </a:solidFill>
-                <a:latin typeface="Malgun Gothic" pitchFamily="34" charset="0"/>
-                <a:ea typeface="Malgun Gothic" pitchFamily="34" charset="-122"/>
-                <a:cs typeface="Malgun Gothic" pitchFamily="34" charset="-120"/>
-              </a:rPr>
-              <a:t>SCA로 다가가고 · FDP로 제공하고 · FDE로 협업한다: 워크로드가 들어올수록 전환비용이 커지는 락인 플라이휠</a:t>
+              <a:rPr lang="en-US" sz="1300" dirty="0">
+                <a:solidFill>
+                  <a:srgbClr val="555555"/>
+                </a:solidFill>
+                <a:latin typeface="Malgun Gothic" pitchFamily="34" charset="0"/>
+                <a:ea typeface="Malgun Gothic" pitchFamily="34" charset="-122"/>
+                <a:cs typeface="Malgun Gothic" pitchFamily="34" charset="-120"/>
+              </a:rPr>
+              <a:t>SCA로 다가가고 · FDP로 제공하고 · FDE로 협업한다: 워크로드가 들어올수록 전환비용이 커지는 락인 플라이휠, 다운턴 피해 최소화</a:t>
             </a:r>
             <a:endParaRPr lang="en-US" sz="1300" dirty="0"/>
           </a:p>
@@ -1089,14 +1089,335 @@
         </p:nvSpPr>
         <p:spPr>
           <a:xfrm>
-            <a:off x="1755648" y="1298448"/>
-            <a:ext cx="1024128" cy="1024128"/>
+            <a:off x="457200" y="1188720"/>
+            <a:ext cx="310896" cy="310896"/>
           </a:xfrm>
           <a:prstGeom prst="ellipse">
             <a:avLst/>
           </a:prstGeom>
           <a:solidFill>
-            <a:srgbClr val="5A7184"/>
+            <a:srgbClr val="1428A0"/>
+          </a:solidFill>
+          <a:ln/>
+        </p:spPr>
+        <p:txBody>
+          <a:bodyPr wrap="square" lIns="0" tIns="0" rIns="0" bIns="0" rtlCol="0" anchor="ctr"/>
+          <a:lstStyle/>
+          <a:p>
+            <a:pPr algn="ctr" indent="0" marL="0">
+              <a:buNone/>
+            </a:pPr>
+            <a:r>
+              <a:rPr lang="en-US" sz="1400" b="1" dirty="0">
+                <a:solidFill>
+                  <a:srgbClr val="FFFFFF"/>
+                </a:solidFill>
+                <a:latin typeface="Malgun Gothic" pitchFamily="34" charset="0"/>
+                <a:ea typeface="Malgun Gothic" pitchFamily="34" charset="-122"/>
+                <a:cs typeface="Malgun Gothic" pitchFamily="34" charset="-120"/>
+              </a:rPr>
+              <a:t>1</a:t>
+            </a:r>
+            <a:endParaRPr lang="en-US" sz="1400" dirty="0"/>
+          </a:p>
+        </p:txBody>
+      </p:sp>
+      <p:sp>
+        <p:nvSpPr>
+          <p:cNvPr id="8" name="Text 6"/>
+          <p:cNvSpPr/>
+          <p:nvPr/>
+        </p:nvSpPr>
+        <p:spPr>
+          <a:xfrm>
+            <a:off x="859536" y="1170432"/>
+            <a:ext cx="3200400" cy="347472"/>
+          </a:xfrm>
+          <a:prstGeom prst="rect">
+            <a:avLst/>
+          </a:prstGeom>
+          <a:noFill/>
+          <a:ln/>
+        </p:spPr>
+        <p:txBody>
+          <a:bodyPr wrap="square" lIns="0" tIns="0" rIns="0" bIns="0" rtlCol="0" anchor="ctr"/>
+          <a:lstStyle/>
+          <a:p>
+            <a:pPr indent="0" marL="0">
+              <a:buNone/>
+            </a:pPr>
+            <a:r>
+              <a:rPr lang="en-US" sz="1400" b="1" dirty="0">
+                <a:solidFill>
+                  <a:srgbClr val="1A1A1A"/>
+                </a:solidFill>
+                <a:latin typeface="Malgun Gothic" pitchFamily="34" charset="0"/>
+                <a:ea typeface="Malgun Gothic" pitchFamily="34" charset="-122"/>
+                <a:cs typeface="Malgun Gothic" pitchFamily="34" charset="-120"/>
+              </a:rPr>
+              <a:t>락인 플라이휠</a:t>
+            </a:r>
+            <a:endParaRPr lang="en-US" sz="1400" dirty="0"/>
+          </a:p>
+        </p:txBody>
+      </p:sp>
+      <p:sp>
+        <p:nvSpPr>
+          <p:cNvPr id="9" name="Shape 7"/>
+          <p:cNvSpPr/>
+          <p:nvPr/>
+        </p:nvSpPr>
+        <p:spPr>
+          <a:xfrm>
+            <a:off x="457200" y="1627632"/>
+            <a:ext cx="3602736" cy="4626864"/>
+          </a:xfrm>
+          <a:prstGeom prst="roundRect">
+            <a:avLst>
+              <a:gd name="adj" fmla="val 2030"/>
+            </a:avLst>
+          </a:prstGeom>
+          <a:solidFill>
+            <a:srgbClr val="FFFFFF"/>
+          </a:solidFill>
+          <a:ln w="12700">
+            <a:solidFill>
+              <a:srgbClr val="D9D9D9"/>
+            </a:solidFill>
+            <a:prstDash val="solid"/>
+          </a:ln>
+        </p:spPr>
+      </p:sp>
+      <p:sp>
+        <p:nvSpPr>
+          <p:cNvPr id="10" name="Text 8"/>
+          <p:cNvSpPr/>
+          <p:nvPr/>
+        </p:nvSpPr>
+        <p:spPr>
+          <a:xfrm>
+            <a:off x="4297680" y="1188720"/>
+            <a:ext cx="310896" cy="310896"/>
+          </a:xfrm>
+          <a:prstGeom prst="ellipse">
+            <a:avLst/>
+          </a:prstGeom>
+          <a:solidFill>
+            <a:srgbClr val="1428A0"/>
+          </a:solidFill>
+          <a:ln/>
+        </p:spPr>
+        <p:txBody>
+          <a:bodyPr wrap="square" lIns="0" tIns="0" rIns="0" bIns="0" rtlCol="0" anchor="ctr"/>
+          <a:lstStyle/>
+          <a:p>
+            <a:pPr algn="ctr" indent="0" marL="0">
+              <a:buNone/>
+            </a:pPr>
+            <a:r>
+              <a:rPr lang="en-US" sz="1400" b="1" dirty="0">
+                <a:solidFill>
+                  <a:srgbClr val="FFFFFF"/>
+                </a:solidFill>
+                <a:latin typeface="Malgun Gothic" pitchFamily="34" charset="0"/>
+                <a:ea typeface="Malgun Gothic" pitchFamily="34" charset="-122"/>
+                <a:cs typeface="Malgun Gothic" pitchFamily="34" charset="-120"/>
+              </a:rPr>
+              <a:t>2</a:t>
+            </a:r>
+            <a:endParaRPr lang="en-US" sz="1400" dirty="0"/>
+          </a:p>
+        </p:txBody>
+      </p:sp>
+      <p:sp>
+        <p:nvSpPr>
+          <p:cNvPr id="11" name="Text 9"/>
+          <p:cNvSpPr/>
+          <p:nvPr/>
+        </p:nvSpPr>
+        <p:spPr>
+          <a:xfrm>
+            <a:off x="4700016" y="1170432"/>
+            <a:ext cx="3200400" cy="347472"/>
+          </a:xfrm>
+          <a:prstGeom prst="rect">
+            <a:avLst/>
+          </a:prstGeom>
+          <a:noFill/>
+          <a:ln/>
+        </p:spPr>
+        <p:txBody>
+          <a:bodyPr wrap="square" lIns="0" tIns="0" rIns="0" bIns="0" rtlCol="0" anchor="ctr"/>
+          <a:lstStyle/>
+          <a:p>
+            <a:pPr indent="0" marL="0">
+              <a:buNone/>
+            </a:pPr>
+            <a:r>
+              <a:rPr lang="en-US" sz="1400" b="1" dirty="0">
+                <a:solidFill>
+                  <a:srgbClr val="1A1A1A"/>
+                </a:solidFill>
+                <a:latin typeface="Malgun Gothic" pitchFamily="34" charset="0"/>
+                <a:ea typeface="Malgun Gothic" pitchFamily="34" charset="-122"/>
+                <a:cs typeface="Malgun Gothic" pitchFamily="34" charset="-120"/>
+              </a:rPr>
+              <a:t>SCA: Micron이 증명한 접근</a:t>
+            </a:r>
+            <a:endParaRPr lang="en-US" sz="1400" dirty="0"/>
+          </a:p>
+        </p:txBody>
+      </p:sp>
+      <p:sp>
+        <p:nvSpPr>
+          <p:cNvPr id="12" name="Shape 10"/>
+          <p:cNvSpPr/>
+          <p:nvPr/>
+        </p:nvSpPr>
+        <p:spPr>
+          <a:xfrm>
+            <a:off x="4297680" y="1627632"/>
+            <a:ext cx="3602736" cy="4626864"/>
+          </a:xfrm>
+          <a:prstGeom prst="roundRect">
+            <a:avLst>
+              <a:gd name="adj" fmla="val 2030"/>
+            </a:avLst>
+          </a:prstGeom>
+          <a:solidFill>
+            <a:srgbClr val="FFFFFF"/>
+          </a:solidFill>
+          <a:ln w="12700">
+            <a:solidFill>
+              <a:srgbClr val="D9D9D9"/>
+            </a:solidFill>
+            <a:prstDash val="solid"/>
+          </a:ln>
+        </p:spPr>
+      </p:sp>
+      <p:sp>
+        <p:nvSpPr>
+          <p:cNvPr id="13" name="Text 11"/>
+          <p:cNvSpPr/>
+          <p:nvPr/>
+        </p:nvSpPr>
+        <p:spPr>
+          <a:xfrm>
+            <a:off x="8129016" y="1188720"/>
+            <a:ext cx="310896" cy="310896"/>
+          </a:xfrm>
+          <a:prstGeom prst="ellipse">
+            <a:avLst/>
+          </a:prstGeom>
+          <a:solidFill>
+            <a:srgbClr val="1428A0"/>
+          </a:solidFill>
+          <a:ln/>
+        </p:spPr>
+        <p:txBody>
+          <a:bodyPr wrap="square" lIns="0" tIns="0" rIns="0" bIns="0" rtlCol="0" anchor="ctr"/>
+          <a:lstStyle/>
+          <a:p>
+            <a:pPr algn="ctr" indent="0" marL="0">
+              <a:buNone/>
+            </a:pPr>
+            <a:r>
+              <a:rPr lang="en-US" sz="1400" b="1" dirty="0">
+                <a:solidFill>
+                  <a:srgbClr val="FFFFFF"/>
+                </a:solidFill>
+                <a:latin typeface="Malgun Gothic" pitchFamily="34" charset="0"/>
+                <a:ea typeface="Malgun Gothic" pitchFamily="34" charset="-122"/>
+                <a:cs typeface="Malgun Gothic" pitchFamily="34" charset="-120"/>
+              </a:rPr>
+              <a:t>3</a:t>
+            </a:r>
+            <a:endParaRPr lang="en-US" sz="1400" dirty="0"/>
+          </a:p>
+        </p:txBody>
+      </p:sp>
+      <p:sp>
+        <p:nvSpPr>
+          <p:cNvPr id="14" name="Text 12"/>
+          <p:cNvSpPr/>
+          <p:nvPr/>
+        </p:nvSpPr>
+        <p:spPr>
+          <a:xfrm>
+            <a:off x="8531352" y="1170432"/>
+            <a:ext cx="3200400" cy="347472"/>
+          </a:xfrm>
+          <a:prstGeom prst="rect">
+            <a:avLst/>
+          </a:prstGeom>
+          <a:noFill/>
+          <a:ln/>
+        </p:spPr>
+        <p:txBody>
+          <a:bodyPr wrap="square" lIns="0" tIns="0" rIns="0" bIns="0" rtlCol="0" anchor="ctr"/>
+          <a:lstStyle/>
+          <a:p>
+            <a:pPr indent="0" marL="0">
+              <a:buNone/>
+            </a:pPr>
+            <a:r>
+              <a:rPr lang="en-US" sz="1400" b="1" dirty="0">
+                <a:solidFill>
+                  <a:srgbClr val="1A1A1A"/>
+                </a:solidFill>
+                <a:latin typeface="Malgun Gothic" pitchFamily="34" charset="0"/>
+                <a:ea typeface="Malgun Gothic" pitchFamily="34" charset="-122"/>
+                <a:cs typeface="Malgun Gothic" pitchFamily="34" charset="-120"/>
+              </a:rPr>
+              <a:t>FDP·FDE: 기술과 사람</a:t>
+            </a:r>
+            <a:endParaRPr lang="en-US" sz="1400" dirty="0"/>
+          </a:p>
+        </p:txBody>
+      </p:sp>
+      <p:sp>
+        <p:nvSpPr>
+          <p:cNvPr id="15" name="Shape 13"/>
+          <p:cNvSpPr/>
+          <p:nvPr/>
+        </p:nvSpPr>
+        <p:spPr>
+          <a:xfrm>
+            <a:off x="8129016" y="1627632"/>
+            <a:ext cx="3602736" cy="4626864"/>
+          </a:xfrm>
+          <a:prstGeom prst="roundRect">
+            <a:avLst>
+              <a:gd name="adj" fmla="val 2030"/>
+            </a:avLst>
+          </a:prstGeom>
+          <a:solidFill>
+            <a:srgbClr val="FFFFFF"/>
+          </a:solidFill>
+          <a:ln w="12700">
+            <a:solidFill>
+              <a:srgbClr val="D9D9D9"/>
+            </a:solidFill>
+            <a:prstDash val="solid"/>
+          </a:ln>
+        </p:spPr>
+      </p:sp>
+      <p:sp>
+        <p:nvSpPr>
+          <p:cNvPr id="16" name="Text 14"/>
+          <p:cNvSpPr/>
+          <p:nvPr/>
+        </p:nvSpPr>
+        <p:spPr>
+          <a:xfrm>
+            <a:off x="1828800" y="1828800"/>
+            <a:ext cx="877824" cy="877824"/>
+          </a:xfrm>
+          <a:prstGeom prst="ellipse">
+            <a:avLst/>
+          </a:prstGeom>
+          <a:solidFill>
+            <a:srgbClr val="1428A0"/>
           </a:solidFill>
           <a:ln/>
         </p:spPr>
@@ -1111,7 +1432,7 @@
               <a:buNone/>
             </a:pPr>
             <a:r>
-              <a:rPr lang="en-US" sz="1600" b="1" dirty="0">
+              <a:rPr lang="en-US" sz="1450" b="1" dirty="0">
                 <a:solidFill>
                   <a:srgbClr val="FFFFFF"/>
                 </a:solidFill>
@@ -1121,7 +1442,7 @@
               </a:rPr>
               <a:t>SCA</a:t>
             </a:r>
-            <a:endParaRPr lang="en-US" sz="1600" dirty="0"/>
+            <a:endParaRPr lang="en-US" sz="1450" dirty="0"/>
           </a:p>
           <a:p>
             <a:pPr algn="ctr" indent="0" marL="0">
@@ -1131,7 +1452,7 @@
               <a:buNone/>
             </a:pPr>
             <a:r>
-              <a:rPr lang="en-US" sz="1050" dirty="0">
+              <a:rPr lang="en-US" sz="950" dirty="0">
                 <a:solidFill>
                   <a:srgbClr val="FFFFFF"/>
                 </a:solidFill>
@@ -1141,26 +1462,26 @@
               </a:rPr>
               <a:t>다가간다</a:t>
             </a:r>
-            <a:endParaRPr lang="en-US" sz="1600" dirty="0"/>
-          </a:p>
-        </p:txBody>
-      </p:sp>
-      <p:sp>
-        <p:nvSpPr>
-          <p:cNvPr id="8" name="Text 6"/>
-          <p:cNvSpPr/>
-          <p:nvPr/>
-        </p:nvSpPr>
-        <p:spPr>
-          <a:xfrm>
-            <a:off x="658368" y="3346704"/>
-            <a:ext cx="1024128" cy="1024128"/>
+            <a:endParaRPr lang="en-US" sz="1450" dirty="0"/>
+          </a:p>
+        </p:txBody>
+      </p:sp>
+      <p:sp>
+        <p:nvSpPr>
+          <p:cNvPr id="17" name="Text 15"/>
+          <p:cNvSpPr/>
+          <p:nvPr/>
+        </p:nvSpPr>
+        <p:spPr>
+          <a:xfrm>
+            <a:off x="859536" y="3456432"/>
+            <a:ext cx="877824" cy="877824"/>
           </a:xfrm>
           <a:prstGeom prst="ellipse">
             <a:avLst/>
           </a:prstGeom>
           <a:solidFill>
-            <a:srgbClr val="028090"/>
+            <a:srgbClr val="3C5AC8"/>
           </a:solidFill>
           <a:ln/>
         </p:spPr>
@@ -1175,7 +1496,7 @@
               <a:buNone/>
             </a:pPr>
             <a:r>
-              <a:rPr lang="en-US" sz="1600" b="1" dirty="0">
+              <a:rPr lang="en-US" sz="1450" b="1" dirty="0">
                 <a:solidFill>
                   <a:srgbClr val="FFFFFF"/>
                 </a:solidFill>
@@ -1185,7 +1506,7 @@
               </a:rPr>
               <a:t>FDP</a:t>
             </a:r>
-            <a:endParaRPr lang="en-US" sz="1600" dirty="0"/>
+            <a:endParaRPr lang="en-US" sz="1450" dirty="0"/>
           </a:p>
           <a:p>
             <a:pPr algn="ctr" indent="0" marL="0">
@@ -1195,7 +1516,7 @@
               <a:buNone/>
             </a:pPr>
             <a:r>
-              <a:rPr lang="en-US" sz="1050" dirty="0">
+              <a:rPr lang="en-US" sz="950" dirty="0">
                 <a:solidFill>
                   <a:srgbClr val="FFFFFF"/>
                 </a:solidFill>
@@ -1205,26 +1526,26 @@
               </a:rPr>
               <a:t>제공한다</a:t>
             </a:r>
-            <a:endParaRPr lang="en-US" sz="1600" dirty="0"/>
-          </a:p>
-        </p:txBody>
-      </p:sp>
-      <p:sp>
-        <p:nvSpPr>
-          <p:cNvPr id="9" name="Text 7"/>
-          <p:cNvSpPr/>
-          <p:nvPr/>
-        </p:nvSpPr>
-        <p:spPr>
-          <a:xfrm>
-            <a:off x="2852928" y="3346704"/>
-            <a:ext cx="1024128" cy="1024128"/>
+            <a:endParaRPr lang="en-US" sz="1450" dirty="0"/>
+          </a:p>
+        </p:txBody>
+      </p:sp>
+      <p:sp>
+        <p:nvSpPr>
+          <p:cNvPr id="18" name="Text 16"/>
+          <p:cNvSpPr/>
+          <p:nvPr/>
+        </p:nvSpPr>
+        <p:spPr>
+          <a:xfrm>
+            <a:off x="2798064" y="3456432"/>
+            <a:ext cx="877824" cy="877824"/>
           </a:xfrm>
           <a:prstGeom prst="ellipse">
             <a:avLst/>
           </a:prstGeom>
           <a:solidFill>
-            <a:srgbClr val="02A878"/>
+            <a:srgbClr val="8FA0DC"/>
           </a:solidFill>
           <a:ln/>
         </p:spPr>
@@ -1239,7 +1560,7 @@
               <a:buNone/>
             </a:pPr>
             <a:r>
-              <a:rPr lang="en-US" sz="1600" b="1" dirty="0">
+              <a:rPr lang="en-US" sz="1450" b="1" dirty="0">
                 <a:solidFill>
                   <a:srgbClr val="FFFFFF"/>
                 </a:solidFill>
@@ -1249,7 +1570,7 @@
               </a:rPr>
               <a:t>FDE</a:t>
             </a:r>
-            <a:endParaRPr lang="en-US" sz="1600" dirty="0"/>
+            <a:endParaRPr lang="en-US" sz="1450" dirty="0"/>
           </a:p>
           <a:p>
             <a:pPr algn="ctr" indent="0" marL="0">
@@ -1259,7 +1580,7 @@
               <a:buNone/>
             </a:pPr>
             <a:r>
-              <a:rPr lang="en-US" sz="1050" dirty="0">
+              <a:rPr lang="en-US" sz="950" dirty="0">
                 <a:solidFill>
                   <a:srgbClr val="FFFFFF"/>
                 </a:solidFill>
@@ -1269,28 +1590,28 @@
               </a:rPr>
               <a:t>협업한다</a:t>
             </a:r>
-            <a:endParaRPr lang="en-US" sz="1600" dirty="0"/>
-          </a:p>
-        </p:txBody>
-      </p:sp>
-      <p:sp>
-        <p:nvSpPr>
-          <p:cNvPr id="10" name="Shape 8"/>
+            <a:endParaRPr lang="en-US" sz="1450" dirty="0"/>
+          </a:p>
+        </p:txBody>
+      </p:sp>
+      <p:sp>
+        <p:nvSpPr>
+          <p:cNvPr id="19" name="Shape 17"/>
           <p:cNvSpPr/>
           <p:nvPr/>
         </p:nvSpPr>
         <p:spPr>
           <a:xfrm flipH="1">
-            <a:off x="1170432" y="2304288"/>
-            <a:ext cx="402336" cy="1005840"/>
+            <a:off x="1371600" y="2706624"/>
+            <a:ext cx="329184" cy="713232"/>
           </a:xfrm>
           <a:prstGeom prst="line">
             <a:avLst/>
           </a:prstGeom>
           <a:noFill/>
-          <a:ln w="25400">
+          <a:ln w="22225">
             <a:solidFill>
-              <a:srgbClr val="C4CFD6"/>
+              <a:srgbClr val="B9C2DC"/>
             </a:solidFill>
             <a:prstDash val="solid"/>
             <a:tailEnd type="triangle"/>
@@ -1299,22 +1620,22 @@
       </p:sp>
       <p:sp>
         <p:nvSpPr>
-          <p:cNvPr id="11" name="Shape 9"/>
-          <p:cNvSpPr/>
-          <p:nvPr/>
-        </p:nvSpPr>
-        <p:spPr>
-          <a:xfrm>
-            <a:off x="1773936" y="3858768"/>
+          <p:cNvPr id="20" name="Shape 18"/>
+          <p:cNvSpPr/>
+          <p:nvPr/>
+        </p:nvSpPr>
+        <p:spPr>
+          <a:xfrm>
+            <a:off x="1773936" y="4059936"/>
             <a:ext cx="987552" cy="914"/>
           </a:xfrm>
           <a:prstGeom prst="line">
             <a:avLst/>
           </a:prstGeom>
           <a:noFill/>
-          <a:ln w="25400">
+          <a:ln w="22225">
             <a:solidFill>
-              <a:srgbClr val="C4CFD6"/>
+              <a:srgbClr val="B9C2DC"/>
             </a:solidFill>
             <a:prstDash val="solid"/>
             <a:tailEnd type="triangle"/>
@@ -1323,22 +1644,22 @@
       </p:sp>
       <p:sp>
         <p:nvSpPr>
-          <p:cNvPr id="12" name="Shape 10"/>
+          <p:cNvPr id="21" name="Shape 19"/>
           <p:cNvSpPr/>
           <p:nvPr/>
         </p:nvSpPr>
         <p:spPr>
           <a:xfrm flipH="1" flipV="1">
-            <a:off x="2907792" y="2286000"/>
-            <a:ext cx="457200" cy="1024128"/>
+            <a:off x="2834640" y="2706624"/>
+            <a:ext cx="384048" cy="713232"/>
           </a:xfrm>
           <a:prstGeom prst="line">
             <a:avLst/>
           </a:prstGeom>
           <a:noFill/>
-          <a:ln w="25400">
+          <a:ln w="22225">
             <a:solidFill>
-              <a:srgbClr val="C4CFD6"/>
+              <a:srgbClr val="B9C2DC"/>
             </a:solidFill>
             <a:prstDash val="solid"/>
             <a:tailEnd type="triangle"/>
@@ -1347,26 +1668,26 @@
       </p:sp>
       <p:sp>
         <p:nvSpPr>
-          <p:cNvPr id="13" name="Text 11"/>
-          <p:cNvSpPr/>
-          <p:nvPr/>
-        </p:nvSpPr>
-        <p:spPr>
-          <a:xfrm>
-            <a:off x="1554480" y="2724912"/>
-            <a:ext cx="1426464" cy="768096"/>
+          <p:cNvPr id="22" name="Text 20"/>
+          <p:cNvSpPr/>
+          <p:nvPr/>
+        </p:nvSpPr>
+        <p:spPr>
+          <a:xfrm>
+            <a:off x="1536192" y="2999232"/>
+            <a:ext cx="1463040" cy="566928"/>
           </a:xfrm>
           <a:prstGeom prst="roundRect">
             <a:avLst>
-              <a:gd name="adj" fmla="val 9524"/>
+              <a:gd name="adj" fmla="val 9677"/>
             </a:avLst>
           </a:prstGeom>
           <a:solidFill>
-            <a:srgbClr val="E8F6F0"/>
-          </a:solidFill>
-          <a:ln w="15875">
+            <a:srgbClr val="EEF1FA"/>
+          </a:solidFill>
+          <a:ln w="12700">
             <a:solidFill>
-              <a:srgbClr val="02A878"/>
+              <a:srgbClr val="1428A0"/>
             </a:solidFill>
           </a:ln>
         </p:spPr>
@@ -1376,14 +1697,14 @@
           <a:p>
             <a:pPr algn="ctr" indent="0" marL="0">
               <a:lnSpc>
-                <a:spcPct val="105000"/>
+                <a:spcPct val="100000"/>
               </a:lnSpc>
               <a:buNone/>
             </a:pPr>
             <a:r>
-              <a:rPr lang="en-US" sz="1150" b="1" dirty="0">
-                <a:solidFill>
-                  <a:srgbClr val="17313B"/>
+              <a:rPr lang="en-US" sz="1000" b="1" dirty="0">
+                <a:solidFill>
+                  <a:srgbClr val="1A1A1A"/>
                 </a:solidFill>
                 <a:latin typeface="Malgun Gothic" pitchFamily="34" charset="0"/>
                 <a:ea typeface="Malgun Gothic" pitchFamily="34" charset="-122"/>
@@ -1391,19 +1712,19 @@
               </a:rPr>
               <a:t>고객 락인</a:t>
             </a:r>
-            <a:endParaRPr lang="en-US" sz="1150" dirty="0"/>
+            <a:endParaRPr lang="en-US" sz="1000" dirty="0"/>
           </a:p>
           <a:p>
             <a:pPr algn="ctr" indent="0" marL="0">
               <a:lnSpc>
-                <a:spcPct val="105000"/>
+                <a:spcPct val="100000"/>
               </a:lnSpc>
               <a:buNone/>
             </a:pPr>
             <a:r>
-              <a:rPr lang="en-US" sz="1150" b="1" dirty="0">
-                <a:solidFill>
-                  <a:srgbClr val="17313B"/>
+              <a:rPr lang="en-US" sz="1000" b="1" dirty="0">
+                <a:solidFill>
+                  <a:srgbClr val="1A1A1A"/>
                 </a:solidFill>
                 <a:latin typeface="Malgun Gothic" pitchFamily="34" charset="0"/>
                 <a:ea typeface="Malgun Gothic" pitchFamily="34" charset="-122"/>
@@ -1411,56 +1732,230 @@
               </a:rPr>
               <a:t>다운턴 방어</a:t>
             </a:r>
-            <a:endParaRPr lang="en-US" sz="1150" dirty="0"/>
-          </a:p>
-        </p:txBody>
-      </p:sp>
-      <p:sp>
-        <p:nvSpPr>
-          <p:cNvPr id="14" name="Text 12"/>
-          <p:cNvSpPr/>
-          <p:nvPr/>
-        </p:nvSpPr>
-        <p:spPr>
-          <a:xfrm>
-            <a:off x="457200" y="4754880"/>
-            <a:ext cx="3785616" cy="1371600"/>
-          </a:xfrm>
-          <a:prstGeom prst="roundRect">
-            <a:avLst>
-              <a:gd name="adj" fmla="val 5333"/>
-            </a:avLst>
-          </a:prstGeom>
-          <a:solidFill>
-            <a:srgbClr val="F5F7F8"/>
-          </a:solidFill>
+            <a:endParaRPr lang="en-US" sz="1000" dirty="0"/>
+          </a:p>
+        </p:txBody>
+      </p:sp>
+      <p:sp>
+        <p:nvSpPr>
+          <p:cNvPr id="23" name="Text 21"/>
+          <p:cNvSpPr/>
+          <p:nvPr/>
+        </p:nvSpPr>
+        <p:spPr>
+          <a:xfrm>
+            <a:off x="658368" y="4572000"/>
+            <a:ext cx="3200400" cy="777240"/>
+          </a:xfrm>
+          <a:prstGeom prst="rect">
+            <a:avLst/>
+          </a:prstGeom>
+          <a:noFill/>
           <a:ln/>
         </p:spPr>
         <p:txBody>
-          <a:bodyPr wrap="square" lIns="1524" tIns="1524" rIns="1524" bIns="1524" rtlCol="0" anchor="ctr"/>
-          <a:lstStyle/>
-          <a:p>
-            <a:pPr algn="l" indent="0" marL="0">
+          <a:bodyPr wrap="square" lIns="0" tIns="0" rIns="0" bIns="0" rtlCol="0" anchor="t"/>
+          <a:lstStyle/>
+          <a:p>
+            <a:pPr indent="0" marL="0">
               <a:lnSpc>
                 <a:spcPct val="115000"/>
               </a:lnSpc>
               <a:buNone/>
             </a:pPr>
             <a:r>
-              <a:rPr lang="en-US" sz="1250" b="1" dirty="0">
-                <a:solidFill>
-                  <a:srgbClr val="17313B"/>
-                </a:solidFill>
-                <a:latin typeface="Malgun Gothic" pitchFamily="34" charset="0"/>
-                <a:ea typeface="Malgun Gothic" pitchFamily="34" charset="-122"/>
-                <a:cs typeface="Malgun Gothic" pitchFamily="34" charset="-120"/>
-              </a:rPr>
-              <a:t>락인 플라이휠</a:t>
-            </a:r>
-            <a:endParaRPr lang="en-US" sz="1250" dirty="0"/>
-          </a:p>
-          <a:p>
-            <a:pPr algn="l" indent="0" marL="0">
+              <a:rPr lang="en-US" sz="1050" dirty="0">
+                <a:solidFill>
+                  <a:srgbClr val="555555"/>
+                </a:solidFill>
+                <a:latin typeface="Malgun Gothic" pitchFamily="34" charset="0"/>
+                <a:ea typeface="Malgun Gothic" pitchFamily="34" charset="-122"/>
+                <a:cs typeface="Malgun Gothic" pitchFamily="34" charset="-120"/>
+              </a:rPr>
+              <a:t>워크로드가 들어올수록 최적화가 깊어지고 전환비용이 커진다. 계약이 끝나도 갈아타기 어려운 관계가 다운턴의 방어벽이 된다</a:t>
+            </a:r>
+            <a:endParaRPr lang="en-US" sz="1050" dirty="0"/>
+          </a:p>
+        </p:txBody>
+      </p:sp>
+      <p:sp>
+        <p:nvSpPr>
+          <p:cNvPr id="24" name="Shape 22"/>
+          <p:cNvSpPr/>
+          <p:nvPr/>
+        </p:nvSpPr>
+        <p:spPr>
+          <a:xfrm>
+            <a:off x="658368" y="5431536"/>
+            <a:ext cx="3200400" cy="0"/>
+          </a:xfrm>
+          <a:prstGeom prst="line">
+            <a:avLst/>
+          </a:prstGeom>
+          <a:noFill/>
+          <a:ln w="9525">
+            <a:solidFill>
+              <a:srgbClr val="D9D9D9"/>
+            </a:solidFill>
+            <a:prstDash val="solid"/>
+          </a:ln>
+        </p:spPr>
+      </p:sp>
+      <p:sp>
+        <p:nvSpPr>
+          <p:cNvPr id="25" name="Text 23"/>
+          <p:cNvSpPr/>
+          <p:nvPr/>
+        </p:nvSpPr>
+        <p:spPr>
+          <a:xfrm>
+            <a:off x="658368" y="5522976"/>
+            <a:ext cx="3246120" cy="658368"/>
+          </a:xfrm>
+          <a:prstGeom prst="rect">
+            <a:avLst/>
+          </a:prstGeom>
+          <a:noFill/>
+          <a:ln/>
+        </p:spPr>
+        <p:txBody>
+          <a:bodyPr wrap="square" lIns="0" tIns="0" rIns="0" bIns="0" rtlCol="0" anchor="t"/>
+          <a:lstStyle/>
+          <a:p>
+            <a:pPr indent="0" marL="0">
+              <a:lnSpc>
+                <a:spcPct val="125000"/>
+              </a:lnSpc>
+              <a:buNone/>
+            </a:pPr>
+            <a:r>
+              <a:rPr lang="en-US" sz="950" b="1" dirty="0">
+                <a:solidFill>
+                  <a:srgbClr val="1428A0"/>
+                </a:solidFill>
+                <a:latin typeface="Malgun Gothic" pitchFamily="34" charset="0"/>
+                <a:ea typeface="Malgun Gothic" pitchFamily="34" charset="-122"/>
+                <a:cs typeface="Malgun Gothic" pitchFamily="34" charset="-120"/>
+              </a:rPr>
+              <a:t>SCA</a:t>
+            </a:r>
+            <a:pPr indent="0" marL="0">
+              <a:lnSpc>
+                <a:spcPct val="125000"/>
+              </a:lnSpc>
+              <a:buNone/>
+            </a:pPr>
+            <a:r>
+              <a:rPr lang="en-US" sz="950" dirty="0">
+                <a:solidFill>
+                  <a:srgbClr val="555555"/>
+                </a:solidFill>
+                <a:latin typeface="Malgun Gothic" pitchFamily="34" charset="0"/>
+                <a:ea typeface="Malgun Gothic" pitchFamily="34" charset="-122"/>
+                <a:cs typeface="Malgun Gothic" pitchFamily="34" charset="-120"/>
+              </a:rPr>
+              <a:t> Strategic Customer Agreement · 전략적 고객 계약</a:t>
+            </a:r>
+            <a:endParaRPr lang="en-US" sz="950" dirty="0"/>
+          </a:p>
+          <a:p>
+            <a:pPr indent="0" marL="0">
+              <a:lnSpc>
+                <a:spcPct val="125000"/>
+              </a:lnSpc>
+              <a:buNone/>
+            </a:pPr>
+            <a:r>
+              <a:rPr lang="en-US" sz="950" b="1" dirty="0">
+                <a:solidFill>
+                  <a:srgbClr val="1428A0"/>
+                </a:solidFill>
+                <a:latin typeface="Malgun Gothic" pitchFamily="34" charset="0"/>
+                <a:ea typeface="Malgun Gothic" pitchFamily="34" charset="-122"/>
+                <a:cs typeface="Malgun Gothic" pitchFamily="34" charset="-120"/>
+              </a:rPr>
+              <a:t>FDP</a:t>
+            </a:r>
+            <a:pPr indent="0" marL="0">
+              <a:lnSpc>
+                <a:spcPct val="125000"/>
+              </a:lnSpc>
+              <a:buNone/>
+            </a:pPr>
+            <a:r>
+              <a:rPr lang="en-US" sz="950" dirty="0">
+                <a:solidFill>
+                  <a:srgbClr val="555555"/>
+                </a:solidFill>
+                <a:latin typeface="Malgun Gothic" pitchFamily="34" charset="0"/>
+                <a:ea typeface="Malgun Gothic" pitchFamily="34" charset="-122"/>
+                <a:cs typeface="Malgun Gothic" pitchFamily="34" charset="-120"/>
+              </a:rPr>
+              <a:t> Flexible Data Placement · NVMe 데이터 배치 표준</a:t>
+            </a:r>
+            <a:endParaRPr lang="en-US" sz="950" dirty="0"/>
+          </a:p>
+          <a:p>
+            <a:pPr indent="0" marL="0">
+              <a:lnSpc>
+                <a:spcPct val="125000"/>
+              </a:lnSpc>
+              <a:buNone/>
+            </a:pPr>
+            <a:r>
+              <a:rPr lang="en-US" sz="950" b="1" dirty="0">
+                <a:solidFill>
+                  <a:srgbClr val="1428A0"/>
+                </a:solidFill>
+                <a:latin typeface="Malgun Gothic" pitchFamily="34" charset="0"/>
+                <a:ea typeface="Malgun Gothic" pitchFamily="34" charset="-122"/>
+                <a:cs typeface="Malgun Gothic" pitchFamily="34" charset="-120"/>
+              </a:rPr>
+              <a:t>FDE</a:t>
+            </a:r>
+            <a:pPr indent="0" marL="0">
+              <a:lnSpc>
+                <a:spcPct val="125000"/>
+              </a:lnSpc>
+              <a:buNone/>
+            </a:pPr>
+            <a:r>
+              <a:rPr lang="en-US" sz="950" dirty="0">
+                <a:solidFill>
+                  <a:srgbClr val="555555"/>
+                </a:solidFill>
+                <a:latin typeface="Malgun Gothic" pitchFamily="34" charset="0"/>
+                <a:ea typeface="Malgun Gothic" pitchFamily="34" charset="-122"/>
+                <a:cs typeface="Malgun Gothic" pitchFamily="34" charset="-120"/>
+              </a:rPr>
+              <a:t> Forward Deployed Engineer · 고객 상주 엔지니어</a:t>
+            </a:r>
+            <a:endParaRPr lang="en-US" sz="950" dirty="0"/>
+          </a:p>
+        </p:txBody>
+      </p:sp>
+      <p:sp>
+        <p:nvSpPr>
+          <p:cNvPr id="26" name="Text 24"/>
+          <p:cNvSpPr/>
+          <p:nvPr/>
+        </p:nvSpPr>
+        <p:spPr>
+          <a:xfrm>
+            <a:off x="4498848" y="1792224"/>
+            <a:ext cx="3200400" cy="1097280"/>
+          </a:xfrm>
+          <a:prstGeom prst="rect">
+            <a:avLst/>
+          </a:prstGeom>
+          <a:noFill/>
+          <a:ln/>
+        </p:spPr>
+        <p:txBody>
+          <a:bodyPr wrap="square" lIns="0" tIns="0" rIns="0" bIns="0" rtlCol="0" anchor="t"/>
+          <a:lstStyle/>
+          <a:p>
+            <a:pPr indent="0" marL="0">
               <a:lnSpc>
                 <a:spcPct val="115000"/>
               </a:lnSpc>
@@ -1469,135 +1964,94 @@
             <a:r>
               <a:rPr lang="en-US" sz="1050" dirty="0">
                 <a:solidFill>
-                  <a:srgbClr val="5A7184"/>
-                </a:solidFill>
-                <a:latin typeface="Malgun Gothic" pitchFamily="34" charset="0"/>
-                <a:ea typeface="Malgun Gothic" pitchFamily="34" charset="-122"/>
-                <a:cs typeface="Malgun Gothic" pitchFamily="34" charset="-120"/>
-              </a:rPr>
-              <a:t>워크로드 유입 → 최적화 심화 → 전환비용 증가. 계약이 끝나도 갈아타기 어려운 관계가 다운턴의 방어벽이 된다</a:t>
-            </a:r>
-            <a:endParaRPr lang="en-US" sz="1250" dirty="0"/>
-          </a:p>
-        </p:txBody>
-      </p:sp>
-      <p:sp>
-        <p:nvSpPr>
-          <p:cNvPr id="15" name="Shape 13"/>
-          <p:cNvSpPr/>
-          <p:nvPr/>
-        </p:nvSpPr>
-        <p:spPr>
-          <a:xfrm>
-            <a:off x="4434840" y="1207008"/>
-            <a:ext cx="7296912" cy="1645920"/>
+                  <a:srgbClr val="1A1A1A"/>
+                </a:solidFill>
+                <a:latin typeface="Malgun Gothic" pitchFamily="34" charset="0"/>
+                <a:ea typeface="Malgun Gothic" pitchFamily="34" charset="-122"/>
+                <a:cs typeface="Malgun Gothic" pitchFamily="34" charset="-120"/>
+              </a:rPr>
+              <a:t>공급부족 협상력의 창이 열려 있을 때 워크로드 교환을 제안한다: 고객이 워크로드를 공유하면 그 워크로드에 최적화한 FDP SSD를 공급. 성능·수명 개선과 TCO 절감으로 거절하기 어려운 딜</a:t>
+            </a:r>
+            <a:endParaRPr lang="en-US" sz="1050" dirty="0"/>
+          </a:p>
+        </p:txBody>
+      </p:sp>
+      <p:sp>
+        <p:nvSpPr>
+          <p:cNvPr id="27" name="Text 25"/>
+          <p:cNvSpPr/>
+          <p:nvPr/>
+        </p:nvSpPr>
+        <p:spPr>
+          <a:xfrm>
+            <a:off x="4498848" y="2926080"/>
+            <a:ext cx="3200400" cy="274320"/>
+          </a:xfrm>
+          <a:prstGeom prst="rect">
+            <a:avLst/>
+          </a:prstGeom>
+          <a:noFill/>
+          <a:ln/>
+        </p:spPr>
+        <p:txBody>
+          <a:bodyPr wrap="square" lIns="0" tIns="0" rIns="0" bIns="0" rtlCol="0" anchor="ctr"/>
+          <a:lstStyle/>
+          <a:p>
+            <a:pPr indent="0" marL="0">
+              <a:buNone/>
+            </a:pPr>
+            <a:r>
+              <a:rPr lang="en-US" sz="950" dirty="0">
+                <a:solidFill>
+                  <a:srgbClr val="555555"/>
+                </a:solidFill>
+                <a:latin typeface="Malgun Gothic" pitchFamily="34" charset="0"/>
+                <a:ea typeface="Malgun Gothic" pitchFamily="34" charset="-122"/>
+                <a:cs typeface="Malgun Gothic" pitchFamily="34" charset="-120"/>
+              </a:rPr>
+              <a:t>대상: 하이퍼스케일러 · Pure Storage · VAST Data · DDN</a:t>
+            </a:r>
+            <a:endParaRPr lang="en-US" sz="950" dirty="0"/>
+          </a:p>
+        </p:txBody>
+      </p:sp>
+      <p:sp>
+        <p:nvSpPr>
+          <p:cNvPr id="28" name="Shape 26"/>
+          <p:cNvSpPr/>
+          <p:nvPr/>
+        </p:nvSpPr>
+        <p:spPr>
+          <a:xfrm>
+            <a:off x="4480560" y="3291840"/>
+            <a:ext cx="3236976" cy="2798064"/>
           </a:xfrm>
           <a:prstGeom prst="roundRect">
             <a:avLst>
-              <a:gd name="adj" fmla="val 5000"/>
+              <a:gd name="adj" fmla="val 2288"/>
             </a:avLst>
           </a:prstGeom>
           <a:solidFill>
-            <a:srgbClr val="F5F7F8"/>
-          </a:solidFill>
-          <a:ln/>
-        </p:spPr>
-      </p:sp>
-      <p:sp>
-        <p:nvSpPr>
-          <p:cNvPr id="16" name="Text 14"/>
-          <p:cNvSpPr/>
-          <p:nvPr/>
-        </p:nvSpPr>
-        <p:spPr>
-          <a:xfrm>
-            <a:off x="4599432" y="1353312"/>
-            <a:ext cx="329184" cy="329184"/>
-          </a:xfrm>
-          <a:prstGeom prst="ellipse">
-            <a:avLst/>
-          </a:prstGeom>
-          <a:solidFill>
-            <a:srgbClr val="17313B"/>
-          </a:solidFill>
-          <a:ln/>
-        </p:spPr>
-        <p:txBody>
-          <a:bodyPr wrap="square" lIns="0" tIns="0" rIns="0" bIns="0" rtlCol="0" anchor="ctr"/>
-          <a:lstStyle/>
-          <a:p>
-            <a:pPr algn="ctr" indent="0" marL="0">
-              <a:buNone/>
-            </a:pPr>
-            <a:r>
-              <a:rPr lang="en-US" sz="1500" b="1" dirty="0">
-                <a:solidFill>
-                  <a:srgbClr val="FFFFFF"/>
-                </a:solidFill>
-                <a:latin typeface="Malgun Gothic" pitchFamily="34" charset="0"/>
-                <a:ea typeface="Malgun Gothic" pitchFamily="34" charset="-122"/>
-                <a:cs typeface="Malgun Gothic" pitchFamily="34" charset="-120"/>
-              </a:rPr>
-              <a:t>1</a:t>
-            </a:r>
-            <a:endParaRPr lang="en-US" sz="1500" dirty="0"/>
-          </a:p>
-        </p:txBody>
-      </p:sp>
-      <p:sp>
-        <p:nvSpPr>
-          <p:cNvPr id="17" name="Shape 15"/>
-          <p:cNvSpPr/>
-          <p:nvPr/>
-        </p:nvSpPr>
-        <p:spPr>
-          <a:xfrm>
-            <a:off x="5020056" y="1325880"/>
-            <a:ext cx="384048" cy="384048"/>
-          </a:xfrm>
-          <a:prstGeom prst="ellipse">
-            <a:avLst/>
-          </a:prstGeom>
-          <a:solidFill>
-            <a:srgbClr val="028090"/>
-          </a:solidFill>
-          <a:ln/>
-        </p:spPr>
-      </p:sp>
-      <p:pic>
-        <p:nvPicPr>
-          <p:cNvPr id="18" name="Image 0" descr="preencoded.png">    </p:cNvPr>
-          <p:cNvPicPr>
-            <a:picLocks noChangeAspect="1"/>
-          </p:cNvPicPr>
-          <p:nvPr/>
-        </p:nvPicPr>
-        <p:blipFill>
-          <a:blip r:embed="rId1"/>
-          <a:stretch>
-            <a:fillRect/>
-          </a:stretch>
-        </p:blipFill>
-        <p:spPr>
-          <a:xfrm>
-            <a:off x="5112228" y="1418052"/>
-            <a:ext cx="199705" cy="199705"/>
-          </a:xfrm>
-          <a:prstGeom prst="rect">
-            <a:avLst/>
-          </a:prstGeom>
-        </p:spPr>
-      </p:pic>
-      <p:sp>
-        <p:nvSpPr>
-          <p:cNvPr id="19" name="Text 16"/>
-          <p:cNvSpPr/>
-          <p:nvPr/>
-        </p:nvSpPr>
-        <p:spPr>
-          <a:xfrm>
-            <a:off x="5532120" y="1335024"/>
-            <a:ext cx="6035040" cy="365760"/>
+            <a:srgbClr val="EEF1FA"/>
+          </a:solidFill>
+          <a:ln w="15875">
+            <a:solidFill>
+              <a:srgbClr val="1428A0"/>
+            </a:solidFill>
+            <a:prstDash val="solid"/>
+          </a:ln>
+        </p:spPr>
+      </p:sp>
+      <p:sp>
+        <p:nvSpPr>
+          <p:cNvPr id="29" name="Text 27"/>
+          <p:cNvSpPr/>
+          <p:nvPr/>
+        </p:nvSpPr>
+        <p:spPr>
+          <a:xfrm>
+            <a:off x="4645152" y="3419856"/>
+            <a:ext cx="3017520" cy="274320"/>
           </a:xfrm>
           <a:prstGeom prst="rect">
             <a:avLst/>
@@ -1613,30 +2067,30 @@
               <a:buNone/>
             </a:pPr>
             <a:r>
-              <a:rPr lang="en-US" sz="1400" b="1" dirty="0">
-                <a:solidFill>
-                  <a:srgbClr val="17313B"/>
-                </a:solidFill>
-                <a:latin typeface="Malgun Gothic" pitchFamily="34" charset="0"/>
-                <a:ea typeface="Malgun Gothic" pitchFamily="34" charset="-122"/>
-                <a:cs typeface="Malgun Gothic" pitchFamily="34" charset="-120"/>
-              </a:rPr>
-              <a:t>협상력의 창이 열려 있을 때 워크로드 교환을 제안한다</a:t>
-            </a:r>
-            <a:endParaRPr lang="en-US" sz="1400" dirty="0"/>
-          </a:p>
-        </p:txBody>
-      </p:sp>
-      <p:sp>
-        <p:nvSpPr>
-          <p:cNvPr id="20" name="Text 17"/>
-          <p:cNvSpPr/>
-          <p:nvPr/>
-        </p:nvSpPr>
-        <p:spPr>
-          <a:xfrm>
-            <a:off x="4645152" y="1755648"/>
-            <a:ext cx="6903720" cy="1024128"/>
+              <a:rPr lang="en-US" sz="1150" b="1" dirty="0">
+                <a:solidFill>
+                  <a:srgbClr val="1428A0"/>
+                </a:solidFill>
+                <a:latin typeface="Malgun Gothic" pitchFamily="34" charset="0"/>
+                <a:ea typeface="Malgun Gothic" pitchFamily="34" charset="-122"/>
+                <a:cs typeface="Malgun Gothic" pitchFamily="34" charset="-120"/>
+              </a:rPr>
+              <a:t>선례: Micron ↔ Anthropic (’26.06)</a:t>
+            </a:r>
+            <a:endParaRPr lang="en-US" sz="1150" dirty="0"/>
+          </a:p>
+        </p:txBody>
+      </p:sp>
+      <p:sp>
+        <p:nvSpPr>
+          <p:cNvPr id="30" name="Text 28"/>
+          <p:cNvSpPr/>
+          <p:nvPr/>
+        </p:nvSpPr>
+        <p:spPr>
+          <a:xfrm>
+            <a:off x="4700016" y="3730752"/>
+            <a:ext cx="2962656" cy="1188720"/>
           </a:xfrm>
           <a:prstGeom prst="rect">
             <a:avLst/>
@@ -1659,17 +2113,17 @@
               <a:buChar char="•"/>
             </a:pPr>
             <a:r>
-              <a:rPr lang="en-US" sz="1050" dirty="0">
-                <a:solidFill>
-                  <a:srgbClr val="17313B"/>
-                </a:solidFill>
-                <a:latin typeface="Malgun Gothic" pitchFamily="34" charset="0"/>
-                <a:ea typeface="Malgun Gothic" pitchFamily="34" charset="-122"/>
-                <a:cs typeface="Malgun Gothic" pitchFamily="34" charset="-120"/>
-              </a:rPr>
-              <a:t>대상: 하이퍼스케일러 + 스토리지 박스 업체(Pure Storage·VAST Data·DDN)</a:t>
-            </a:r>
-            <a:endParaRPr lang="en-US" sz="1050" dirty="0"/>
+              <a:rPr lang="en-US" sz="1000" dirty="0">
+                <a:solidFill>
+                  <a:srgbClr val="1A1A1A"/>
+                </a:solidFill>
+                <a:latin typeface="Malgun Gothic" pitchFamily="34" charset="0"/>
+                <a:ea typeface="Malgun Gothic" pitchFamily="34" charset="-122"/>
+                <a:cs typeface="Malgun Gothic" pitchFamily="34" charset="-120"/>
+              </a:rPr>
+              <a:t>다년 공급 (HBM·DRAM·SSD 전 포트폴리오)</a:t>
+            </a:r>
+            <a:endParaRPr lang="en-US" sz="1000" dirty="0"/>
           </a:p>
           <a:p>
             <a:pPr marL="342900" indent="-342900">
@@ -1683,17 +2137,17 @@
               <a:buChar char="•"/>
             </a:pPr>
             <a:r>
-              <a:rPr lang="en-US" sz="1050" dirty="0">
-                <a:solidFill>
-                  <a:srgbClr val="17313B"/>
-                </a:solidFill>
-                <a:latin typeface="Malgun Gothic" pitchFamily="34" charset="0"/>
-                <a:ea typeface="Malgun Gothic" pitchFamily="34" charset="-122"/>
-                <a:cs typeface="Malgun Gothic" pitchFamily="34" charset="-120"/>
-              </a:rPr>
-              <a:t>딜 구조: 고객 워크로드 공유 ↔ 그 워크로드에 최적화한 FDP SSD 공급</a:t>
-            </a:r>
-            <a:endParaRPr lang="en-US" sz="1050" dirty="0"/>
+              <a:rPr lang="en-US" sz="1000" dirty="0">
+                <a:solidFill>
+                  <a:srgbClr val="1A1A1A"/>
+                </a:solidFill>
+                <a:latin typeface="Malgun Gothic" pitchFamily="34" charset="0"/>
+                <a:ea typeface="Malgun Gothic" pitchFamily="34" charset="-122"/>
+                <a:cs typeface="Malgun Gothic" pitchFamily="34" charset="-120"/>
+              </a:rPr>
+              <a:t>Claude 워크로드 공동 최적화</a:t>
+            </a:r>
+            <a:endParaRPr lang="en-US" sz="1000" dirty="0"/>
           </a:p>
           <a:p>
             <a:pPr marL="342900" indent="-342900">
@@ -1707,186 +2161,18 @@
               <a:buChar char="•"/>
             </a:pPr>
             <a:r>
-              <a:rPr lang="en-US" sz="1050" dirty="0">
-                <a:solidFill>
-                  <a:srgbClr val="17313B"/>
-                </a:solidFill>
-                <a:latin typeface="Malgun Gothic" pitchFamily="34" charset="0"/>
-                <a:ea typeface="Malgun Gothic" pitchFamily="34" charset="-122"/>
-                <a:cs typeface="Malgun Gothic" pitchFamily="34" charset="-120"/>
-              </a:rPr>
-              <a:t>고객 효익: 성능·수명 개선과 TCO 절감으로 거절하기 어려운 제안 (공급부족 국면 한정의 창)</a:t>
-            </a:r>
-            <a:endParaRPr lang="en-US" sz="1050" dirty="0"/>
-          </a:p>
-        </p:txBody>
-      </p:sp>
-      <p:sp>
-        <p:nvSpPr>
-          <p:cNvPr id="21" name="Shape 18"/>
-          <p:cNvSpPr/>
-          <p:nvPr/>
-        </p:nvSpPr>
-        <p:spPr>
-          <a:xfrm>
-            <a:off x="4434840" y="2980944"/>
-            <a:ext cx="7296912" cy="1645920"/>
-          </a:xfrm>
-          <a:prstGeom prst="roundRect">
-            <a:avLst>
-              <a:gd name="adj" fmla="val 5000"/>
-            </a:avLst>
-          </a:prstGeom>
-          <a:solidFill>
-            <a:srgbClr val="F5F7F8"/>
-          </a:solidFill>
-          <a:ln/>
-        </p:spPr>
-      </p:sp>
-      <p:sp>
-        <p:nvSpPr>
-          <p:cNvPr id="22" name="Text 19"/>
-          <p:cNvSpPr/>
-          <p:nvPr/>
-        </p:nvSpPr>
-        <p:spPr>
-          <a:xfrm>
-            <a:off x="4599432" y="3127248"/>
-            <a:ext cx="329184" cy="329184"/>
-          </a:xfrm>
-          <a:prstGeom prst="ellipse">
-            <a:avLst/>
-          </a:prstGeom>
-          <a:solidFill>
-            <a:srgbClr val="17313B"/>
-          </a:solidFill>
-          <a:ln/>
-        </p:spPr>
-        <p:txBody>
-          <a:bodyPr wrap="square" lIns="0" tIns="0" rIns="0" bIns="0" rtlCol="0" anchor="ctr"/>
-          <a:lstStyle/>
-          <a:p>
-            <a:pPr algn="ctr" indent="0" marL="0">
-              <a:buNone/>
-            </a:pPr>
-            <a:r>
-              <a:rPr lang="en-US" sz="1500" b="1" dirty="0">
-                <a:solidFill>
-                  <a:srgbClr val="FFFFFF"/>
-                </a:solidFill>
-                <a:latin typeface="Malgun Gothic" pitchFamily="34" charset="0"/>
-                <a:ea typeface="Malgun Gothic" pitchFamily="34" charset="-122"/>
-                <a:cs typeface="Malgun Gothic" pitchFamily="34" charset="-120"/>
-              </a:rPr>
-              <a:t>2</a:t>
-            </a:r>
-            <a:endParaRPr lang="en-US" sz="1500" dirty="0"/>
-          </a:p>
-        </p:txBody>
-      </p:sp>
-      <p:sp>
-        <p:nvSpPr>
-          <p:cNvPr id="23" name="Shape 20"/>
-          <p:cNvSpPr/>
-          <p:nvPr/>
-        </p:nvSpPr>
-        <p:spPr>
-          <a:xfrm>
-            <a:off x="5020056" y="3099816"/>
-            <a:ext cx="384048" cy="384048"/>
-          </a:xfrm>
-          <a:prstGeom prst="ellipse">
-            <a:avLst/>
-          </a:prstGeom>
-          <a:solidFill>
-            <a:srgbClr val="4C7C94"/>
-          </a:solidFill>
-          <a:ln/>
-        </p:spPr>
-      </p:sp>
-      <p:pic>
-        <p:nvPicPr>
-          <p:cNvPr id="24" name="Image 1" descr="preencoded.png">    </p:cNvPr>
-          <p:cNvPicPr>
-            <a:picLocks noChangeAspect="1"/>
-          </p:cNvPicPr>
-          <p:nvPr/>
-        </p:nvPicPr>
-        <p:blipFill>
-          <a:blip r:embed="rId2"/>
-          <a:stretch>
-            <a:fillRect/>
-          </a:stretch>
-        </p:blipFill>
-        <p:spPr>
-          <a:xfrm>
-            <a:off x="5112228" y="3191988"/>
-            <a:ext cx="199705" cy="199705"/>
-          </a:xfrm>
-          <a:prstGeom prst="rect">
-            <a:avLst/>
-          </a:prstGeom>
-        </p:spPr>
-      </p:pic>
-      <p:sp>
-        <p:nvSpPr>
-          <p:cNvPr id="25" name="Text 21"/>
-          <p:cNvSpPr/>
-          <p:nvPr/>
-        </p:nvSpPr>
-        <p:spPr>
-          <a:xfrm>
-            <a:off x="5532120" y="3108960"/>
-            <a:ext cx="6035040" cy="365760"/>
-          </a:xfrm>
-          <a:prstGeom prst="rect">
-            <a:avLst/>
-          </a:prstGeom>
-          <a:noFill/>
-          <a:ln/>
-        </p:spPr>
-        <p:txBody>
-          <a:bodyPr wrap="square" lIns="0" tIns="0" rIns="0" bIns="0" rtlCol="0" anchor="ctr"/>
-          <a:lstStyle/>
-          <a:p>
-            <a:pPr indent="0" marL="0">
-              <a:buNone/>
-            </a:pPr>
-            <a:r>
-              <a:rPr lang="en-US" sz="1400" b="1" dirty="0">
-                <a:solidFill>
-                  <a:srgbClr val="17313B"/>
-                </a:solidFill>
-                <a:latin typeface="Malgun Gothic" pitchFamily="34" charset="0"/>
-                <a:ea typeface="Malgun Gothic" pitchFamily="34" charset="-122"/>
-                <a:cs typeface="Malgun Gothic" pitchFamily="34" charset="-120"/>
-              </a:rPr>
-              <a:t>호스트를 이해하는 최적화 개발 역량을 채용·양성으로 확보한다</a:t>
-            </a:r>
-            <a:endParaRPr lang="en-US" sz="1400" dirty="0"/>
-          </a:p>
-        </p:txBody>
-      </p:sp>
-      <p:sp>
-        <p:nvSpPr>
-          <p:cNvPr id="26" name="Text 22"/>
-          <p:cNvSpPr/>
-          <p:nvPr/>
-        </p:nvSpPr>
-        <p:spPr>
-          <a:xfrm>
-            <a:off x="4645152" y="3529584"/>
-            <a:ext cx="6903720" cy="1024128"/>
-          </a:xfrm>
-          <a:prstGeom prst="rect">
-            <a:avLst/>
-          </a:prstGeom>
-          <a:noFill/>
-          <a:ln/>
-        </p:spPr>
-        <p:txBody>
-          <a:bodyPr wrap="square" lIns="0" tIns="0" rIns="0" bIns="0" rtlCol="0" anchor="t"/>
-          <a:lstStyle/>
+              <a:rPr lang="en-US" sz="1000" dirty="0">
+                <a:solidFill>
+                  <a:srgbClr val="1A1A1A"/>
+                </a:solidFill>
+                <a:latin typeface="Malgun Gothic" pitchFamily="34" charset="0"/>
+                <a:ea typeface="Malgun Gothic" pitchFamily="34" charset="-122"/>
+                <a:cs typeface="Malgun Gothic" pitchFamily="34" charset="-120"/>
+              </a:rPr>
+              <a:t>운영 통합 (Micron 전사에 Claude 배치)</a:t>
+            </a:r>
+            <a:endParaRPr lang="en-US" sz="1000" dirty="0"/>
+          </a:p>
           <a:p>
             <a:pPr marL="342900" indent="-342900">
               <a:lnSpc>
@@ -1899,39 +2185,138 @@
               <a:buChar char="•"/>
             </a:pPr>
             <a:r>
-              <a:rPr lang="en-US" sz="1050" dirty="0">
-                <a:solidFill>
-                  <a:srgbClr val="17313B"/>
-                </a:solidFill>
-                <a:latin typeface="Malgun Gothic" pitchFamily="34" charset="0"/>
-                <a:ea typeface="Malgun Gothic" pitchFamily="34" charset="-122"/>
-                <a:cs typeface="Malgun Gothic" pitchFamily="34" charset="-120"/>
-              </a:rPr>
-              <a:t>전문가 5종: ① 커널 블록계층·io_uring·NVMe ② SPDK 유저스페이스 ③ DB·캐시 내부(RocksDB·CacheLib·Ceph) ④ 성능·워크로드 분석(fio·eBPF·WAF) ⑤ FTL·미디어 모델(사내 강점 브리지)</a:t>
+              <a:rPr lang="en-US" sz="1000" dirty="0">
+                <a:solidFill>
+                  <a:srgbClr val="1A1A1A"/>
+                </a:solidFill>
+                <a:latin typeface="Malgun Gothic" pitchFamily="34" charset="0"/>
+                <a:ea typeface="Malgun Gothic" pitchFamily="34" charset="-122"/>
+                <a:cs typeface="Malgun Gothic" pitchFamily="34" charset="-120"/>
+              </a:rPr>
+              <a:t>자본 연계 (Series H 전략 투자)</a:t>
+            </a:r>
+            <a:endParaRPr lang="en-US" sz="1000" dirty="0"/>
+          </a:p>
+        </p:txBody>
+      </p:sp>
+      <p:sp>
+        <p:nvSpPr>
+          <p:cNvPr id="31" name="Text 29"/>
+          <p:cNvSpPr/>
+          <p:nvPr/>
+        </p:nvSpPr>
+        <p:spPr>
+          <a:xfrm>
+            <a:off x="4645152" y="5029200"/>
+            <a:ext cx="2962656" cy="457200"/>
+          </a:xfrm>
+          <a:prstGeom prst="rect">
+            <a:avLst/>
+          </a:prstGeom>
+          <a:noFill/>
+          <a:ln/>
+        </p:spPr>
+        <p:txBody>
+          <a:bodyPr wrap="square" lIns="0" tIns="0" rIns="0" bIns="0" rtlCol="0" anchor="ctr"/>
+          <a:lstStyle/>
+          <a:p>
+            <a:pPr indent="0" marL="0">
+              <a:lnSpc>
+                <a:spcPct val="110000"/>
+              </a:lnSpc>
+              <a:buNone/>
+            </a:pPr>
+            <a:r>
+              <a:rPr lang="en-US" sz="1050" b="1" dirty="0">
+                <a:solidFill>
+                  <a:srgbClr val="1A1A1A"/>
+                </a:solidFill>
+                <a:latin typeface="Malgun Gothic" pitchFamily="34" charset="0"/>
+                <a:ea typeface="Malgun Gothic" pitchFamily="34" charset="-122"/>
+                <a:cs typeface="Malgun Gothic" pitchFamily="34" charset="-120"/>
+              </a:rPr>
+              <a:t>전략적 고객 계약 16건 · 최소 매출 $100B · 예치금 $22B</a:t>
             </a:r>
             <a:endParaRPr lang="en-US" sz="1050" dirty="0"/>
           </a:p>
-          <a:p>
-            <a:pPr marL="342900" indent="-342900">
+        </p:txBody>
+      </p:sp>
+      <p:sp>
+        <p:nvSpPr>
+          <p:cNvPr id="32" name="Text 30"/>
+          <p:cNvSpPr/>
+          <p:nvPr/>
+        </p:nvSpPr>
+        <p:spPr>
+          <a:xfrm>
+            <a:off x="4645152" y="5541264"/>
+            <a:ext cx="2999232" cy="475488"/>
+          </a:xfrm>
+          <a:prstGeom prst="rect">
+            <a:avLst/>
+          </a:prstGeom>
+          <a:noFill/>
+          <a:ln/>
+        </p:spPr>
+        <p:txBody>
+          <a:bodyPr wrap="square" lIns="0" tIns="0" rIns="0" bIns="0" rtlCol="0" anchor="ctr"/>
+          <a:lstStyle/>
+          <a:p>
+            <a:pPr indent="0" marL="0">
               <a:lnSpc>
-                <a:spcPct val="108000"/>
+                <a:spcPct val="112000"/>
               </a:lnSpc>
-              <a:spcAft>
-                <a:spcPts val="400"/>
-              </a:spcAft>
-              <a:buSzPct val="100000"/>
-              <a:buChar char="•"/>
-            </a:pPr>
-            <a:r>
-              <a:rPr lang="en-US" sz="1050" dirty="0">
-                <a:solidFill>
-                  <a:srgbClr val="17313B"/>
-                </a:solidFill>
-                <a:latin typeface="Malgun Gothic" pitchFamily="34" charset="0"/>
-                <a:ea typeface="Malgun Gothic" pitchFamily="34" charset="-122"/>
-                <a:cs typeface="Malgun Gothic" pitchFamily="34" charset="-120"/>
-              </a:rPr>
-              <a:t>확보: 오픈소스 커미터·하이퍼스케일러 스토리지팀 출신 채용 + 사내 FW 인력의 호스트 SW 전환 트랙(오픈소스 기여를 평가에 반영)</a:t>
+              <a:buNone/>
+            </a:pPr>
+            <a:r>
+              <a:rPr lang="en-US" sz="1000" i="1" dirty="0">
+                <a:solidFill>
+                  <a:srgbClr val="555555"/>
+                </a:solidFill>
+                <a:latin typeface="Malgun Gothic" pitchFamily="34" charset="0"/>
+                <a:ea typeface="Malgun Gothic" pitchFamily="34" charset="-122"/>
+                <a:cs typeface="Malgun Gothic" pitchFamily="34" charset="-120"/>
+              </a:rPr>
+              <a:t>워크로드를 열고 공급을 잠근 계약. 우리가 맺으려는 관계의 실물 견본이다</a:t>
+            </a:r>
+            <a:endParaRPr lang="en-US" sz="1000" dirty="0"/>
+          </a:p>
+        </p:txBody>
+      </p:sp>
+      <p:sp>
+        <p:nvSpPr>
+          <p:cNvPr id="33" name="Text 31"/>
+          <p:cNvSpPr/>
+          <p:nvPr/>
+        </p:nvSpPr>
+        <p:spPr>
+          <a:xfrm>
+            <a:off x="8330184" y="1773936"/>
+            <a:ext cx="3200400" cy="256032"/>
+          </a:xfrm>
+          <a:prstGeom prst="rect">
+            <a:avLst/>
+          </a:prstGeom>
+          <a:noFill/>
+          <a:ln/>
+        </p:spPr>
+        <p:txBody>
+          <a:bodyPr wrap="square" lIns="0" tIns="0" rIns="0" bIns="0" rtlCol="0" anchor="ctr"/>
+          <a:lstStyle/>
+          <a:p>
+            <a:pPr indent="0" marL="0">
+              <a:buNone/>
+            </a:pPr>
+            <a:r>
+              <a:rPr lang="en-US" sz="1050" b="1" dirty="0">
+                <a:solidFill>
+                  <a:srgbClr val="1428A0"/>
+                </a:solidFill>
+                <a:latin typeface="Malgun Gothic" pitchFamily="34" charset="0"/>
+                <a:ea typeface="Malgun Gothic" pitchFamily="34" charset="-122"/>
+                <a:cs typeface="Malgun Gothic" pitchFamily="34" charset="-120"/>
+              </a:rPr>
+              <a:t>추가로 필요한 기술 (기존 SSD 기술 대비)</a:t>
             </a:r>
             <a:endParaRPr lang="en-US" sz="1050" dirty="0"/>
           </a:p>
@@ -1939,46 +2324,146 @@
       </p:sp>
       <p:sp>
         <p:nvSpPr>
-          <p:cNvPr id="27" name="Shape 23"/>
-          <p:cNvSpPr/>
-          <p:nvPr/>
-        </p:nvSpPr>
-        <p:spPr>
-          <a:xfrm>
-            <a:off x="4434840" y="4754880"/>
-            <a:ext cx="7296912" cy="1645920"/>
+          <p:cNvPr id="34" name="Text 32"/>
+          <p:cNvSpPr/>
+          <p:nvPr/>
+        </p:nvSpPr>
+        <p:spPr>
+          <a:xfrm>
+            <a:off x="8330184" y="2066544"/>
+            <a:ext cx="3200400" cy="329184"/>
           </a:xfrm>
           <a:prstGeom prst="roundRect">
             <a:avLst>
-              <a:gd name="adj" fmla="val 5000"/>
+              <a:gd name="adj" fmla="val 13889"/>
             </a:avLst>
           </a:prstGeom>
           <a:solidFill>
-            <a:srgbClr val="F5F7F8"/>
+            <a:srgbClr val="F4F4F6"/>
           </a:solidFill>
           <a:ln/>
         </p:spPr>
-      </p:sp>
-      <p:sp>
-        <p:nvSpPr>
-          <p:cNvPr id="28" name="Text 24"/>
-          <p:cNvSpPr/>
-          <p:nvPr/>
-        </p:nvSpPr>
-        <p:spPr>
-          <a:xfrm>
-            <a:off x="4599432" y="4901184"/>
-            <a:ext cx="329184" cy="329184"/>
-          </a:xfrm>
-          <a:prstGeom prst="ellipse">
-            <a:avLst/>
-          </a:prstGeom>
-          <a:solidFill>
-            <a:srgbClr val="17313B"/>
+        <p:txBody>
+          <a:bodyPr wrap="square" lIns="1016" tIns="1016" rIns="1016" bIns="1016" rtlCol="0" anchor="ctr"/>
+          <a:lstStyle/>
+          <a:p>
+            <a:pPr indent="0" marL="0">
+              <a:buNone/>
+            </a:pPr>
+            <a:r>
+              <a:rPr lang="en-US" sz="950" b="1" dirty="0">
+                <a:solidFill>
+                  <a:srgbClr val="555555"/>
+                </a:solidFill>
+                <a:latin typeface="Malgun Gothic" pitchFamily="34" charset="0"/>
+                <a:ea typeface="Malgun Gothic" pitchFamily="34" charset="-122"/>
+                <a:cs typeface="Malgun Gothic" pitchFamily="34" charset="-120"/>
+              </a:rPr>
+              <a:t>기존  </a:t>
+            </a:r>
+            <a:pPr indent="0" marL="0">
+              <a:buNone/>
+            </a:pPr>
+            <a:r>
+              <a:rPr lang="en-US" sz="950" dirty="0">
+                <a:solidFill>
+                  <a:srgbClr val="555555"/>
+                </a:solidFill>
+                <a:latin typeface="Malgun Gothic" pitchFamily="34" charset="0"/>
+                <a:ea typeface="Malgun Gothic" pitchFamily="34" charset="-122"/>
+                <a:cs typeface="Malgun Gothic" pitchFamily="34" charset="-120"/>
+              </a:rPr>
+              <a:t>NAND · 컨트롤러 · 펌웨어 · 수율</a:t>
+            </a:r>
+            <a:endParaRPr lang="en-US" sz="950" dirty="0"/>
+          </a:p>
+        </p:txBody>
+      </p:sp>
+      <p:sp>
+        <p:nvSpPr>
+          <p:cNvPr id="35" name="Text 33"/>
+          <p:cNvSpPr/>
+          <p:nvPr/>
+        </p:nvSpPr>
+        <p:spPr>
+          <a:xfrm>
+            <a:off x="8330184" y="2450592"/>
+            <a:ext cx="3200400" cy="749808"/>
+          </a:xfrm>
+          <a:prstGeom prst="roundRect">
+            <a:avLst>
+              <a:gd name="adj" fmla="val 6098"/>
+            </a:avLst>
+          </a:prstGeom>
+          <a:solidFill>
+            <a:srgbClr val="EEF1FA"/>
           </a:solidFill>
           <a:ln/>
         </p:spPr>
         <p:txBody>
+          <a:bodyPr wrap="square" lIns="1016" tIns="1016" rIns="1016" bIns="1016" rtlCol="0" anchor="ctr"/>
+          <a:lstStyle/>
+          <a:p>
+            <a:pPr indent="0" marL="0">
+              <a:lnSpc>
+                <a:spcPct val="112000"/>
+              </a:lnSpc>
+              <a:buNone/>
+            </a:pPr>
+            <a:r>
+              <a:rPr lang="en-US" sz="950" b="1" dirty="0">
+                <a:solidFill>
+                  <a:srgbClr val="1428A0"/>
+                </a:solidFill>
+                <a:latin typeface="Malgun Gothic" pitchFamily="34" charset="0"/>
+                <a:ea typeface="Malgun Gothic" pitchFamily="34" charset="-122"/>
+                <a:cs typeface="Malgun Gothic" pitchFamily="34" charset="-120"/>
+              </a:rPr>
+              <a:t>추가  </a:t>
+            </a:r>
+            <a:pPr indent="0" marL="0">
+              <a:lnSpc>
+                <a:spcPct val="112000"/>
+              </a:lnSpc>
+              <a:buNone/>
+            </a:pPr>
+            <a:r>
+              <a:rPr lang="en-US" sz="950" dirty="0">
+                <a:solidFill>
+                  <a:srgbClr val="1A1A1A"/>
+                </a:solidFill>
+                <a:latin typeface="Malgun Gothic" pitchFamily="34" charset="0"/>
+                <a:ea typeface="Malgun Gothic" pitchFamily="34" charset="-122"/>
+                <a:cs typeface="Malgun Gothic" pitchFamily="34" charset="-120"/>
+              </a:rPr>
+              <a:t>커널 블록계층·io_uring·NVMe / SPDK / DB·캐시 내부 (RocksDB·CacheLib·Ceph) / 워크로드 분석 (fio·eBPF·WAF)</a:t>
+            </a:r>
+            <a:endParaRPr lang="en-US" sz="950" dirty="0"/>
+          </a:p>
+        </p:txBody>
+      </p:sp>
+      <p:sp>
+        <p:nvSpPr>
+          <p:cNvPr id="36" name="Text 34"/>
+          <p:cNvSpPr/>
+          <p:nvPr/>
+        </p:nvSpPr>
+        <p:spPr>
+          <a:xfrm>
+            <a:off x="8330184" y="3401568"/>
+            <a:ext cx="566928" cy="292608"/>
+          </a:xfrm>
+          <a:prstGeom prst="roundRect">
+            <a:avLst>
+              <a:gd name="adj" fmla="val 15625"/>
+            </a:avLst>
+          </a:prstGeom>
+          <a:solidFill>
+            <a:srgbClr val="1428A0"/>
+          </a:solidFill>
+          <a:ln/>
+        </p:spPr>
+        <p:txBody>
           <a:bodyPr wrap="square" lIns="0" tIns="0" rIns="0" bIns="0" rtlCol="0" anchor="ctr"/>
           <a:lstStyle/>
           <a:p>
@@ -1986,7 +2471,7 @@
               <a:buNone/>
             </a:pPr>
             <a:r>
-              <a:rPr lang="en-US" sz="1500" b="1" dirty="0">
+              <a:rPr lang="en-US" sz="1000" b="1" dirty="0">
                 <a:solidFill>
                   <a:srgbClr val="FFFFFF"/>
                 </a:solidFill>
@@ -1994,66 +2479,22 @@
                 <a:ea typeface="Malgun Gothic" pitchFamily="34" charset="-122"/>
                 <a:cs typeface="Malgun Gothic" pitchFamily="34" charset="-120"/>
               </a:rPr>
-              <a:t>3</a:t>
-            </a:r>
-            <a:endParaRPr lang="en-US" sz="1500" dirty="0"/>
-          </a:p>
-        </p:txBody>
-      </p:sp>
-      <p:sp>
-        <p:nvSpPr>
-          <p:cNvPr id="29" name="Shape 25"/>
-          <p:cNvSpPr/>
-          <p:nvPr/>
-        </p:nvSpPr>
-        <p:spPr>
-          <a:xfrm>
-            <a:off x="5020056" y="4873752"/>
-            <a:ext cx="384048" cy="384048"/>
-          </a:xfrm>
-          <a:prstGeom prst="ellipse">
-            <a:avLst/>
-          </a:prstGeom>
-          <a:solidFill>
-            <a:srgbClr val="02A878"/>
-          </a:solidFill>
-          <a:ln/>
-        </p:spPr>
-      </p:sp>
-      <p:pic>
-        <p:nvPicPr>
-          <p:cNvPr id="30" name="Image 2" descr="preencoded.png">    </p:cNvPr>
-          <p:cNvPicPr>
-            <a:picLocks noChangeAspect="1"/>
-          </p:cNvPicPr>
-          <p:nvPr/>
-        </p:nvPicPr>
-        <p:blipFill>
-          <a:blip r:embed="rId3"/>
-          <a:stretch>
-            <a:fillRect/>
-          </a:stretch>
-        </p:blipFill>
-        <p:spPr>
-          <a:xfrm>
-            <a:off x="5112228" y="4965924"/>
-            <a:ext cx="199705" cy="199705"/>
-          </a:xfrm>
-          <a:prstGeom prst="rect">
-            <a:avLst/>
-          </a:prstGeom>
-        </p:spPr>
-      </p:pic>
-      <p:sp>
-        <p:nvSpPr>
-          <p:cNvPr id="31" name="Text 26"/>
-          <p:cNvSpPr/>
-          <p:nvPr/>
-        </p:nvSpPr>
-        <p:spPr>
-          <a:xfrm>
-            <a:off x="5532120" y="4882896"/>
-            <a:ext cx="6035040" cy="365760"/>
+              <a:t>채용</a:t>
+            </a:r>
+            <a:endParaRPr lang="en-US" sz="1000" dirty="0"/>
+          </a:p>
+        </p:txBody>
+      </p:sp>
+      <p:sp>
+        <p:nvSpPr>
+          <p:cNvPr id="37" name="Text 35"/>
+          <p:cNvSpPr/>
+          <p:nvPr/>
+        </p:nvSpPr>
+        <p:spPr>
+          <a:xfrm>
+            <a:off x="9006840" y="3383280"/>
+            <a:ext cx="2578608" cy="859536"/>
           </a:xfrm>
           <a:prstGeom prst="rect">
             <a:avLst/>
@@ -2062,37 +2503,83 @@
           <a:ln/>
         </p:spPr>
         <p:txBody>
+          <a:bodyPr wrap="square" lIns="0" tIns="0" rIns="0" bIns="0" rtlCol="0" anchor="t"/>
+          <a:lstStyle/>
+          <a:p>
+            <a:pPr indent="0" marL="0">
+              <a:lnSpc>
+                <a:spcPct val="112000"/>
+              </a:lnSpc>
+              <a:buNone/>
+            </a:pPr>
+            <a:r>
+              <a:rPr lang="en-US" sz="1000" dirty="0">
+                <a:solidFill>
+                  <a:srgbClr val="1A1A1A"/>
+                </a:solidFill>
+                <a:latin typeface="Malgun Gothic" pitchFamily="34" charset="0"/>
+                <a:ea typeface="Malgun Gothic" pitchFamily="34" charset="-122"/>
+                <a:cs typeface="Malgun Gothic" pitchFamily="34" charset="-120"/>
+              </a:rPr>
+              <a:t>실리콘밸리 현지 중심, 오픈소스 스토리지 기여자 우대, 영어 커뮤니케이션 필수</a:t>
+            </a:r>
+            <a:endParaRPr lang="en-US" sz="1000" dirty="0"/>
+          </a:p>
+        </p:txBody>
+      </p:sp>
+      <p:sp>
+        <p:nvSpPr>
+          <p:cNvPr id="38" name="Text 36"/>
+          <p:cNvSpPr/>
+          <p:nvPr/>
+        </p:nvSpPr>
+        <p:spPr>
+          <a:xfrm>
+            <a:off x="8330184" y="4315968"/>
+            <a:ext cx="566928" cy="292608"/>
+          </a:xfrm>
+          <a:prstGeom prst="roundRect">
+            <a:avLst>
+              <a:gd name="adj" fmla="val 15625"/>
+            </a:avLst>
+          </a:prstGeom>
+          <a:solidFill>
+            <a:srgbClr val="1428A0"/>
+          </a:solidFill>
+          <a:ln/>
+        </p:spPr>
+        <p:txBody>
           <a:bodyPr wrap="square" lIns="0" tIns="0" rIns="0" bIns="0" rtlCol="0" anchor="ctr"/>
           <a:lstStyle/>
           <a:p>
-            <a:pPr indent="0" marL="0">
-              <a:buNone/>
-            </a:pPr>
-            <a:r>
-              <a:rPr lang="en-US" sz="1400" b="1" dirty="0">
-                <a:solidFill>
-                  <a:srgbClr val="17313B"/>
-                </a:solidFill>
-                <a:latin typeface="Malgun Gothic" pitchFamily="34" charset="0"/>
-                <a:ea typeface="Malgun Gothic" pitchFamily="34" charset="-122"/>
-                <a:cs typeface="Malgun Gothic" pitchFamily="34" charset="-120"/>
-              </a:rPr>
-              <a:t>FDE를 고객 옆에 두고 FDP 생태계에 함께 기여한다</a:t>
-            </a:r>
-            <a:endParaRPr lang="en-US" sz="1400" dirty="0"/>
-          </a:p>
-        </p:txBody>
-      </p:sp>
-      <p:sp>
-        <p:nvSpPr>
-          <p:cNvPr id="32" name="Text 27"/>
-          <p:cNvSpPr/>
-          <p:nvPr/>
-        </p:nvSpPr>
-        <p:spPr>
-          <a:xfrm>
-            <a:off x="4645152" y="5303520"/>
-            <a:ext cx="6903720" cy="1024128"/>
+            <a:pPr algn="ctr" indent="0" marL="0">
+              <a:buNone/>
+            </a:pPr>
+            <a:r>
+              <a:rPr lang="en-US" sz="1000" b="1" dirty="0">
+                <a:solidFill>
+                  <a:srgbClr val="FFFFFF"/>
+                </a:solidFill>
+                <a:latin typeface="Malgun Gothic" pitchFamily="34" charset="0"/>
+                <a:ea typeface="Malgun Gothic" pitchFamily="34" charset="-122"/>
+                <a:cs typeface="Malgun Gothic" pitchFamily="34" charset="-120"/>
+              </a:rPr>
+              <a:t>양성</a:t>
+            </a:r>
+            <a:endParaRPr lang="en-US" sz="1000" dirty="0"/>
+          </a:p>
+        </p:txBody>
+      </p:sp>
+      <p:sp>
+        <p:nvSpPr>
+          <p:cNvPr id="39" name="Text 37"/>
+          <p:cNvSpPr/>
+          <p:nvPr/>
+        </p:nvSpPr>
+        <p:spPr>
+          <a:xfrm>
+            <a:off x="9006840" y="4297680"/>
+            <a:ext cx="2578608" cy="859536"/>
           </a:xfrm>
           <a:prstGeom prst="rect">
             <a:avLst/>
@@ -2104,76 +2591,109 @@
           <a:bodyPr wrap="square" lIns="0" tIns="0" rIns="0" bIns="0" rtlCol="0" anchor="t"/>
           <a:lstStyle/>
           <a:p>
-            <a:pPr marL="342900" indent="-342900">
+            <a:pPr indent="0" marL="0">
               <a:lnSpc>
-                <a:spcPct val="108000"/>
+                <a:spcPct val="112000"/>
               </a:lnSpc>
-              <a:spcAft>
-                <a:spcPts val="400"/>
-              </a:spcAft>
-              <a:buSzPct val="100000"/>
-              <a:buChar char="•"/>
-            </a:pPr>
-            <a:r>
-              <a:rPr lang="en-US" sz="1050" dirty="0">
-                <a:solidFill>
-                  <a:srgbClr val="17313B"/>
-                </a:solidFill>
-                <a:latin typeface="Malgun Gothic" pitchFamily="34" charset="0"/>
-                <a:ea typeface="Malgun Gothic" pitchFamily="34" charset="-122"/>
-                <a:cs typeface="Malgun Gothic" pitchFamily="34" charset="-120"/>
-              </a:rPr>
-              <a:t>채용: 실리콘밸리 현지 중심, 오픈소스 스토리지 기여자 우대, 영어 커뮤니케이션 필수</a:t>
-            </a:r>
-            <a:endParaRPr lang="en-US" sz="1050" dirty="0"/>
-          </a:p>
-          <a:p>
-            <a:pPr marL="342900" indent="-342900">
+              <a:buNone/>
+            </a:pPr>
+            <a:r>
+              <a:rPr lang="en-US" sz="1000" dirty="0">
+                <a:solidFill>
+                  <a:srgbClr val="1A1A1A"/>
+                </a:solidFill>
+                <a:latin typeface="Malgun Gothic" pitchFamily="34" charset="0"/>
+                <a:ea typeface="Malgun Gothic" pitchFamily="34" charset="-122"/>
+                <a:cs typeface="Malgun Gothic" pitchFamily="34" charset="-120"/>
+              </a:rPr>
+              <a:t>본사 엔지니어 미국 로테이션 6~12개월 + 현지 FDE 멘토 페어링, 사내 FW 인력의 호스트 SW 전환 트랙</a:t>
+            </a:r>
+            <a:endParaRPr lang="en-US" sz="1000" dirty="0"/>
+          </a:p>
+        </p:txBody>
+      </p:sp>
+      <p:sp>
+        <p:nvSpPr>
+          <p:cNvPr id="40" name="Text 38"/>
+          <p:cNvSpPr/>
+          <p:nvPr/>
+        </p:nvSpPr>
+        <p:spPr>
+          <a:xfrm>
+            <a:off x="8330184" y="5230368"/>
+            <a:ext cx="566928" cy="292608"/>
+          </a:xfrm>
+          <a:prstGeom prst="roundRect">
+            <a:avLst>
+              <a:gd name="adj" fmla="val 15625"/>
+            </a:avLst>
+          </a:prstGeom>
+          <a:solidFill>
+            <a:srgbClr val="1428A0"/>
+          </a:solidFill>
+          <a:ln/>
+        </p:spPr>
+        <p:txBody>
+          <a:bodyPr wrap="square" lIns="0" tIns="0" rIns="0" bIns="0" rtlCol="0" anchor="ctr"/>
+          <a:lstStyle/>
+          <a:p>
+            <a:pPr algn="ctr" indent="0" marL="0">
+              <a:buNone/>
+            </a:pPr>
+            <a:r>
+              <a:rPr lang="en-US" sz="1000" b="1" dirty="0">
+                <a:solidFill>
+                  <a:srgbClr val="FFFFFF"/>
+                </a:solidFill>
+                <a:latin typeface="Malgun Gothic" pitchFamily="34" charset="0"/>
+                <a:ea typeface="Malgun Gothic" pitchFamily="34" charset="-122"/>
+                <a:cs typeface="Malgun Gothic" pitchFamily="34" charset="-120"/>
+              </a:rPr>
+              <a:t>운영</a:t>
+            </a:r>
+            <a:endParaRPr lang="en-US" sz="1000" dirty="0"/>
+          </a:p>
+        </p:txBody>
+      </p:sp>
+      <p:sp>
+        <p:nvSpPr>
+          <p:cNvPr id="41" name="Text 39"/>
+          <p:cNvSpPr/>
+          <p:nvPr/>
+        </p:nvSpPr>
+        <p:spPr>
+          <a:xfrm>
+            <a:off x="9006840" y="5212080"/>
+            <a:ext cx="2578608" cy="859536"/>
+          </a:xfrm>
+          <a:prstGeom prst="rect">
+            <a:avLst/>
+          </a:prstGeom>
+          <a:noFill/>
+          <a:ln/>
+        </p:spPr>
+        <p:txBody>
+          <a:bodyPr wrap="square" lIns="0" tIns="0" rIns="0" bIns="0" rtlCol="0" anchor="t"/>
+          <a:lstStyle/>
+          <a:p>
+            <a:pPr indent="0" marL="0">
               <a:lnSpc>
-                <a:spcPct val="108000"/>
+                <a:spcPct val="112000"/>
               </a:lnSpc>
-              <a:spcAft>
-                <a:spcPts val="400"/>
-              </a:spcAft>
-              <a:buSzPct val="100000"/>
-              <a:buChar char="•"/>
-            </a:pPr>
-            <a:r>
-              <a:rPr lang="en-US" sz="1050" dirty="0">
-                <a:solidFill>
-                  <a:srgbClr val="17313B"/>
-                </a:solidFill>
-                <a:latin typeface="Malgun Gothic" pitchFamily="34" charset="0"/>
-                <a:ea typeface="Malgun Gothic" pitchFamily="34" charset="-122"/>
-                <a:cs typeface="Malgun Gothic" pitchFamily="34" charset="-120"/>
-              </a:rPr>
-              <a:t>양성: 본사 엔지니어 미국 로테이션(6~12개월) + 현지 FDE 멘토 페어링</a:t>
-            </a:r>
-            <a:endParaRPr lang="en-US" sz="1050" dirty="0"/>
-          </a:p>
-          <a:p>
-            <a:pPr marL="342900" indent="-342900">
-              <a:lnSpc>
-                <a:spcPct val="108000"/>
-              </a:lnSpc>
-              <a:spcAft>
-                <a:spcPts val="400"/>
-              </a:spcAft>
-              <a:buSzPct val="100000"/>
-              <a:buChar char="•"/>
-            </a:pPr>
-            <a:r>
-              <a:rPr lang="en-US" sz="1050" dirty="0">
-                <a:solidFill>
-                  <a:srgbClr val="17313B"/>
-                </a:solidFill>
-                <a:latin typeface="Malgun Gothic" pitchFamily="34" charset="0"/>
-                <a:ea typeface="Malgun Gothic" pitchFamily="34" charset="-122"/>
-                <a:cs typeface="Malgun Gothic" pitchFamily="34" charset="-120"/>
-              </a:rPr>
-              <a:t>운영: 파일럿 1~2사 상주(Pod 소속·dual-ladder), outcome 평가(FDP 활성화 용량), 커널·SPDK·CacheLib 업스트림 기여로 호명</a:t>
-            </a:r>
-            <a:endParaRPr lang="en-US" sz="1050" dirty="0"/>
+              <a:buNone/>
+            </a:pPr>
+            <a:r>
+              <a:rPr lang="en-US" sz="1000" dirty="0">
+                <a:solidFill>
+                  <a:srgbClr val="1A1A1A"/>
+                </a:solidFill>
+                <a:latin typeface="Malgun Gothic" pitchFamily="34" charset="0"/>
+                <a:ea typeface="Malgun Gothic" pitchFamily="34" charset="-122"/>
+                <a:cs typeface="Malgun Gothic" pitchFamily="34" charset="-120"/>
+              </a:rPr>
+              <a:t>파일럿 1~2사 상주 (Pod 소속·dual-ladder), 평가는 outcome (FDP 활성화 용량), 커널·SPDK·CacheLib 업스트림 기여</a:t>
+            </a:r>
+            <a:endParaRPr lang="en-US" sz="1000" dirty="0"/>
           </a:p>
         </p:txBody>
       </p:sp>

</xml_diff>

<commit_message>
build(pptx): 제품 축 ④에 FDE 도입 선례 박스 추가 (v2.46.9)
- Palantir 창안(코드명 Delta·640% 주가 동력) · Anthropic·OpenAI GTM 채택 선례를
  3번 컬럼에 배치, Micron 선례 박스와 대구 구조
- wiki §4.5 동일 반영, pptx 재생성·다운로드 미러

Co-Authored-By: Claude Fable 5 <noreply@anthropic.com>
Claude-Session: https://claude.ai/code/session_01P75FajBNDiW5p24ay2HU9V
</commit_message>
<xml_diff>
--- a/dashboard/public/downloads/dev-transformation-summary-fdp-eco.pptx
+++ b/dashboard/public/downloads/dev-transformation-summary-fdp-eco.pptx
@@ -2450,7 +2450,74 @@
         </p:nvSpPr>
         <p:spPr>
           <a:xfrm>
-            <a:off x="8330184" y="3401568"/>
+            <a:off x="8330184" y="3310128"/>
+            <a:ext cx="3200400" cy="694944"/>
+          </a:xfrm>
+          <a:prstGeom prst="roundRect">
+            <a:avLst>
+              <a:gd name="adj" fmla="val 6579"/>
+            </a:avLst>
+          </a:prstGeom>
+          <a:solidFill>
+            <a:srgbClr val="EEF1FA"/>
+          </a:solidFill>
+          <a:ln w="12700">
+            <a:solidFill>
+              <a:srgbClr val="1428A0"/>
+            </a:solidFill>
+          </a:ln>
+        </p:spPr>
+        <p:txBody>
+          <a:bodyPr wrap="square" lIns="1016" tIns="1016" rIns="1016" bIns="1016" rtlCol="0" anchor="ctr"/>
+          <a:lstStyle/>
+          <a:p>
+            <a:pPr indent="0" marL="0">
+              <a:lnSpc>
+                <a:spcPct val="110000"/>
+              </a:lnSpc>
+              <a:buNone/>
+            </a:pPr>
+            <a:r>
+              <a:rPr lang="en-US" sz="950" b="1" dirty="0">
+                <a:solidFill>
+                  <a:srgbClr val="1428A0"/>
+                </a:solidFill>
+                <a:latin typeface="Malgun Gothic" pitchFamily="34" charset="0"/>
+                <a:ea typeface="Malgun Gothic" pitchFamily="34" charset="-122"/>
+                <a:cs typeface="Malgun Gothic" pitchFamily="34" charset="-120"/>
+              </a:rPr>
+              <a:t>FDE 선례  </a:t>
+            </a:r>
+            <a:pPr indent="0" marL="0">
+              <a:lnSpc>
+                <a:spcPct val="110000"/>
+              </a:lnSpc>
+              <a:buNone/>
+            </a:pPr>
+            <a:r>
+              <a:rPr lang="en-US" sz="950" dirty="0">
+                <a:solidFill>
+                  <a:srgbClr val="1A1A1A"/>
+                </a:solidFill>
+                <a:latin typeface="Malgun Gothic" pitchFamily="34" charset="0"/>
+                <a:ea typeface="Malgun Gothic" pitchFamily="34" charset="-122"/>
+                <a:cs typeface="Malgun Gothic" pitchFamily="34" charset="-120"/>
+              </a:rPr>
+              <a:t>Palantir가 창안한 직군 (코드명 Delta, 640% 주가 동력으로 회자) · Anthropic·OpenAI도 엔터프라이즈 GTM으로 채택</a:t>
+            </a:r>
+            <a:endParaRPr lang="en-US" sz="950" dirty="0"/>
+          </a:p>
+        </p:txBody>
+      </p:sp>
+      <p:sp>
+        <p:nvSpPr>
+          <p:cNvPr id="37" name="Text 35"/>
+          <p:cNvSpPr/>
+          <p:nvPr/>
+        </p:nvSpPr>
+        <p:spPr>
+          <a:xfrm>
+            <a:off x="8330184" y="4133088"/>
             <a:ext cx="566928" cy="292608"/>
           </a:xfrm>
           <a:prstGeom prst="roundRect">
@@ -2487,14 +2554,14 @@
       </p:sp>
       <p:sp>
         <p:nvSpPr>
-          <p:cNvPr id="37" name="Text 35"/>
-          <p:cNvSpPr/>
-          <p:nvPr/>
-        </p:nvSpPr>
-        <p:spPr>
-          <a:xfrm>
-            <a:off x="9006840" y="3383280"/>
-            <a:ext cx="2578608" cy="859536"/>
+          <p:cNvPr id="38" name="Text 36"/>
+          <p:cNvSpPr/>
+          <p:nvPr/>
+        </p:nvSpPr>
+        <p:spPr>
+          <a:xfrm>
+            <a:off x="9006840" y="4114800"/>
+            <a:ext cx="2578608" cy="658368"/>
           </a:xfrm>
           <a:prstGeom prst="rect">
             <a:avLst/>
@@ -2521,7 +2588,7 @@
                 <a:ea typeface="Malgun Gothic" pitchFamily="34" charset="-122"/>
                 <a:cs typeface="Malgun Gothic" pitchFamily="34" charset="-120"/>
               </a:rPr>
-              <a:t>실리콘밸리 현지 중심, 오픈소스 스토리지 기여자 우대, 영어 커뮤니케이션 필수</a:t>
+              <a:t>실리콘밸리 현지, 오픈소스 스토리지 기여자 우대, 영어 필수</a:t>
             </a:r>
             <a:endParaRPr lang="en-US" sz="1000" dirty="0"/>
           </a:p>
@@ -2529,13 +2596,13 @@
       </p:sp>
       <p:sp>
         <p:nvSpPr>
-          <p:cNvPr id="38" name="Text 36"/>
-          <p:cNvSpPr/>
-          <p:nvPr/>
-        </p:nvSpPr>
-        <p:spPr>
-          <a:xfrm>
-            <a:off x="8330184" y="4315968"/>
+          <p:cNvPr id="39" name="Text 37"/>
+          <p:cNvSpPr/>
+          <p:nvPr/>
+        </p:nvSpPr>
+        <p:spPr>
+          <a:xfrm>
+            <a:off x="8330184" y="4846320"/>
             <a:ext cx="566928" cy="292608"/>
           </a:xfrm>
           <a:prstGeom prst="roundRect">
@@ -2572,14 +2639,14 @@
       </p:sp>
       <p:sp>
         <p:nvSpPr>
-          <p:cNvPr id="39" name="Text 37"/>
-          <p:cNvSpPr/>
-          <p:nvPr/>
-        </p:nvSpPr>
-        <p:spPr>
-          <a:xfrm>
-            <a:off x="9006840" y="4297680"/>
-            <a:ext cx="2578608" cy="859536"/>
+          <p:cNvPr id="40" name="Text 38"/>
+          <p:cNvSpPr/>
+          <p:nvPr/>
+        </p:nvSpPr>
+        <p:spPr>
+          <a:xfrm>
+            <a:off x="9006840" y="4828032"/>
+            <a:ext cx="2578608" cy="658368"/>
           </a:xfrm>
           <a:prstGeom prst="rect">
             <a:avLst/>
@@ -2606,7 +2673,7 @@
                 <a:ea typeface="Malgun Gothic" pitchFamily="34" charset="-122"/>
                 <a:cs typeface="Malgun Gothic" pitchFamily="34" charset="-120"/>
               </a:rPr>
-              <a:t>본사 엔지니어 미국 로테이션 6~12개월 + 현지 FDE 멘토 페어링, 사내 FW 인력의 호스트 SW 전환 트랙</a:t>
+              <a:t>본사 엔지니어 미국 로테이션 6~12개월 + 현지 FDE 멘토 페어링</a:t>
             </a:r>
             <a:endParaRPr lang="en-US" sz="1000" dirty="0"/>
           </a:p>
@@ -2614,13 +2681,13 @@
       </p:sp>
       <p:sp>
         <p:nvSpPr>
-          <p:cNvPr id="40" name="Text 38"/>
-          <p:cNvSpPr/>
-          <p:nvPr/>
-        </p:nvSpPr>
-        <p:spPr>
-          <a:xfrm>
-            <a:off x="8330184" y="5230368"/>
+          <p:cNvPr id="41" name="Text 39"/>
+          <p:cNvSpPr/>
+          <p:nvPr/>
+        </p:nvSpPr>
+        <p:spPr>
+          <a:xfrm>
+            <a:off x="8330184" y="5559552"/>
             <a:ext cx="566928" cy="292608"/>
           </a:xfrm>
           <a:prstGeom prst="roundRect">
@@ -2657,14 +2724,14 @@
       </p:sp>
       <p:sp>
         <p:nvSpPr>
-          <p:cNvPr id="41" name="Text 39"/>
-          <p:cNvSpPr/>
-          <p:nvPr/>
-        </p:nvSpPr>
-        <p:spPr>
-          <a:xfrm>
-            <a:off x="9006840" y="5212080"/>
-            <a:ext cx="2578608" cy="859536"/>
+          <p:cNvPr id="42" name="Text 40"/>
+          <p:cNvSpPr/>
+          <p:nvPr/>
+        </p:nvSpPr>
+        <p:spPr>
+          <a:xfrm>
+            <a:off x="9006840" y="5541264"/>
+            <a:ext cx="2578608" cy="658368"/>
           </a:xfrm>
           <a:prstGeom prst="rect">
             <a:avLst/>
@@ -2691,7 +2758,7 @@
                 <a:ea typeface="Malgun Gothic" pitchFamily="34" charset="-122"/>
                 <a:cs typeface="Malgun Gothic" pitchFamily="34" charset="-120"/>
               </a:rPr>
-              <a:t>파일럿 1~2사 상주 (Pod 소속·dual-ladder), 평가는 outcome (FDP 활성화 용량), 커널·SPDK·CacheLib 업스트림 기여</a:t>
+              <a:t>파일럿 1~2사 상주 (Pod 소속), outcome 평가 (활성화 용량), 업스트림 기여</a:t>
             </a:r>
             <a:endParaRPr lang="en-US" sz="1000" dirty="0"/>
           </a:p>

</xml_diff>

<commit_message>
ingest(strategy,pptx): 배경 2장: 2023 다운턴 복기 + KV Cache·DWPD 갭 (v2.46.10)
- 소스 2건: 2023 벤더 낙폭(삼성 -54%·SK -63%·Kioxia -35%)·eSSD 점유·CapEx 재배분·
  Solidigm 반증 / KV cache 수요(FMS'26 75~100EB→2배·35%)·7~10+ DWPD 요구·FDP 해법
- wiki §2.5·§2.6 신설, PPT 배경 ①·②(수제 차트 5종) 추가: -fdp-eco 3장·통합 9장
- DT_DOWNLOADS desc 갱신, v2.46.10

Co-Authored-By: Claude Fable 5 <noreply@anthropic.com>
Claude-Session: https://claude.ai/code/session_01P75FajBNDiW5p24ay2HU9V
</commit_message>
<xml_diff>
--- a/dashboard/public/downloads/dev-transformation-summary-fdp-eco.pptx
+++ b/dashboard/public/downloads/dev-transformation-summary-fdp-eco.pptx
@@ -6,9 +6,11 @@
   </p:sldMasterIdLst>
   <p:sldIdLst>
     <p:sldId id="256" r:id="rId2"/>
+    <p:sldId id="257" r:id="rId3"/>
+    <p:sldId id="258" r:id="rId4"/>
   </p:sldIdLst>
   <p:notesMasterIdLst>
-    <p:notesMasterId r:id="rId3"/>
+    <p:notesMasterId r:id="rId5"/>
   </p:notesMasterIdLst>
   <p:sldSz cx="12192000" cy="6858000"/>
   <p:notesSz cx="6858000" cy="12192000"/>
@@ -544,6 +546,182 @@
 </p:notes>
 </file>
 
+<file path=ppt/notesSlides/notesSlide2.xml><?xml version="1.0" encoding="utf-8"?>
+<p:notes xmlns:a="http://schemas.openxmlformats.org/drawingml/2006/main" xmlns:r="http://schemas.openxmlformats.org/officeDocument/2006/relationships" xmlns:p="http://schemas.openxmlformats.org/presentationml/2006/main">
+  <p:cSld>
+    <p:spTree>
+      <p:nvGrpSpPr>
+        <p:cNvPr id="1" name=""/>
+        <p:cNvGrpSpPr/>
+        <p:nvPr/>
+      </p:nvGrpSpPr>
+      <p:grpSpPr>
+        <a:xfrm>
+          <a:off x="0" y="0"/>
+          <a:ext cx="0" cy="0"/>
+          <a:chOff x="0" y="0"/>
+          <a:chExt cx="0" cy="0"/>
+        </a:xfrm>
+      </p:grpSpPr>
+      <p:sp>
+        <p:nvSpPr>
+          <p:cNvPr id="2" name="Slide Image Placeholder 1"/>
+          <p:cNvSpPr>
+            <a:spLocks noGrp="1" noRot="1" noChangeAspect="1"/>
+          </p:cNvSpPr>
+          <p:nvPr>
+            <p:ph type="sldImg"/>
+          </p:nvPr>
+        </p:nvSpPr>
+        <p:spPr/>
+      </p:sp>
+      <p:sp>
+        <p:nvSpPr>
+          <p:cNvPr id="3" name="Notes Placeholder 2"/>
+          <p:cNvSpPr>
+            <a:spLocks noGrp="1"/>
+          </p:cNvSpPr>
+          <p:nvPr>
+            <p:ph type="body" idx="1"/>
+          </p:nvPr>
+        </p:nvSpPr>
+        <p:spPr/>
+        <p:txBody>
+          <a:bodyPr/>
+          <a:lstStyle/>
+          <a:p>
+            <a:r>
+              <a:rPr lang="en-US" dirty="0"/>
+              <a:t/>
+            </a:r>
+            <a:endParaRPr lang="en-US" dirty="0"/>
+          </a:p>
+        </p:txBody>
+      </p:sp>
+      <p:sp>
+        <p:nvSpPr>
+          <p:cNvPr id="4" name="Slide Number Placeholder 3"/>
+          <p:cNvSpPr>
+            <a:spLocks noGrp="1"/>
+          </p:cNvSpPr>
+          <p:nvPr>
+            <p:ph type="sldNum" sz="quarter" idx="10"/>
+          </p:nvPr>
+        </p:nvSpPr>
+        <p:spPr/>
+        <p:txBody>
+          <a:bodyPr/>
+          <a:lstStyle/>
+          <a:p>
+            <a:fld id="{F7021451-1387-4CA6-816F-3879F97B5CBC}" type="slidenum">
+              <a:rPr lang="en-US"/>
+              <a:t>2</a:t>
+            </a:fld>
+            <a:endParaRPr lang="en-US"/>
+          </a:p>
+        </p:txBody>
+      </p:sp>
+    </p:spTree>
+    <p:extLst>
+      <p:ext uri="{BB962C8B-B14F-4D97-AF65-F5344CB8AC3E}">
+        <p14:creationId xmlns:p14="http://schemas.microsoft.com/office/powerpoint/2010/main" val="1024086991"/>
+      </p:ext>
+    </p:extLst>
+  </p:cSld>
+  <p:clrMapOvr>
+    <a:masterClrMapping/>
+  </p:clrMapOvr>
+</p:notes>
+</file>
+
+<file path=ppt/notesSlides/notesSlide3.xml><?xml version="1.0" encoding="utf-8"?>
+<p:notes xmlns:a="http://schemas.openxmlformats.org/drawingml/2006/main" xmlns:r="http://schemas.openxmlformats.org/officeDocument/2006/relationships" xmlns:p="http://schemas.openxmlformats.org/presentationml/2006/main">
+  <p:cSld>
+    <p:spTree>
+      <p:nvGrpSpPr>
+        <p:cNvPr id="1" name=""/>
+        <p:cNvGrpSpPr/>
+        <p:nvPr/>
+      </p:nvGrpSpPr>
+      <p:grpSpPr>
+        <a:xfrm>
+          <a:off x="0" y="0"/>
+          <a:ext cx="0" cy="0"/>
+          <a:chOff x="0" y="0"/>
+          <a:chExt cx="0" cy="0"/>
+        </a:xfrm>
+      </p:grpSpPr>
+      <p:sp>
+        <p:nvSpPr>
+          <p:cNvPr id="2" name="Slide Image Placeholder 1"/>
+          <p:cNvSpPr>
+            <a:spLocks noGrp="1" noRot="1" noChangeAspect="1"/>
+          </p:cNvSpPr>
+          <p:nvPr>
+            <p:ph type="sldImg"/>
+          </p:nvPr>
+        </p:nvSpPr>
+        <p:spPr/>
+      </p:sp>
+      <p:sp>
+        <p:nvSpPr>
+          <p:cNvPr id="3" name="Notes Placeholder 2"/>
+          <p:cNvSpPr>
+            <a:spLocks noGrp="1"/>
+          </p:cNvSpPr>
+          <p:nvPr>
+            <p:ph type="body" idx="1"/>
+          </p:nvPr>
+        </p:nvSpPr>
+        <p:spPr/>
+        <p:txBody>
+          <a:bodyPr/>
+          <a:lstStyle/>
+          <a:p>
+            <a:r>
+              <a:rPr lang="en-US" dirty="0"/>
+              <a:t/>
+            </a:r>
+            <a:endParaRPr lang="en-US" dirty="0"/>
+          </a:p>
+        </p:txBody>
+      </p:sp>
+      <p:sp>
+        <p:nvSpPr>
+          <p:cNvPr id="4" name="Slide Number Placeholder 3"/>
+          <p:cNvSpPr>
+            <a:spLocks noGrp="1"/>
+          </p:cNvSpPr>
+          <p:nvPr>
+            <p:ph type="sldNum" sz="quarter" idx="10"/>
+          </p:nvPr>
+        </p:nvSpPr>
+        <p:spPr/>
+        <p:txBody>
+          <a:bodyPr/>
+          <a:lstStyle/>
+          <a:p>
+            <a:fld id="{F7021451-1387-4CA6-816F-3879F97B5CBC}" type="slidenum">
+              <a:rPr lang="en-US"/>
+              <a:t>3</a:t>
+            </a:fld>
+            <a:endParaRPr lang="en-US"/>
+          </a:p>
+        </p:txBody>
+      </p:sp>
+    </p:spTree>
+    <p:extLst>
+      <p:ext uri="{BB962C8B-B14F-4D97-AF65-F5344CB8AC3E}">
+        <p14:creationId xmlns:p14="http://schemas.microsoft.com/office/powerpoint/2010/main" val="1024086991"/>
+      </p:ext>
+    </p:extLst>
+  </p:cSld>
+  <p:clrMapOvr>
+    <a:masterClrMapping/>
+  </p:clrMapOvr>
+</p:notes>
+</file>
+
 <file path=ppt/slideLayouts/slideLayout1.xml><?xml version="1.0" encoding="utf-8"?>
 <p:sldLayout xmlns:a="http://schemas.openxmlformats.org/drawingml/2006/main" xmlns:r="http://schemas.openxmlformats.org/officeDocument/2006/relationships" xmlns:p="http://schemas.openxmlformats.org/presentationml/2006/main" preserve="1">
   <p:cSld name="DEFAULT">
@@ -854,6 +1032,4263 @@
 <file path=ppt/slides/slide1.xml><?xml version="1.0" encoding="utf-8"?>
 <p:sld xmlns:a="http://schemas.openxmlformats.org/drawingml/2006/main" xmlns:r="http://schemas.openxmlformats.org/officeDocument/2006/relationships" xmlns:p="http://schemas.openxmlformats.org/presentationml/2006/main">
   <p:cSld name="Slide 1">
+    <p:spTree>
+      <p:nvGrpSpPr>
+        <p:cNvPr id="1" name=""/>
+        <p:cNvGrpSpPr/>
+        <p:nvPr/>
+      </p:nvGrpSpPr>
+      <p:grpSpPr>
+        <a:xfrm>
+          <a:off x="0" y="0"/>
+          <a:ext cx="0" cy="0"/>
+          <a:chOff x="0" y="0"/>
+          <a:chExt cx="0" cy="0"/>
+        </a:xfrm>
+      </p:grpSpPr>
+      <p:sp>
+        <p:nvSpPr>
+          <p:cNvPr id="2" name="Text 0"/>
+          <p:cNvSpPr/>
+          <p:nvPr/>
+        </p:nvSpPr>
+        <p:spPr>
+          <a:xfrm>
+            <a:off x="457200" y="237744"/>
+            <a:ext cx="9765792" cy="566928"/>
+          </a:xfrm>
+          <a:prstGeom prst="rect">
+            <a:avLst/>
+          </a:prstGeom>
+          <a:noFill/>
+          <a:ln/>
+        </p:spPr>
+        <p:txBody>
+          <a:bodyPr wrap="square" lIns="0" tIns="0" rIns="0" bIns="0" rtlCol="0" anchor="ctr"/>
+          <a:lstStyle/>
+          <a:p>
+            <a:pPr indent="0" marL="0">
+              <a:buNone/>
+            </a:pPr>
+            <a:r>
+              <a:rPr lang="en-US" sz="3200" b="1" dirty="0">
+                <a:solidFill>
+                  <a:srgbClr val="17313B"/>
+                </a:solidFill>
+                <a:latin typeface="Malgun Gothic" pitchFamily="34" charset="0"/>
+                <a:ea typeface="Malgun Gothic" pitchFamily="34" charset="-122"/>
+                <a:cs typeface="Malgun Gothic" pitchFamily="34" charset="-120"/>
+              </a:rPr>
+              <a:t>2023 다운턴: 깊이는 고객 구조가 결정했다</a:t>
+            </a:r>
+            <a:endParaRPr lang="en-US" sz="3200" dirty="0"/>
+          </a:p>
+        </p:txBody>
+      </p:sp>
+      <p:sp>
+        <p:nvSpPr>
+          <p:cNvPr id="3" name="Text 1"/>
+          <p:cNvSpPr/>
+          <p:nvPr/>
+        </p:nvSpPr>
+        <p:spPr>
+          <a:xfrm>
+            <a:off x="10268712" y="310896"/>
+            <a:ext cx="1463040" cy="420624"/>
+          </a:xfrm>
+          <a:prstGeom prst="roundRect">
+            <a:avLst>
+              <a:gd name="adj" fmla="val 21739"/>
+            </a:avLst>
+          </a:prstGeom>
+          <a:solidFill>
+            <a:srgbClr val="EFF3F5"/>
+          </a:solidFill>
+          <a:ln/>
+        </p:spPr>
+        <p:txBody>
+          <a:bodyPr wrap="square" lIns="0" tIns="0" rIns="0" bIns="0" rtlCol="0" anchor="ctr"/>
+          <a:lstStyle/>
+          <a:p>
+            <a:pPr algn="ctr" indent="0" marL="0">
+              <a:buNone/>
+            </a:pPr>
+            <a:r>
+              <a:rPr lang="en-US" sz="1400" b="1" dirty="0">
+                <a:solidFill>
+                  <a:srgbClr val="5A7184"/>
+                </a:solidFill>
+                <a:latin typeface="Malgun Gothic" pitchFamily="34" charset="0"/>
+                <a:ea typeface="Malgun Gothic" pitchFamily="34" charset="-122"/>
+                <a:cs typeface="Malgun Gothic" pitchFamily="34" charset="-120"/>
+              </a:rPr>
+              <a:t>배경 ①</a:t>
+            </a:r>
+            <a:endParaRPr lang="en-US" sz="1400" dirty="0"/>
+          </a:p>
+        </p:txBody>
+      </p:sp>
+      <p:sp>
+        <p:nvSpPr>
+          <p:cNvPr id="4" name="Text 2"/>
+          <p:cNvSpPr/>
+          <p:nvPr/>
+        </p:nvSpPr>
+        <p:spPr>
+          <a:xfrm>
+            <a:off x="457200" y="6510528"/>
+            <a:ext cx="6949440" cy="256032"/>
+          </a:xfrm>
+          <a:prstGeom prst="rect">
+            <a:avLst/>
+          </a:prstGeom>
+          <a:noFill/>
+          <a:ln/>
+        </p:spPr>
+        <p:txBody>
+          <a:bodyPr wrap="square" lIns="0" tIns="0" rIns="0" bIns="0" rtlCol="0" anchor="ctr"/>
+          <a:lstStyle/>
+          <a:p>
+            <a:pPr indent="0" marL="0">
+              <a:buNone/>
+            </a:pPr>
+            <a:r>
+              <a:rPr lang="en-US" sz="1000" dirty="0">
+                <a:solidFill>
+                  <a:srgbClr val="5A7184"/>
+                </a:solidFill>
+                <a:latin typeface="Malgun Gothic" pitchFamily="34" charset="0"/>
+                <a:ea typeface="Malgun Gothic" pitchFamily="34" charset="-122"/>
+                <a:cs typeface="Malgun Gothic" pitchFamily="34" charset="-120"/>
+              </a:rPr>
+              <a:t>삼성전자 메모리사업부 · 개발실 체질 전환 전략 요약 · 2026-07-24</a:t>
+            </a:r>
+            <a:endParaRPr lang="en-US" sz="1000" dirty="0"/>
+          </a:p>
+        </p:txBody>
+      </p:sp>
+      <p:sp>
+        <p:nvSpPr>
+          <p:cNvPr id="5" name="Text 3"/>
+          <p:cNvSpPr/>
+          <p:nvPr/>
+        </p:nvSpPr>
+        <p:spPr>
+          <a:xfrm>
+            <a:off x="7589520" y="6510528"/>
+            <a:ext cx="4142232" cy="256032"/>
+          </a:xfrm>
+          <a:prstGeom prst="rect">
+            <a:avLst/>
+          </a:prstGeom>
+          <a:noFill/>
+          <a:ln/>
+        </p:spPr>
+        <p:txBody>
+          <a:bodyPr wrap="square" lIns="0" tIns="0" rIns="0" bIns="0" rtlCol="0" anchor="ctr"/>
+          <a:lstStyle/>
+          <a:p>
+            <a:pPr algn="r" indent="0" marL="0">
+              <a:buNone/>
+            </a:pPr>
+            <a:r>
+              <a:rPr lang="en-US" sz="1000" dirty="0">
+                <a:solidFill>
+                  <a:srgbClr val="5A7184"/>
+                </a:solidFill>
+                <a:latin typeface="Malgun Gothic" pitchFamily="34" charset="0"/>
+                <a:ea typeface="Malgun Gothic" pitchFamily="34" charset="-122"/>
+                <a:cs typeface="Malgun Gothic" pitchFamily="34" charset="-120"/>
+              </a:rPr>
+              <a:t>원천: wiki/strategies/fdp-host-ssd-platform.md</a:t>
+            </a:r>
+            <a:endParaRPr lang="en-US" sz="1000" dirty="0"/>
+          </a:p>
+        </p:txBody>
+      </p:sp>
+      <p:sp>
+        <p:nvSpPr>
+          <p:cNvPr id="6" name="Text 4"/>
+          <p:cNvSpPr/>
+          <p:nvPr/>
+        </p:nvSpPr>
+        <p:spPr>
+          <a:xfrm>
+            <a:off x="457200" y="822960"/>
+            <a:ext cx="11274552" cy="274320"/>
+          </a:xfrm>
+          <a:prstGeom prst="rect">
+            <a:avLst/>
+          </a:prstGeom>
+          <a:noFill/>
+          <a:ln/>
+        </p:spPr>
+        <p:txBody>
+          <a:bodyPr wrap="square" lIns="0" tIns="0" rIns="0" bIns="0" rtlCol="0" anchor="ctr"/>
+          <a:lstStyle/>
+          <a:p>
+            <a:pPr indent="0" marL="0">
+              <a:buNone/>
+            </a:pPr>
+            <a:r>
+              <a:rPr lang="en-US" sz="1300" b="1" dirty="0">
+                <a:solidFill>
+                  <a:srgbClr val="1428A0"/>
+                </a:solidFill>
+                <a:latin typeface="Malgun Gothic" pitchFamily="34" charset="0"/>
+                <a:ea typeface="Malgun Gothic" pitchFamily="34" charset="-122"/>
+                <a:cs typeface="Malgun Gothic" pitchFamily="34" charset="-120"/>
+              </a:rPr>
+              <a:t>배경  </a:t>
+            </a:r>
+            <a:pPr indent="0" marL="0">
+              <a:buNone/>
+            </a:pPr>
+            <a:r>
+              <a:rPr lang="en-US" sz="1300" dirty="0">
+                <a:solidFill>
+                  <a:srgbClr val="555555"/>
+                </a:solidFill>
+                <a:latin typeface="Malgun Gothic" pitchFamily="34" charset="0"/>
+                <a:ea typeface="Malgun Gothic" pitchFamily="34" charset="-122"/>
+                <a:cs typeface="Malgun Gothic" pitchFamily="34" charset="-120"/>
+              </a:rPr>
+              <a:t>서버 노출이 큰 벤더일수록 깊게 맞았다: 문제는 총수요가 아니라 수요의 형태 변화, 답은 다변화가 아니라 니즈 적중 (Solidigm)</a:t>
+            </a:r>
+            <a:endParaRPr lang="en-US" sz="1300" dirty="0"/>
+          </a:p>
+        </p:txBody>
+      </p:sp>
+      <p:sp>
+        <p:nvSpPr>
+          <p:cNvPr id="7" name="Text 5"/>
+          <p:cNvSpPr/>
+          <p:nvPr/>
+        </p:nvSpPr>
+        <p:spPr>
+          <a:xfrm>
+            <a:off x="457200" y="1188720"/>
+            <a:ext cx="310896" cy="310896"/>
+          </a:xfrm>
+          <a:prstGeom prst="ellipse">
+            <a:avLst/>
+          </a:prstGeom>
+          <a:solidFill>
+            <a:srgbClr val="1428A0"/>
+          </a:solidFill>
+          <a:ln/>
+        </p:spPr>
+        <p:txBody>
+          <a:bodyPr wrap="square" lIns="0" tIns="0" rIns="0" bIns="0" rtlCol="0" anchor="ctr"/>
+          <a:lstStyle/>
+          <a:p>
+            <a:pPr algn="ctr" indent="0" marL="0">
+              <a:buNone/>
+            </a:pPr>
+            <a:r>
+              <a:rPr lang="en-US" sz="1400" b="1" dirty="0">
+                <a:solidFill>
+                  <a:srgbClr val="FFFFFF"/>
+                </a:solidFill>
+                <a:latin typeface="Malgun Gothic" pitchFamily="34" charset="0"/>
+                <a:ea typeface="Malgun Gothic" pitchFamily="34" charset="-122"/>
+                <a:cs typeface="Malgun Gothic" pitchFamily="34" charset="-120"/>
+              </a:rPr>
+              <a:t>1</a:t>
+            </a:r>
+            <a:endParaRPr lang="en-US" sz="1400" dirty="0"/>
+          </a:p>
+        </p:txBody>
+      </p:sp>
+      <p:sp>
+        <p:nvSpPr>
+          <p:cNvPr id="8" name="Text 6"/>
+          <p:cNvSpPr/>
+          <p:nvPr/>
+        </p:nvSpPr>
+        <p:spPr>
+          <a:xfrm>
+            <a:off x="859536" y="1170432"/>
+            <a:ext cx="3200400" cy="347472"/>
+          </a:xfrm>
+          <a:prstGeom prst="rect">
+            <a:avLst/>
+          </a:prstGeom>
+          <a:noFill/>
+          <a:ln/>
+        </p:spPr>
+        <p:txBody>
+          <a:bodyPr wrap="square" lIns="0" tIns="0" rIns="0" bIns="0" rtlCol="0" anchor="ctr"/>
+          <a:lstStyle/>
+          <a:p>
+            <a:pPr indent="0" marL="0">
+              <a:buNone/>
+            </a:pPr>
+            <a:r>
+              <a:rPr lang="en-US" sz="1350" b="1" dirty="0">
+                <a:solidFill>
+                  <a:srgbClr val="1A1A1A"/>
+                </a:solidFill>
+                <a:latin typeface="Malgun Gothic" pitchFamily="34" charset="0"/>
+                <a:ea typeface="Malgun Gothic" pitchFamily="34" charset="-122"/>
+                <a:cs typeface="Malgun Gothic" pitchFamily="34" charset="-120"/>
+              </a:rPr>
+              <a:t>낙폭: 피크(2Q22)→저점(1Q23)</a:t>
+            </a:r>
+            <a:endParaRPr lang="en-US" sz="1350" dirty="0"/>
+          </a:p>
+        </p:txBody>
+      </p:sp>
+      <p:sp>
+        <p:nvSpPr>
+          <p:cNvPr id="9" name="Shape 7"/>
+          <p:cNvSpPr/>
+          <p:nvPr/>
+        </p:nvSpPr>
+        <p:spPr>
+          <a:xfrm>
+            <a:off x="457200" y="1627632"/>
+            <a:ext cx="3602736" cy="4626864"/>
+          </a:xfrm>
+          <a:prstGeom prst="roundRect">
+            <a:avLst>
+              <a:gd name="adj" fmla="val 2030"/>
+            </a:avLst>
+          </a:prstGeom>
+          <a:solidFill>
+            <a:srgbClr val="FFFFFF"/>
+          </a:solidFill>
+          <a:ln w="12700">
+            <a:solidFill>
+              <a:srgbClr val="D9D9D9"/>
+            </a:solidFill>
+            <a:prstDash val="solid"/>
+          </a:ln>
+        </p:spPr>
+      </p:sp>
+      <p:sp>
+        <p:nvSpPr>
+          <p:cNvPr id="10" name="Text 8"/>
+          <p:cNvSpPr/>
+          <p:nvPr/>
+        </p:nvSpPr>
+        <p:spPr>
+          <a:xfrm>
+            <a:off x="4297680" y="1188720"/>
+            <a:ext cx="310896" cy="310896"/>
+          </a:xfrm>
+          <a:prstGeom prst="ellipse">
+            <a:avLst/>
+          </a:prstGeom>
+          <a:solidFill>
+            <a:srgbClr val="1428A0"/>
+          </a:solidFill>
+          <a:ln/>
+        </p:spPr>
+        <p:txBody>
+          <a:bodyPr wrap="square" lIns="0" tIns="0" rIns="0" bIns="0" rtlCol="0" anchor="ctr"/>
+          <a:lstStyle/>
+          <a:p>
+            <a:pPr algn="ctr" indent="0" marL="0">
+              <a:buNone/>
+            </a:pPr>
+            <a:r>
+              <a:rPr lang="en-US" sz="1400" b="1" dirty="0">
+                <a:solidFill>
+                  <a:srgbClr val="FFFFFF"/>
+                </a:solidFill>
+                <a:latin typeface="Malgun Gothic" pitchFamily="34" charset="0"/>
+                <a:ea typeface="Malgun Gothic" pitchFamily="34" charset="-122"/>
+                <a:cs typeface="Malgun Gothic" pitchFamily="34" charset="-120"/>
+              </a:rPr>
+              <a:t>2</a:t>
+            </a:r>
+            <a:endParaRPr lang="en-US" sz="1400" dirty="0"/>
+          </a:p>
+        </p:txBody>
+      </p:sp>
+      <p:sp>
+        <p:nvSpPr>
+          <p:cNvPr id="11" name="Text 9"/>
+          <p:cNvSpPr/>
+          <p:nvPr/>
+        </p:nvSpPr>
+        <p:spPr>
+          <a:xfrm>
+            <a:off x="4700016" y="1170432"/>
+            <a:ext cx="3200400" cy="347472"/>
+          </a:xfrm>
+          <a:prstGeom prst="rect">
+            <a:avLst/>
+          </a:prstGeom>
+          <a:noFill/>
+          <a:ln/>
+        </p:spPr>
+        <p:txBody>
+          <a:bodyPr wrap="square" lIns="0" tIns="0" rIns="0" bIns="0" rtlCol="0" anchor="ctr"/>
+          <a:lstStyle/>
+          <a:p>
+            <a:pPr indent="0" marL="0">
+              <a:buNone/>
+            </a:pPr>
+            <a:r>
+              <a:rPr lang="en-US" sz="1350" b="1" dirty="0">
+                <a:solidFill>
+                  <a:srgbClr val="1A1A1A"/>
+                </a:solidFill>
+                <a:latin typeface="Malgun Gothic" pitchFamily="34" charset="0"/>
+                <a:ea typeface="Malgun Gothic" pitchFamily="34" charset="-122"/>
+                <a:cs typeface="Malgun Gothic" pitchFamily="34" charset="-120"/>
+              </a:rPr>
+              <a:t>원인: 서버·고객 노출</a:t>
+            </a:r>
+            <a:endParaRPr lang="en-US" sz="1350" dirty="0"/>
+          </a:p>
+        </p:txBody>
+      </p:sp>
+      <p:sp>
+        <p:nvSpPr>
+          <p:cNvPr id="12" name="Shape 10"/>
+          <p:cNvSpPr/>
+          <p:nvPr/>
+        </p:nvSpPr>
+        <p:spPr>
+          <a:xfrm>
+            <a:off x="4297680" y="1627632"/>
+            <a:ext cx="3602736" cy="4626864"/>
+          </a:xfrm>
+          <a:prstGeom prst="roundRect">
+            <a:avLst>
+              <a:gd name="adj" fmla="val 2030"/>
+            </a:avLst>
+          </a:prstGeom>
+          <a:solidFill>
+            <a:srgbClr val="FFFFFF"/>
+          </a:solidFill>
+          <a:ln w="12700">
+            <a:solidFill>
+              <a:srgbClr val="D9D9D9"/>
+            </a:solidFill>
+            <a:prstDash val="solid"/>
+          </a:ln>
+        </p:spPr>
+      </p:sp>
+      <p:sp>
+        <p:nvSpPr>
+          <p:cNvPr id="13" name="Text 11"/>
+          <p:cNvSpPr/>
+          <p:nvPr/>
+        </p:nvSpPr>
+        <p:spPr>
+          <a:xfrm>
+            <a:off x="8129016" y="1188720"/>
+            <a:ext cx="310896" cy="310896"/>
+          </a:xfrm>
+          <a:prstGeom prst="ellipse">
+            <a:avLst/>
+          </a:prstGeom>
+          <a:solidFill>
+            <a:srgbClr val="1428A0"/>
+          </a:solidFill>
+          <a:ln/>
+        </p:spPr>
+        <p:txBody>
+          <a:bodyPr wrap="square" lIns="0" tIns="0" rIns="0" bIns="0" rtlCol="0" anchor="ctr"/>
+          <a:lstStyle/>
+          <a:p>
+            <a:pPr algn="ctr" indent="0" marL="0">
+              <a:buNone/>
+            </a:pPr>
+            <a:r>
+              <a:rPr lang="en-US" sz="1400" b="1" dirty="0">
+                <a:solidFill>
+                  <a:srgbClr val="FFFFFF"/>
+                </a:solidFill>
+                <a:latin typeface="Malgun Gothic" pitchFamily="34" charset="0"/>
+                <a:ea typeface="Malgun Gothic" pitchFamily="34" charset="-122"/>
+                <a:cs typeface="Malgun Gothic" pitchFamily="34" charset="-120"/>
+              </a:rPr>
+              <a:t>3</a:t>
+            </a:r>
+            <a:endParaRPr lang="en-US" sz="1400" dirty="0"/>
+          </a:p>
+        </p:txBody>
+      </p:sp>
+      <p:sp>
+        <p:nvSpPr>
+          <p:cNvPr id="14" name="Text 12"/>
+          <p:cNvSpPr/>
+          <p:nvPr/>
+        </p:nvSpPr>
+        <p:spPr>
+          <a:xfrm>
+            <a:off x="8531352" y="1170432"/>
+            <a:ext cx="3200400" cy="347472"/>
+          </a:xfrm>
+          <a:prstGeom prst="rect">
+            <a:avLst/>
+          </a:prstGeom>
+          <a:noFill/>
+          <a:ln/>
+        </p:spPr>
+        <p:txBody>
+          <a:bodyPr wrap="square" lIns="0" tIns="0" rIns="0" bIns="0" rtlCol="0" anchor="ctr"/>
+          <a:lstStyle/>
+          <a:p>
+            <a:pPr indent="0" marL="0">
+              <a:buNone/>
+            </a:pPr>
+            <a:r>
+              <a:rPr lang="en-US" sz="1350" b="1" dirty="0">
+                <a:solidFill>
+                  <a:srgbClr val="1A1A1A"/>
+                </a:solidFill>
+                <a:latin typeface="Malgun Gothic" pitchFamily="34" charset="0"/>
+                <a:ea typeface="Malgun Gothic" pitchFamily="34" charset="-122"/>
+                <a:cs typeface="Malgun Gothic" pitchFamily="34" charset="-120"/>
+              </a:rPr>
+              <a:t>재배분, 그리고 반증</a:t>
+            </a:r>
+            <a:endParaRPr lang="en-US" sz="1350" dirty="0"/>
+          </a:p>
+        </p:txBody>
+      </p:sp>
+      <p:sp>
+        <p:nvSpPr>
+          <p:cNvPr id="15" name="Shape 13"/>
+          <p:cNvSpPr/>
+          <p:nvPr/>
+        </p:nvSpPr>
+        <p:spPr>
+          <a:xfrm>
+            <a:off x="8129016" y="1627632"/>
+            <a:ext cx="3602736" cy="4626864"/>
+          </a:xfrm>
+          <a:prstGeom prst="roundRect">
+            <a:avLst>
+              <a:gd name="adj" fmla="val 2030"/>
+            </a:avLst>
+          </a:prstGeom>
+          <a:solidFill>
+            <a:srgbClr val="FFFFFF"/>
+          </a:solidFill>
+          <a:ln w="12700">
+            <a:solidFill>
+              <a:srgbClr val="D9D9D9"/>
+            </a:solidFill>
+            <a:prstDash val="solid"/>
+          </a:ln>
+        </p:spPr>
+      </p:sp>
+      <p:sp>
+        <p:nvSpPr>
+          <p:cNvPr id="16" name="Shape 14"/>
+          <p:cNvSpPr/>
+          <p:nvPr/>
+        </p:nvSpPr>
+        <p:spPr>
+          <a:xfrm>
+            <a:off x="658368" y="2212848"/>
+            <a:ext cx="3200400" cy="0"/>
+          </a:xfrm>
+          <a:prstGeom prst="line">
+            <a:avLst/>
+          </a:prstGeom>
+          <a:noFill/>
+          <a:ln w="12700">
+            <a:solidFill>
+              <a:srgbClr val="555555"/>
+            </a:solidFill>
+            <a:prstDash val="solid"/>
+          </a:ln>
+        </p:spPr>
+      </p:sp>
+      <p:sp>
+        <p:nvSpPr>
+          <p:cNvPr id="17" name="Text 15"/>
+          <p:cNvSpPr/>
+          <p:nvPr/>
+        </p:nvSpPr>
+        <p:spPr>
+          <a:xfrm>
+            <a:off x="658368" y="1938528"/>
+            <a:ext cx="822960" cy="237744"/>
+          </a:xfrm>
+          <a:prstGeom prst="rect">
+            <a:avLst/>
+          </a:prstGeom>
+          <a:noFill/>
+          <a:ln/>
+        </p:spPr>
+        <p:txBody>
+          <a:bodyPr wrap="square" lIns="0" tIns="0" rIns="0" bIns="0" rtlCol="0" anchor="ctr"/>
+          <a:lstStyle/>
+          <a:p>
+            <a:pPr algn="ctr" indent="0" marL="0">
+              <a:buNone/>
+            </a:pPr>
+            <a:r>
+              <a:rPr lang="en-US" sz="1050" b="1" dirty="0">
+                <a:solidFill>
+                  <a:srgbClr val="1A1A1A"/>
+                </a:solidFill>
+                <a:latin typeface="Malgun Gothic" pitchFamily="34" charset="0"/>
+                <a:ea typeface="Malgun Gothic" pitchFamily="34" charset="-122"/>
+                <a:cs typeface="Malgun Gothic" pitchFamily="34" charset="-120"/>
+              </a:rPr>
+              <a:t>삼성</a:t>
+            </a:r>
+            <a:endParaRPr lang="en-US" sz="1050" dirty="0"/>
+          </a:p>
+        </p:txBody>
+      </p:sp>
+      <p:sp>
+        <p:nvSpPr>
+          <p:cNvPr id="18" name="Shape 16"/>
+          <p:cNvSpPr/>
+          <p:nvPr/>
+        </p:nvSpPr>
+        <p:spPr>
+          <a:xfrm>
+            <a:off x="786384" y="2212848"/>
+            <a:ext cx="548640" cy="1685109"/>
+          </a:xfrm>
+          <a:prstGeom prst="roundRect">
+            <a:avLst>
+              <a:gd name="adj" fmla="val 5000"/>
+            </a:avLst>
+          </a:prstGeom>
+          <a:solidFill>
+            <a:srgbClr val="1428A0"/>
+          </a:solidFill>
+          <a:ln/>
+        </p:spPr>
+      </p:sp>
+      <p:sp>
+        <p:nvSpPr>
+          <p:cNvPr id="19" name="Text 17"/>
+          <p:cNvSpPr/>
+          <p:nvPr/>
+        </p:nvSpPr>
+        <p:spPr>
+          <a:xfrm>
+            <a:off x="658368" y="3925389"/>
+            <a:ext cx="822960" cy="256032"/>
+          </a:xfrm>
+          <a:prstGeom prst="rect">
+            <a:avLst/>
+          </a:prstGeom>
+          <a:noFill/>
+          <a:ln/>
+        </p:spPr>
+        <p:txBody>
+          <a:bodyPr wrap="square" lIns="0" tIns="0" rIns="0" bIns="0" rtlCol="0" anchor="ctr"/>
+          <a:lstStyle/>
+          <a:p>
+            <a:pPr algn="ctr" indent="0" marL="0">
+              <a:buNone/>
+            </a:pPr>
+            <a:r>
+              <a:rPr lang="en-US" sz="1250" b="1" dirty="0">
+                <a:solidFill>
+                  <a:srgbClr val="1428A0"/>
+                </a:solidFill>
+                <a:latin typeface="Malgun Gothic" pitchFamily="34" charset="0"/>
+                <a:ea typeface="Malgun Gothic" pitchFamily="34" charset="-122"/>
+                <a:cs typeface="Malgun Gothic" pitchFamily="34" charset="-120"/>
+              </a:rPr>
+              <a:t>-54%</a:t>
+            </a:r>
+            <a:endParaRPr lang="en-US" sz="1250" dirty="0"/>
+          </a:p>
+        </p:txBody>
+      </p:sp>
+      <p:sp>
+        <p:nvSpPr>
+          <p:cNvPr id="20" name="Text 18"/>
+          <p:cNvSpPr/>
+          <p:nvPr/>
+        </p:nvSpPr>
+        <p:spPr>
+          <a:xfrm>
+            <a:off x="1435608" y="1938528"/>
+            <a:ext cx="822960" cy="237744"/>
+          </a:xfrm>
+          <a:prstGeom prst="rect">
+            <a:avLst/>
+          </a:prstGeom>
+          <a:noFill/>
+          <a:ln/>
+        </p:spPr>
+        <p:txBody>
+          <a:bodyPr wrap="square" lIns="0" tIns="0" rIns="0" bIns="0" rtlCol="0" anchor="ctr"/>
+          <a:lstStyle/>
+          <a:p>
+            <a:pPr algn="ctr" indent="0" marL="0">
+              <a:buNone/>
+            </a:pPr>
+            <a:r>
+              <a:rPr lang="en-US" sz="1050" b="1" dirty="0">
+                <a:solidFill>
+                  <a:srgbClr val="1A1A1A"/>
+                </a:solidFill>
+                <a:latin typeface="Malgun Gothic" pitchFamily="34" charset="0"/>
+                <a:ea typeface="Malgun Gothic" pitchFamily="34" charset="-122"/>
+                <a:cs typeface="Malgun Gothic" pitchFamily="34" charset="-120"/>
+              </a:rPr>
+              <a:t>SK그룹</a:t>
+            </a:r>
+            <a:endParaRPr lang="en-US" sz="1050" dirty="0"/>
+          </a:p>
+        </p:txBody>
+      </p:sp>
+      <p:sp>
+        <p:nvSpPr>
+          <p:cNvPr id="21" name="Shape 19"/>
+          <p:cNvSpPr/>
+          <p:nvPr/>
+        </p:nvSpPr>
+        <p:spPr>
+          <a:xfrm>
+            <a:off x="1563624" y="2212848"/>
+            <a:ext cx="548640" cy="1965960"/>
+          </a:xfrm>
+          <a:prstGeom prst="roundRect">
+            <a:avLst>
+              <a:gd name="adj" fmla="val 5000"/>
+            </a:avLst>
+          </a:prstGeom>
+          <a:solidFill>
+            <a:srgbClr val="B9C2D0"/>
+          </a:solidFill>
+          <a:ln/>
+        </p:spPr>
+      </p:sp>
+      <p:sp>
+        <p:nvSpPr>
+          <p:cNvPr id="22" name="Text 20"/>
+          <p:cNvSpPr/>
+          <p:nvPr/>
+        </p:nvSpPr>
+        <p:spPr>
+          <a:xfrm>
+            <a:off x="1435608" y="4206240"/>
+            <a:ext cx="822960" cy="256032"/>
+          </a:xfrm>
+          <a:prstGeom prst="rect">
+            <a:avLst/>
+          </a:prstGeom>
+          <a:noFill/>
+          <a:ln/>
+        </p:spPr>
+        <p:txBody>
+          <a:bodyPr wrap="square" lIns="0" tIns="0" rIns="0" bIns="0" rtlCol="0" anchor="ctr"/>
+          <a:lstStyle/>
+          <a:p>
+            <a:pPr algn="ctr" indent="0" marL="0">
+              <a:buNone/>
+            </a:pPr>
+            <a:r>
+              <a:rPr lang="en-US" sz="1250" b="1" dirty="0">
+                <a:solidFill>
+                  <a:srgbClr val="555555"/>
+                </a:solidFill>
+                <a:latin typeface="Malgun Gothic" pitchFamily="34" charset="0"/>
+                <a:ea typeface="Malgun Gothic" pitchFamily="34" charset="-122"/>
+                <a:cs typeface="Malgun Gothic" pitchFamily="34" charset="-120"/>
+              </a:rPr>
+              <a:t>-63%</a:t>
+            </a:r>
+            <a:endParaRPr lang="en-US" sz="1250" dirty="0"/>
+          </a:p>
+        </p:txBody>
+      </p:sp>
+      <p:sp>
+        <p:nvSpPr>
+          <p:cNvPr id="23" name="Text 21"/>
+          <p:cNvSpPr/>
+          <p:nvPr/>
+        </p:nvSpPr>
+        <p:spPr>
+          <a:xfrm>
+            <a:off x="2212848" y="1938528"/>
+            <a:ext cx="822960" cy="237744"/>
+          </a:xfrm>
+          <a:prstGeom prst="rect">
+            <a:avLst/>
+          </a:prstGeom>
+          <a:noFill/>
+          <a:ln/>
+        </p:spPr>
+        <p:txBody>
+          <a:bodyPr wrap="square" lIns="0" tIns="0" rIns="0" bIns="0" rtlCol="0" anchor="ctr"/>
+          <a:lstStyle/>
+          <a:p>
+            <a:pPr algn="ctr" indent="0" marL="0">
+              <a:buNone/>
+            </a:pPr>
+            <a:r>
+              <a:rPr lang="en-US" sz="1050" b="1" dirty="0">
+                <a:solidFill>
+                  <a:srgbClr val="1A1A1A"/>
+                </a:solidFill>
+                <a:latin typeface="Malgun Gothic" pitchFamily="34" charset="0"/>
+                <a:ea typeface="Malgun Gothic" pitchFamily="34" charset="-122"/>
+                <a:cs typeface="Malgun Gothic" pitchFamily="34" charset="-120"/>
+              </a:rPr>
+              <a:t>WDC</a:t>
+            </a:r>
+            <a:endParaRPr lang="en-US" sz="1050" dirty="0"/>
+          </a:p>
+        </p:txBody>
+      </p:sp>
+      <p:sp>
+        <p:nvSpPr>
+          <p:cNvPr id="24" name="Shape 22"/>
+          <p:cNvSpPr/>
+          <p:nvPr/>
+        </p:nvSpPr>
+        <p:spPr>
+          <a:xfrm>
+            <a:off x="2340864" y="2212848"/>
+            <a:ext cx="548640" cy="1404257"/>
+          </a:xfrm>
+          <a:prstGeom prst="roundRect">
+            <a:avLst>
+              <a:gd name="adj" fmla="val 5000"/>
+            </a:avLst>
+          </a:prstGeom>
+          <a:solidFill>
+            <a:srgbClr val="B9C2D0"/>
+          </a:solidFill>
+          <a:ln/>
+        </p:spPr>
+      </p:sp>
+      <p:sp>
+        <p:nvSpPr>
+          <p:cNvPr id="25" name="Text 23"/>
+          <p:cNvSpPr/>
+          <p:nvPr/>
+        </p:nvSpPr>
+        <p:spPr>
+          <a:xfrm>
+            <a:off x="2212848" y="3644537"/>
+            <a:ext cx="822960" cy="256032"/>
+          </a:xfrm>
+          <a:prstGeom prst="rect">
+            <a:avLst/>
+          </a:prstGeom>
+          <a:noFill/>
+          <a:ln/>
+        </p:spPr>
+        <p:txBody>
+          <a:bodyPr wrap="square" lIns="0" tIns="0" rIns="0" bIns="0" rtlCol="0" anchor="ctr"/>
+          <a:lstStyle/>
+          <a:p>
+            <a:pPr algn="ctr" indent="0" marL="0">
+              <a:buNone/>
+            </a:pPr>
+            <a:r>
+              <a:rPr lang="en-US" sz="1250" b="1" dirty="0">
+                <a:solidFill>
+                  <a:srgbClr val="555555"/>
+                </a:solidFill>
+                <a:latin typeface="Malgun Gothic" pitchFamily="34" charset="0"/>
+                <a:ea typeface="Malgun Gothic" pitchFamily="34" charset="-122"/>
+                <a:cs typeface="Malgun Gothic" pitchFamily="34" charset="-120"/>
+              </a:rPr>
+              <a:t>-45%</a:t>
+            </a:r>
+            <a:endParaRPr lang="en-US" sz="1250" dirty="0"/>
+          </a:p>
+        </p:txBody>
+      </p:sp>
+      <p:sp>
+        <p:nvSpPr>
+          <p:cNvPr id="26" name="Text 24"/>
+          <p:cNvSpPr/>
+          <p:nvPr/>
+        </p:nvSpPr>
+        <p:spPr>
+          <a:xfrm>
+            <a:off x="2990088" y="1938528"/>
+            <a:ext cx="822960" cy="237744"/>
+          </a:xfrm>
+          <a:prstGeom prst="rect">
+            <a:avLst/>
+          </a:prstGeom>
+          <a:noFill/>
+          <a:ln/>
+        </p:spPr>
+        <p:txBody>
+          <a:bodyPr wrap="square" lIns="0" tIns="0" rIns="0" bIns="0" rtlCol="0" anchor="ctr"/>
+          <a:lstStyle/>
+          <a:p>
+            <a:pPr algn="ctr" indent="0" marL="0">
+              <a:buNone/>
+            </a:pPr>
+            <a:r>
+              <a:rPr lang="en-US" sz="1050" b="1" dirty="0">
+                <a:solidFill>
+                  <a:srgbClr val="1A1A1A"/>
+                </a:solidFill>
+                <a:latin typeface="Malgun Gothic" pitchFamily="34" charset="0"/>
+                <a:ea typeface="Malgun Gothic" pitchFamily="34" charset="-122"/>
+                <a:cs typeface="Malgun Gothic" pitchFamily="34" charset="-120"/>
+              </a:rPr>
+              <a:t>Kioxia</a:t>
+            </a:r>
+            <a:endParaRPr lang="en-US" sz="1050" dirty="0"/>
+          </a:p>
+        </p:txBody>
+      </p:sp>
+      <p:sp>
+        <p:nvSpPr>
+          <p:cNvPr id="27" name="Shape 25"/>
+          <p:cNvSpPr/>
+          <p:nvPr/>
+        </p:nvSpPr>
+        <p:spPr>
+          <a:xfrm>
+            <a:off x="3118104" y="2212848"/>
+            <a:ext cx="548640" cy="1092200"/>
+          </a:xfrm>
+          <a:prstGeom prst="roundRect">
+            <a:avLst>
+              <a:gd name="adj" fmla="val 5000"/>
+            </a:avLst>
+          </a:prstGeom>
+          <a:solidFill>
+            <a:srgbClr val="B9C2D0"/>
+          </a:solidFill>
+          <a:ln/>
+        </p:spPr>
+      </p:sp>
+      <p:sp>
+        <p:nvSpPr>
+          <p:cNvPr id="28" name="Text 26"/>
+          <p:cNvSpPr/>
+          <p:nvPr/>
+        </p:nvSpPr>
+        <p:spPr>
+          <a:xfrm>
+            <a:off x="2990088" y="3332480"/>
+            <a:ext cx="822960" cy="256032"/>
+          </a:xfrm>
+          <a:prstGeom prst="rect">
+            <a:avLst/>
+          </a:prstGeom>
+          <a:noFill/>
+          <a:ln/>
+        </p:spPr>
+        <p:txBody>
+          <a:bodyPr wrap="square" lIns="0" tIns="0" rIns="0" bIns="0" rtlCol="0" anchor="ctr"/>
+          <a:lstStyle/>
+          <a:p>
+            <a:pPr algn="ctr" indent="0" marL="0">
+              <a:buNone/>
+            </a:pPr>
+            <a:r>
+              <a:rPr lang="en-US" sz="1250" b="1" dirty="0">
+                <a:solidFill>
+                  <a:srgbClr val="555555"/>
+                </a:solidFill>
+                <a:latin typeface="Malgun Gothic" pitchFamily="34" charset="0"/>
+                <a:ea typeface="Malgun Gothic" pitchFamily="34" charset="-122"/>
+                <a:cs typeface="Malgun Gothic" pitchFamily="34" charset="-120"/>
+              </a:rPr>
+              <a:t>-35%</a:t>
+            </a:r>
+            <a:endParaRPr lang="en-US" sz="1250" dirty="0"/>
+          </a:p>
+        </p:txBody>
+      </p:sp>
+      <p:sp>
+        <p:nvSpPr>
+          <p:cNvPr id="29" name="Text 27"/>
+          <p:cNvSpPr/>
+          <p:nvPr/>
+        </p:nvSpPr>
+        <p:spPr>
+          <a:xfrm>
+            <a:off x="658368" y="4864608"/>
+            <a:ext cx="3200400" cy="566928"/>
+          </a:xfrm>
+          <a:prstGeom prst="roundRect">
+            <a:avLst>
+              <a:gd name="adj" fmla="val 8065"/>
+            </a:avLst>
+          </a:prstGeom>
+          <a:solidFill>
+            <a:srgbClr val="F4F4F6"/>
+          </a:solidFill>
+          <a:ln/>
+        </p:spPr>
+        <p:txBody>
+          <a:bodyPr wrap="square" lIns="1016" tIns="1016" rIns="1016" bIns="1016" rtlCol="0" anchor="ctr"/>
+          <a:lstStyle/>
+          <a:p>
+            <a:pPr indent="0" marL="0">
+              <a:lnSpc>
+                <a:spcPct val="110000"/>
+              </a:lnSpc>
+              <a:buNone/>
+            </a:pPr>
+            <a:r>
+              <a:rPr lang="en-US" sz="1000" b="1" dirty="0">
+                <a:solidFill>
+                  <a:srgbClr val="1428A0"/>
+                </a:solidFill>
+                <a:latin typeface="Malgun Gothic" pitchFamily="34" charset="0"/>
+                <a:ea typeface="Malgun Gothic" pitchFamily="34" charset="-122"/>
+                <a:cs typeface="Malgun Gothic" pitchFamily="34" charset="-120"/>
+              </a:rPr>
+              <a:t>진앙은 SSD  </a:t>
+            </a:r>
+            <a:pPr indent="0" marL="0">
+              <a:lnSpc>
+                <a:spcPct val="110000"/>
+              </a:lnSpc>
+              <a:buNone/>
+            </a:pPr>
+            <a:r>
+              <a:rPr lang="en-US" sz="1000" dirty="0">
+                <a:solidFill>
+                  <a:srgbClr val="1A1A1A"/>
+                </a:solidFill>
+                <a:latin typeface="Malgun Gothic" pitchFamily="34" charset="0"/>
+                <a:ea typeface="Malgun Gothic" pitchFamily="34" charset="-122"/>
+                <a:cs typeface="Malgun Gothic" pitchFamily="34" charset="-120"/>
+              </a:rPr>
+              <a:t>산업 매출 중 SSD 기여 50%+ → 20~25% (4Q22→1Q23)</a:t>
+            </a:r>
+            <a:endParaRPr lang="en-US" sz="1000" dirty="0"/>
+          </a:p>
+        </p:txBody>
+      </p:sp>
+      <p:sp>
+        <p:nvSpPr>
+          <p:cNvPr id="30" name="Text 28"/>
+          <p:cNvSpPr/>
+          <p:nvPr/>
+        </p:nvSpPr>
+        <p:spPr>
+          <a:xfrm>
+            <a:off x="658368" y="5541264"/>
+            <a:ext cx="3200400" cy="365760"/>
+          </a:xfrm>
+          <a:prstGeom prst="rect">
+            <a:avLst/>
+          </a:prstGeom>
+          <a:noFill/>
+          <a:ln/>
+        </p:spPr>
+        <p:txBody>
+          <a:bodyPr wrap="square" lIns="0" tIns="0" rIns="0" bIns="0" rtlCol="0" anchor="ctr"/>
+          <a:lstStyle/>
+          <a:p>
+            <a:pPr indent="0" marL="0">
+              <a:lnSpc>
+                <a:spcPct val="110000"/>
+              </a:lnSpc>
+              <a:buNone/>
+            </a:pPr>
+            <a:r>
+              <a:rPr lang="en-US" sz="900" dirty="0">
+                <a:solidFill>
+                  <a:srgbClr val="555555"/>
+                </a:solidFill>
+                <a:latin typeface="Malgun Gothic" pitchFamily="34" charset="0"/>
+                <a:ea typeface="Malgun Gothic" pitchFamily="34" charset="-122"/>
+                <a:cs typeface="Malgun Gothic" pitchFamily="34" charset="-120"/>
+              </a:rPr>
+              <a:t>분기 매출 피크·저점 기준, TrendForce 분기 데이터 합성. Micron은 회계분기 차이로 제외</a:t>
+            </a:r>
+            <a:endParaRPr lang="en-US" sz="900" dirty="0"/>
+          </a:p>
+        </p:txBody>
+      </p:sp>
+      <p:sp>
+        <p:nvSpPr>
+          <p:cNvPr id="31" name="Text 29"/>
+          <p:cNvSpPr/>
+          <p:nvPr/>
+        </p:nvSpPr>
+        <p:spPr>
+          <a:xfrm>
+            <a:off x="4498848" y="1773936"/>
+            <a:ext cx="3200400" cy="256032"/>
+          </a:xfrm>
+          <a:prstGeom prst="rect">
+            <a:avLst/>
+          </a:prstGeom>
+          <a:noFill/>
+          <a:ln/>
+        </p:spPr>
+        <p:txBody>
+          <a:bodyPr wrap="square" lIns="0" tIns="0" rIns="0" bIns="0" rtlCol="0" anchor="ctr"/>
+          <a:lstStyle/>
+          <a:p>
+            <a:pPr indent="0" marL="0">
+              <a:buNone/>
+            </a:pPr>
+            <a:r>
+              <a:rPr lang="en-US" sz="1050" b="1" dirty="0">
+                <a:solidFill>
+                  <a:srgbClr val="1428A0"/>
+                </a:solidFill>
+                <a:latin typeface="Malgun Gothic" pitchFamily="34" charset="0"/>
+                <a:ea typeface="Malgun Gothic" pitchFamily="34" charset="-122"/>
+                <a:cs typeface="Malgun Gothic" pitchFamily="34" charset="-120"/>
+              </a:rPr>
+              <a:t>Enterprise SSD 매출 점유, 4Q22 (시장 $3.79B)</a:t>
+            </a:r>
+            <a:endParaRPr lang="en-US" sz="1050" dirty="0"/>
+          </a:p>
+        </p:txBody>
+      </p:sp>
+      <p:sp>
+        <p:nvSpPr>
+          <p:cNvPr id="32" name="Text 30"/>
+          <p:cNvSpPr/>
+          <p:nvPr/>
+        </p:nvSpPr>
+        <p:spPr>
+          <a:xfrm>
+            <a:off x="4498848" y="2157984"/>
+            <a:ext cx="868680" cy="274320"/>
+          </a:xfrm>
+          <a:prstGeom prst="rect">
+            <a:avLst/>
+          </a:prstGeom>
+          <a:noFill/>
+          <a:ln/>
+        </p:spPr>
+        <p:txBody>
+          <a:bodyPr wrap="square" lIns="0" tIns="0" rIns="0" bIns="0" rtlCol="0" anchor="ctr"/>
+          <a:lstStyle/>
+          <a:p>
+            <a:pPr indent="0" marL="0">
+              <a:buNone/>
+            </a:pPr>
+            <a:r>
+              <a:rPr lang="en-US" sz="1050" dirty="0">
+                <a:solidFill>
+                  <a:srgbClr val="1A1A1A"/>
+                </a:solidFill>
+                <a:latin typeface="Malgun Gothic" pitchFamily="34" charset="0"/>
+                <a:ea typeface="Malgun Gothic" pitchFamily="34" charset="-122"/>
+                <a:cs typeface="Malgun Gothic" pitchFamily="34" charset="-120"/>
+              </a:rPr>
+              <a:t>삼성</a:t>
+            </a:r>
+            <a:endParaRPr lang="en-US" sz="1050" dirty="0"/>
+          </a:p>
+        </p:txBody>
+      </p:sp>
+      <p:sp>
+        <p:nvSpPr>
+          <p:cNvPr id="33" name="Shape 31"/>
+          <p:cNvSpPr/>
+          <p:nvPr/>
+        </p:nvSpPr>
+        <p:spPr>
+          <a:xfrm>
+            <a:off x="5413248" y="2139696"/>
+            <a:ext cx="1828800" cy="292608"/>
+          </a:xfrm>
+          <a:prstGeom prst="roundRect">
+            <a:avLst>
+              <a:gd name="adj" fmla="val 9375"/>
+            </a:avLst>
+          </a:prstGeom>
+          <a:solidFill>
+            <a:srgbClr val="1428A0"/>
+          </a:solidFill>
+          <a:ln/>
+        </p:spPr>
+      </p:sp>
+      <p:sp>
+        <p:nvSpPr>
+          <p:cNvPr id="34" name="Text 32"/>
+          <p:cNvSpPr/>
+          <p:nvPr/>
+        </p:nvSpPr>
+        <p:spPr>
+          <a:xfrm>
+            <a:off x="7296912" y="2157984"/>
+            <a:ext cx="640080" cy="274320"/>
+          </a:xfrm>
+          <a:prstGeom prst="rect">
+            <a:avLst/>
+          </a:prstGeom>
+          <a:noFill/>
+          <a:ln/>
+        </p:spPr>
+        <p:txBody>
+          <a:bodyPr wrap="square" lIns="0" tIns="0" rIns="0" bIns="0" rtlCol="0" anchor="ctr"/>
+          <a:lstStyle/>
+          <a:p>
+            <a:pPr indent="0" marL="0">
+              <a:buNone/>
+            </a:pPr>
+            <a:r>
+              <a:rPr lang="en-US" sz="1100" b="1" dirty="0">
+                <a:solidFill>
+                  <a:srgbClr val="1428A0"/>
+                </a:solidFill>
+                <a:latin typeface="Malgun Gothic" pitchFamily="34" charset="0"/>
+                <a:ea typeface="Malgun Gothic" pitchFamily="34" charset="-122"/>
+                <a:cs typeface="Malgun Gothic" pitchFamily="34" charset="-120"/>
+              </a:rPr>
+              <a:t>46.9%</a:t>
+            </a:r>
+            <a:endParaRPr lang="en-US" sz="1100" dirty="0"/>
+          </a:p>
+        </p:txBody>
+      </p:sp>
+      <p:sp>
+        <p:nvSpPr>
+          <p:cNvPr id="35" name="Text 33"/>
+          <p:cNvSpPr/>
+          <p:nvPr/>
+        </p:nvSpPr>
+        <p:spPr>
+          <a:xfrm>
+            <a:off x="4498848" y="2651760"/>
+            <a:ext cx="868680" cy="274320"/>
+          </a:xfrm>
+          <a:prstGeom prst="rect">
+            <a:avLst/>
+          </a:prstGeom>
+          <a:noFill/>
+          <a:ln/>
+        </p:spPr>
+        <p:txBody>
+          <a:bodyPr wrap="square" lIns="0" tIns="0" rIns="0" bIns="0" rtlCol="0" anchor="ctr"/>
+          <a:lstStyle/>
+          <a:p>
+            <a:pPr indent="0" marL="0">
+              <a:buNone/>
+            </a:pPr>
+            <a:r>
+              <a:rPr lang="en-US" sz="1050" dirty="0">
+                <a:solidFill>
+                  <a:srgbClr val="1A1A1A"/>
+                </a:solidFill>
+                <a:latin typeface="Malgun Gothic" pitchFamily="34" charset="0"/>
+                <a:ea typeface="Malgun Gothic" pitchFamily="34" charset="-122"/>
+                <a:cs typeface="Malgun Gothic" pitchFamily="34" charset="-120"/>
+              </a:rPr>
+              <a:t>SK그룹</a:t>
+            </a:r>
+            <a:endParaRPr lang="en-US" sz="1050" dirty="0"/>
+          </a:p>
+        </p:txBody>
+      </p:sp>
+      <p:sp>
+        <p:nvSpPr>
+          <p:cNvPr id="36" name="Shape 34"/>
+          <p:cNvSpPr/>
+          <p:nvPr/>
+        </p:nvSpPr>
+        <p:spPr>
+          <a:xfrm>
+            <a:off x="5413248" y="2633472"/>
+            <a:ext cx="740878" cy="292608"/>
+          </a:xfrm>
+          <a:prstGeom prst="roundRect">
+            <a:avLst>
+              <a:gd name="adj" fmla="val 9375"/>
+            </a:avLst>
+          </a:prstGeom>
+          <a:solidFill>
+            <a:srgbClr val="B9C2D0"/>
+          </a:solidFill>
+          <a:ln/>
+        </p:spPr>
+      </p:sp>
+      <p:sp>
+        <p:nvSpPr>
+          <p:cNvPr id="37" name="Text 35"/>
+          <p:cNvSpPr/>
+          <p:nvPr/>
+        </p:nvSpPr>
+        <p:spPr>
+          <a:xfrm>
+            <a:off x="6208990" y="2651760"/>
+            <a:ext cx="640080" cy="274320"/>
+          </a:xfrm>
+          <a:prstGeom prst="rect">
+            <a:avLst/>
+          </a:prstGeom>
+          <a:noFill/>
+          <a:ln/>
+        </p:spPr>
+        <p:txBody>
+          <a:bodyPr wrap="square" lIns="0" tIns="0" rIns="0" bIns="0" rtlCol="0" anchor="ctr"/>
+          <a:lstStyle/>
+          <a:p>
+            <a:pPr indent="0" marL="0">
+              <a:buNone/>
+            </a:pPr>
+            <a:r>
+              <a:rPr lang="en-US" sz="1100" b="1" dirty="0">
+                <a:solidFill>
+                  <a:srgbClr val="555555"/>
+                </a:solidFill>
+                <a:latin typeface="Malgun Gothic" pitchFamily="34" charset="0"/>
+                <a:ea typeface="Malgun Gothic" pitchFamily="34" charset="-122"/>
+                <a:cs typeface="Malgun Gothic" pitchFamily="34" charset="-120"/>
+              </a:rPr>
+              <a:t>19%</a:t>
+            </a:r>
+            <a:endParaRPr lang="en-US" sz="1100" dirty="0"/>
+          </a:p>
+        </p:txBody>
+      </p:sp>
+      <p:sp>
+        <p:nvSpPr>
+          <p:cNvPr id="38" name="Text 36"/>
+          <p:cNvSpPr/>
+          <p:nvPr/>
+        </p:nvSpPr>
+        <p:spPr>
+          <a:xfrm>
+            <a:off x="4498848" y="3145536"/>
+            <a:ext cx="868680" cy="274320"/>
+          </a:xfrm>
+          <a:prstGeom prst="rect">
+            <a:avLst/>
+          </a:prstGeom>
+          <a:noFill/>
+          <a:ln/>
+        </p:spPr>
+        <p:txBody>
+          <a:bodyPr wrap="square" lIns="0" tIns="0" rIns="0" bIns="0" rtlCol="0" anchor="ctr"/>
+          <a:lstStyle/>
+          <a:p>
+            <a:pPr indent="0" marL="0">
+              <a:buNone/>
+            </a:pPr>
+            <a:r>
+              <a:rPr lang="en-US" sz="1050" dirty="0">
+                <a:solidFill>
+                  <a:srgbClr val="1A1A1A"/>
+                </a:solidFill>
+                <a:latin typeface="Malgun Gothic" pitchFamily="34" charset="0"/>
+                <a:ea typeface="Malgun Gothic" pitchFamily="34" charset="-122"/>
+                <a:cs typeface="Malgun Gothic" pitchFamily="34" charset="-120"/>
+              </a:rPr>
+              <a:t>Kioxia</a:t>
+            </a:r>
+            <a:endParaRPr lang="en-US" sz="1050" dirty="0"/>
+          </a:p>
+        </p:txBody>
+      </p:sp>
+      <p:sp>
+        <p:nvSpPr>
+          <p:cNvPr id="39" name="Shape 37"/>
+          <p:cNvSpPr/>
+          <p:nvPr/>
+        </p:nvSpPr>
+        <p:spPr>
+          <a:xfrm>
+            <a:off x="5413248" y="3127248"/>
+            <a:ext cx="506917" cy="292608"/>
+          </a:xfrm>
+          <a:prstGeom prst="roundRect">
+            <a:avLst>
+              <a:gd name="adj" fmla="val 9375"/>
+            </a:avLst>
+          </a:prstGeom>
+          <a:solidFill>
+            <a:srgbClr val="B9C2D0"/>
+          </a:solidFill>
+          <a:ln/>
+        </p:spPr>
+      </p:sp>
+      <p:sp>
+        <p:nvSpPr>
+          <p:cNvPr id="40" name="Text 38"/>
+          <p:cNvSpPr/>
+          <p:nvPr/>
+        </p:nvSpPr>
+        <p:spPr>
+          <a:xfrm>
+            <a:off x="5975029" y="3145536"/>
+            <a:ext cx="640080" cy="274320"/>
+          </a:xfrm>
+          <a:prstGeom prst="rect">
+            <a:avLst/>
+          </a:prstGeom>
+          <a:noFill/>
+          <a:ln/>
+        </p:spPr>
+        <p:txBody>
+          <a:bodyPr wrap="square" lIns="0" tIns="0" rIns="0" bIns="0" rtlCol="0" anchor="ctr"/>
+          <a:lstStyle/>
+          <a:p>
+            <a:pPr indent="0" marL="0">
+              <a:buNone/>
+            </a:pPr>
+            <a:r>
+              <a:rPr lang="en-US" sz="1100" b="1" dirty="0">
+                <a:solidFill>
+                  <a:srgbClr val="555555"/>
+                </a:solidFill>
+                <a:latin typeface="Malgun Gothic" pitchFamily="34" charset="0"/>
+                <a:ea typeface="Malgun Gothic" pitchFamily="34" charset="-122"/>
+                <a:cs typeface="Malgun Gothic" pitchFamily="34" charset="-120"/>
+              </a:rPr>
+              <a:t>13%</a:t>
+            </a:r>
+            <a:endParaRPr lang="en-US" sz="1100" dirty="0"/>
+          </a:p>
+        </p:txBody>
+      </p:sp>
+      <p:sp>
+        <p:nvSpPr>
+          <p:cNvPr id="41" name="Text 39"/>
+          <p:cNvSpPr/>
+          <p:nvPr/>
+        </p:nvSpPr>
+        <p:spPr>
+          <a:xfrm>
+            <a:off x="4498848" y="3749040"/>
+            <a:ext cx="3200400" cy="1371600"/>
+          </a:xfrm>
+          <a:prstGeom prst="rect">
+            <a:avLst/>
+          </a:prstGeom>
+          <a:noFill/>
+          <a:ln/>
+        </p:spPr>
+        <p:txBody>
+          <a:bodyPr wrap="square" lIns="0" tIns="0" rIns="0" bIns="0" rtlCol="0" anchor="t"/>
+          <a:lstStyle/>
+          <a:p>
+            <a:pPr indent="0" marL="0">
+              <a:lnSpc>
+                <a:spcPct val="120000"/>
+              </a:lnSpc>
+              <a:buNone/>
+            </a:pPr>
+            <a:r>
+              <a:rPr lang="en-US" sz="1050" dirty="0">
+                <a:solidFill>
+                  <a:srgbClr val="1A1A1A"/>
+                </a:solidFill>
+                <a:latin typeface="Malgun Gothic" pitchFamily="34" charset="0"/>
+                <a:ea typeface="Malgun Gothic" pitchFamily="34" charset="-122"/>
+                <a:cs typeface="Malgun Gothic" pitchFamily="34" charset="-120"/>
+              </a:rPr>
+              <a:t>노출 순위 = 낙폭 순위. 삼성은 enterprise SSD 1위로 하이퍼스케일러 노출 최대, SK그룹 -63%에는 서버 100%인 Solidigm 포함. 반면 Kioxia(모바일 중심)·WDC(리테일 중심)는 얕게 맞았다</a:t>
+            </a:r>
+            <a:endParaRPr lang="en-US" sz="1050" dirty="0"/>
+          </a:p>
+        </p:txBody>
+      </p:sp>
+      <p:sp>
+        <p:nvSpPr>
+          <p:cNvPr id="42" name="Text 40"/>
+          <p:cNvSpPr/>
+          <p:nvPr/>
+        </p:nvSpPr>
+        <p:spPr>
+          <a:xfrm>
+            <a:off x="4498848" y="5870448"/>
+            <a:ext cx="3200400" cy="274320"/>
+          </a:xfrm>
+          <a:prstGeom prst="rect">
+            <a:avLst/>
+          </a:prstGeom>
+          <a:noFill/>
+          <a:ln/>
+        </p:spPr>
+        <p:txBody>
+          <a:bodyPr wrap="square" lIns="0" tIns="0" rIns="0" bIns="0" rtlCol="0" anchor="ctr"/>
+          <a:lstStyle/>
+          <a:p>
+            <a:pPr indent="0" marL="0">
+              <a:buNone/>
+            </a:pPr>
+            <a:r>
+              <a:rPr lang="en-US" sz="900" dirty="0">
+                <a:solidFill>
+                  <a:srgbClr val="555555"/>
+                </a:solidFill>
+                <a:latin typeface="Malgun Gothic" pitchFamily="34" charset="0"/>
+                <a:ea typeface="Malgun Gothic" pitchFamily="34" charset="-122"/>
+                <a:cs typeface="Malgun Gothic" pitchFamily="34" charset="-120"/>
+              </a:rPr>
+              <a:t>출처: TrendForce enterprise SSD 4Q22 · Blocks &amp; Files</a:t>
+            </a:r>
+            <a:endParaRPr lang="en-US" sz="900" dirty="0"/>
+          </a:p>
+        </p:txBody>
+      </p:sp>
+      <p:sp>
+        <p:nvSpPr>
+          <p:cNvPr id="43" name="Text 41"/>
+          <p:cNvSpPr/>
+          <p:nvPr/>
+        </p:nvSpPr>
+        <p:spPr>
+          <a:xfrm>
+            <a:off x="8330184" y="1773936"/>
+            <a:ext cx="3200400" cy="256032"/>
+          </a:xfrm>
+          <a:prstGeom prst="rect">
+            <a:avLst/>
+          </a:prstGeom>
+          <a:noFill/>
+          <a:ln/>
+        </p:spPr>
+        <p:txBody>
+          <a:bodyPr wrap="square" lIns="0" tIns="0" rIns="0" bIns="0" rtlCol="0" anchor="ctr"/>
+          <a:lstStyle/>
+          <a:p>
+            <a:pPr indent="0" marL="0">
+              <a:buNone/>
+            </a:pPr>
+            <a:r>
+              <a:rPr lang="en-US" sz="1050" b="1" dirty="0">
+                <a:solidFill>
+                  <a:srgbClr val="1428A0"/>
+                </a:solidFill>
+                <a:latin typeface="Malgun Gothic" pitchFamily="34" charset="0"/>
+                <a:ea typeface="Malgun Gothic" pitchFamily="34" charset="-122"/>
+                <a:cs typeface="Malgun Gothic" pitchFamily="34" charset="-120"/>
+              </a:rPr>
+              <a:t>하이퍼스케일러 CapEx ($B, 각사 10-K)</a:t>
+            </a:r>
+            <a:endParaRPr lang="en-US" sz="1050" dirty="0"/>
+          </a:p>
+        </p:txBody>
+      </p:sp>
+      <p:sp>
+        <p:nvSpPr>
+          <p:cNvPr id="44" name="Shape 42"/>
+          <p:cNvSpPr/>
+          <p:nvPr/>
+        </p:nvSpPr>
+        <p:spPr>
+          <a:xfrm>
+            <a:off x="8330184" y="3346704"/>
+            <a:ext cx="3200400" cy="0"/>
+          </a:xfrm>
+          <a:prstGeom prst="line">
+            <a:avLst/>
+          </a:prstGeom>
+          <a:noFill/>
+          <a:ln w="12700">
+            <a:solidFill>
+              <a:srgbClr val="555555"/>
+            </a:solidFill>
+            <a:prstDash val="solid"/>
+          </a:ln>
+        </p:spPr>
+      </p:sp>
+      <p:sp>
+        <p:nvSpPr>
+          <p:cNvPr id="45" name="Shape 43"/>
+          <p:cNvSpPr/>
+          <p:nvPr/>
+        </p:nvSpPr>
+        <p:spPr>
+          <a:xfrm>
+            <a:off x="8476488" y="2211848"/>
+            <a:ext cx="256032" cy="1134856"/>
+          </a:xfrm>
+          <a:prstGeom prst="rect">
+            <a:avLst/>
+          </a:prstGeom>
+          <a:solidFill>
+            <a:srgbClr val="D6DCE8"/>
+          </a:solidFill>
+          <a:ln/>
+        </p:spPr>
+      </p:sp>
+      <p:sp>
+        <p:nvSpPr>
+          <p:cNvPr id="46" name="Shape 44"/>
+          <p:cNvSpPr/>
+          <p:nvPr/>
+        </p:nvSpPr>
+        <p:spPr>
+          <a:xfrm>
+            <a:off x="8769096" y="2165414"/>
+            <a:ext cx="256032" cy="1181291"/>
+          </a:xfrm>
+          <a:prstGeom prst="rect">
+            <a:avLst/>
+          </a:prstGeom>
+          <a:solidFill>
+            <a:srgbClr val="8FA0DC"/>
+          </a:solidFill>
+          <a:ln/>
+        </p:spPr>
+      </p:sp>
+      <p:sp>
+        <p:nvSpPr>
+          <p:cNvPr id="47" name="Shape 45"/>
+          <p:cNvSpPr/>
+          <p:nvPr/>
+        </p:nvSpPr>
+        <p:spPr>
+          <a:xfrm>
+            <a:off x="9061704" y="2367867"/>
+            <a:ext cx="256032" cy="978837"/>
+          </a:xfrm>
+          <a:prstGeom prst="rect">
+            <a:avLst/>
+          </a:prstGeom>
+          <a:solidFill>
+            <a:srgbClr val="1428A0"/>
+          </a:solidFill>
+          <a:ln/>
+        </p:spPr>
+      </p:sp>
+      <p:sp>
+        <p:nvSpPr>
+          <p:cNvPr id="48" name="Text 46"/>
+          <p:cNvSpPr/>
+          <p:nvPr/>
+        </p:nvSpPr>
+        <p:spPr>
+          <a:xfrm>
+            <a:off x="8339328" y="3383280"/>
+            <a:ext cx="1152144" cy="219456"/>
+          </a:xfrm>
+          <a:prstGeom prst="rect">
+            <a:avLst/>
+          </a:prstGeom>
+          <a:noFill/>
+          <a:ln/>
+        </p:spPr>
+        <p:txBody>
+          <a:bodyPr wrap="square" lIns="0" tIns="0" rIns="0" bIns="0" rtlCol="0" anchor="ctr"/>
+          <a:lstStyle/>
+          <a:p>
+            <a:pPr algn="ctr" indent="0" marL="0">
+              <a:buNone/>
+            </a:pPr>
+            <a:r>
+              <a:rPr lang="en-US" sz="950" dirty="0">
+                <a:solidFill>
+                  <a:srgbClr val="1A1A1A"/>
+                </a:solidFill>
+                <a:latin typeface="Malgun Gothic" pitchFamily="34" charset="0"/>
+                <a:ea typeface="Malgun Gothic" pitchFamily="34" charset="-122"/>
+                <a:cs typeface="Malgun Gothic" pitchFamily="34" charset="-120"/>
+              </a:rPr>
+              <a:t>Amazon</a:t>
+            </a:r>
+            <a:endParaRPr lang="en-US" sz="950" dirty="0"/>
+          </a:p>
+        </p:txBody>
+      </p:sp>
+      <p:sp>
+        <p:nvSpPr>
+          <p:cNvPr id="49" name="Shape 47"/>
+          <p:cNvSpPr/>
+          <p:nvPr/>
+        </p:nvSpPr>
+        <p:spPr>
+          <a:xfrm>
+            <a:off x="9518904" y="2990088"/>
+            <a:ext cx="256032" cy="356616"/>
+          </a:xfrm>
+          <a:prstGeom prst="rect">
+            <a:avLst/>
+          </a:prstGeom>
+          <a:solidFill>
+            <a:srgbClr val="D6DCE8"/>
+          </a:solidFill>
+          <a:ln/>
+        </p:spPr>
+      </p:sp>
+      <p:sp>
+        <p:nvSpPr>
+          <p:cNvPr id="50" name="Shape 48"/>
+          <p:cNvSpPr/>
+          <p:nvPr/>
+        </p:nvSpPr>
+        <p:spPr>
+          <a:xfrm>
+            <a:off x="9811512" y="2763488"/>
+            <a:ext cx="256032" cy="583216"/>
+          </a:xfrm>
+          <a:prstGeom prst="rect">
+            <a:avLst/>
+          </a:prstGeom>
+          <a:solidFill>
+            <a:srgbClr val="8FA0DC"/>
+          </a:solidFill>
+          <a:ln/>
+        </p:spPr>
+      </p:sp>
+      <p:sp>
+        <p:nvSpPr>
+          <p:cNvPr id="51" name="Shape 49"/>
+          <p:cNvSpPr/>
+          <p:nvPr/>
+        </p:nvSpPr>
+        <p:spPr>
+          <a:xfrm>
+            <a:off x="10104120" y="2824782"/>
+            <a:ext cx="256032" cy="521922"/>
+          </a:xfrm>
+          <a:prstGeom prst="rect">
+            <a:avLst/>
+          </a:prstGeom>
+          <a:solidFill>
+            <a:srgbClr val="1428A0"/>
+          </a:solidFill>
+          <a:ln/>
+        </p:spPr>
+      </p:sp>
+      <p:sp>
+        <p:nvSpPr>
+          <p:cNvPr id="52" name="Text 50"/>
+          <p:cNvSpPr/>
+          <p:nvPr/>
+        </p:nvSpPr>
+        <p:spPr>
+          <a:xfrm>
+            <a:off x="9381744" y="3383280"/>
+            <a:ext cx="1152144" cy="219456"/>
+          </a:xfrm>
+          <a:prstGeom prst="rect">
+            <a:avLst/>
+          </a:prstGeom>
+          <a:noFill/>
+          <a:ln/>
+        </p:spPr>
+        <p:txBody>
+          <a:bodyPr wrap="square" lIns="0" tIns="0" rIns="0" bIns="0" rtlCol="0" anchor="ctr"/>
+          <a:lstStyle/>
+          <a:p>
+            <a:pPr algn="ctr" indent="0" marL="0">
+              <a:buNone/>
+            </a:pPr>
+            <a:r>
+              <a:rPr lang="en-US" sz="950" dirty="0">
+                <a:solidFill>
+                  <a:srgbClr val="1A1A1A"/>
+                </a:solidFill>
+                <a:latin typeface="Malgun Gothic" pitchFamily="34" charset="0"/>
+                <a:ea typeface="Malgun Gothic" pitchFamily="34" charset="-122"/>
+                <a:cs typeface="Malgun Gothic" pitchFamily="34" charset="-120"/>
+              </a:rPr>
+              <a:t>Meta</a:t>
+            </a:r>
+            <a:endParaRPr lang="en-US" sz="950" dirty="0"/>
+          </a:p>
+        </p:txBody>
+      </p:sp>
+      <p:sp>
+        <p:nvSpPr>
+          <p:cNvPr id="53" name="Shape 51"/>
+          <p:cNvSpPr/>
+          <p:nvPr/>
+        </p:nvSpPr>
+        <p:spPr>
+          <a:xfrm>
+            <a:off x="10561320" y="2889790"/>
+            <a:ext cx="256032" cy="456914"/>
+          </a:xfrm>
+          <a:prstGeom prst="rect">
+            <a:avLst/>
+          </a:prstGeom>
+          <a:solidFill>
+            <a:srgbClr val="D6DCE8"/>
+          </a:solidFill>
+          <a:ln/>
+        </p:spPr>
+      </p:sp>
+      <p:sp>
+        <p:nvSpPr>
+          <p:cNvPr id="54" name="Shape 52"/>
+          <p:cNvSpPr/>
+          <p:nvPr/>
+        </p:nvSpPr>
+        <p:spPr>
+          <a:xfrm>
+            <a:off x="10853928" y="2761631"/>
+            <a:ext cx="256032" cy="585073"/>
+          </a:xfrm>
+          <a:prstGeom prst="rect">
+            <a:avLst/>
+          </a:prstGeom>
+          <a:solidFill>
+            <a:srgbClr val="8FA0DC"/>
+          </a:solidFill>
+          <a:ln/>
+        </p:spPr>
+      </p:sp>
+      <p:sp>
+        <p:nvSpPr>
+          <p:cNvPr id="55" name="Shape 53"/>
+          <p:cNvSpPr/>
+          <p:nvPr/>
+        </p:nvSpPr>
+        <p:spPr>
+          <a:xfrm>
+            <a:off x="11146536" y="2746772"/>
+            <a:ext cx="256032" cy="599932"/>
+          </a:xfrm>
+          <a:prstGeom prst="rect">
+            <a:avLst/>
+          </a:prstGeom>
+          <a:solidFill>
+            <a:srgbClr val="1428A0"/>
+          </a:solidFill>
+          <a:ln/>
+        </p:spPr>
+      </p:sp>
+      <p:sp>
+        <p:nvSpPr>
+          <p:cNvPr id="56" name="Text 54"/>
+          <p:cNvSpPr/>
+          <p:nvPr/>
+        </p:nvSpPr>
+        <p:spPr>
+          <a:xfrm>
+            <a:off x="10424160" y="3383280"/>
+            <a:ext cx="1152144" cy="219456"/>
+          </a:xfrm>
+          <a:prstGeom prst="rect">
+            <a:avLst/>
+          </a:prstGeom>
+          <a:noFill/>
+          <a:ln/>
+        </p:spPr>
+        <p:txBody>
+          <a:bodyPr wrap="square" lIns="0" tIns="0" rIns="0" bIns="0" rtlCol="0" anchor="ctr"/>
+          <a:lstStyle/>
+          <a:p>
+            <a:pPr algn="ctr" indent="0" marL="0">
+              <a:buNone/>
+            </a:pPr>
+            <a:r>
+              <a:rPr lang="en-US" sz="950" dirty="0">
+                <a:solidFill>
+                  <a:srgbClr val="1A1A1A"/>
+                </a:solidFill>
+                <a:latin typeface="Malgun Gothic" pitchFamily="34" charset="0"/>
+                <a:ea typeface="Malgun Gothic" pitchFamily="34" charset="-122"/>
+                <a:cs typeface="Malgun Gothic" pitchFamily="34" charset="-120"/>
+              </a:rPr>
+              <a:t>Alphabet</a:t>
+            </a:r>
+            <a:endParaRPr lang="en-US" sz="950" dirty="0"/>
+          </a:p>
+        </p:txBody>
+      </p:sp>
+      <p:sp>
+        <p:nvSpPr>
+          <p:cNvPr id="57" name="Text 55"/>
+          <p:cNvSpPr/>
+          <p:nvPr/>
+        </p:nvSpPr>
+        <p:spPr>
+          <a:xfrm>
+            <a:off x="8330184" y="3675888"/>
+            <a:ext cx="3200400" cy="713232"/>
+          </a:xfrm>
+          <a:prstGeom prst="rect">
+            <a:avLst/>
+          </a:prstGeom>
+          <a:noFill/>
+          <a:ln/>
+        </p:spPr>
+        <p:txBody>
+          <a:bodyPr wrap="square" lIns="0" tIns="0" rIns="0" bIns="0" rtlCol="0" anchor="t"/>
+          <a:lstStyle/>
+          <a:p>
+            <a:pPr indent="0" marL="0">
+              <a:lnSpc>
+                <a:spcPct val="115000"/>
+              </a:lnSpc>
+              <a:buNone/>
+            </a:pPr>
+            <a:r>
+              <a:rPr lang="en-US" sz="950" dirty="0">
+                <a:solidFill>
+                  <a:srgbClr val="555555"/>
+                </a:solidFill>
+                <a:latin typeface="Malgun Gothic" pitchFamily="34" charset="0"/>
+                <a:ea typeface="Malgun Gothic" pitchFamily="34" charset="-122"/>
+                <a:cs typeface="Malgun Gothic" pitchFamily="34" charset="-120"/>
+              </a:rPr>
+              <a:t>’21  ’22  ’23  ·  Amazon 창사 최초 감소(-17%), Meta -11%. 반면 AI 서버는 ’23 ~$50B로 서버 시장 가치의 ~23%: 총량이 아니라 재배분</a:t>
+            </a:r>
+            <a:endParaRPr lang="en-US" sz="950" dirty="0"/>
+          </a:p>
+        </p:txBody>
+      </p:sp>
+      <p:sp>
+        <p:nvSpPr>
+          <p:cNvPr id="58" name="Shape 56"/>
+          <p:cNvSpPr/>
+          <p:nvPr/>
+        </p:nvSpPr>
+        <p:spPr>
+          <a:xfrm>
+            <a:off x="8311896" y="4498848"/>
+            <a:ext cx="3236976" cy="1536192"/>
+          </a:xfrm>
+          <a:prstGeom prst="roundRect">
+            <a:avLst>
+              <a:gd name="adj" fmla="val 4167"/>
+            </a:avLst>
+          </a:prstGeom>
+          <a:solidFill>
+            <a:srgbClr val="EEF1FA"/>
+          </a:solidFill>
+          <a:ln w="15875">
+            <a:solidFill>
+              <a:srgbClr val="1428A0"/>
+            </a:solidFill>
+            <a:prstDash val="solid"/>
+          </a:ln>
+        </p:spPr>
+      </p:sp>
+      <p:sp>
+        <p:nvSpPr>
+          <p:cNvPr id="59" name="Text 57"/>
+          <p:cNvSpPr/>
+          <p:nvPr/>
+        </p:nvSpPr>
+        <p:spPr>
+          <a:xfrm>
+            <a:off x="8476488" y="4590288"/>
+            <a:ext cx="2926080" cy="1371600"/>
+          </a:xfrm>
+          <a:prstGeom prst="rect">
+            <a:avLst/>
+          </a:prstGeom>
+          <a:noFill/>
+          <a:ln/>
+        </p:spPr>
+        <p:txBody>
+          <a:bodyPr wrap="square" lIns="0" tIns="0" rIns="0" bIns="0" rtlCol="0" anchor="t"/>
+          <a:lstStyle/>
+          <a:p>
+            <a:pPr indent="0" marL="0">
+              <a:lnSpc>
+                <a:spcPct val="115000"/>
+              </a:lnSpc>
+              <a:buNone/>
+            </a:pPr>
+            <a:r>
+              <a:rPr lang="en-US" sz="1150" b="1" dirty="0">
+                <a:solidFill>
+                  <a:srgbClr val="1428A0"/>
+                </a:solidFill>
+                <a:latin typeface="Malgun Gothic" pitchFamily="34" charset="0"/>
+                <a:ea typeface="Malgun Gothic" pitchFamily="34" charset="-122"/>
+                <a:cs typeface="Malgun Gothic" pitchFamily="34" charset="-120"/>
+              </a:rPr>
+              <a:t>반증: Solidigm</a:t>
+            </a:r>
+            <a:endParaRPr lang="en-US" sz="1150" dirty="0"/>
+          </a:p>
+          <a:p>
+            <a:pPr indent="0" marL="0">
+              <a:lnSpc>
+                <a:spcPct val="115000"/>
+              </a:lnSpc>
+              <a:buNone/>
+            </a:pPr>
+            <a:r>
+              <a:rPr lang="en-US" sz="1000" dirty="0">
+                <a:solidFill>
+                  <a:srgbClr val="1A1A1A"/>
+                </a:solidFill>
+                <a:latin typeface="Malgun Gothic" pitchFamily="34" charset="0"/>
+                <a:ea typeface="Malgun Gothic" pitchFamily="34" charset="-122"/>
+                <a:cs typeface="Malgun Gothic" pitchFamily="34" charset="-120"/>
+              </a:rPr>
+              <a:t>낙폭 최심부(SK그룹)에서 ’23.07 61.44TB QLC 출시로 AI 스토리지 수요 적중, ’24 흑자 전환. 다변화(방어)가 아니라 니즈 적중(공격)이 다운턴을 이긴다</a:t>
+            </a:r>
+            <a:endParaRPr lang="en-US" sz="1150" dirty="0"/>
+          </a:p>
+        </p:txBody>
+      </p:sp>
+      <p:sp>
+        <p:nvSpPr>
+          <p:cNvPr id="60" name="Text 58"/>
+          <p:cNvSpPr/>
+          <p:nvPr/>
+        </p:nvSpPr>
+        <p:spPr>
+          <a:xfrm>
+            <a:off x="8330184" y="6053328"/>
+            <a:ext cx="3200400" cy="201168"/>
+          </a:xfrm>
+          <a:prstGeom prst="rect">
+            <a:avLst/>
+          </a:prstGeom>
+          <a:noFill/>
+          <a:ln/>
+        </p:spPr>
+        <p:txBody>
+          <a:bodyPr wrap="square" lIns="0" tIns="0" rIns="0" bIns="0" rtlCol="0" anchor="ctr"/>
+          <a:lstStyle/>
+          <a:p>
+            <a:pPr indent="0" marL="0">
+              <a:buNone/>
+            </a:pPr>
+            <a:r>
+              <a:rPr lang="en-US" sz="900" dirty="0">
+                <a:solidFill>
+                  <a:srgbClr val="555555"/>
+                </a:solidFill>
+                <a:latin typeface="Malgun Gothic" pitchFamily="34" charset="0"/>
+                <a:ea typeface="Malgun Gothic" pitchFamily="34" charset="-122"/>
+                <a:cs typeface="Malgun Gothic" pitchFamily="34" charset="-120"/>
+              </a:rPr>
+              <a:t>출처: 각사 10-K · Platformonomics · TrendForce</a:t>
+            </a:r>
+            <a:endParaRPr lang="en-US" sz="900" dirty="0"/>
+          </a:p>
+        </p:txBody>
+      </p:sp>
+    </p:spTree>
+  </p:cSld>
+  <p:clrMapOvr>
+    <a:masterClrMapping/>
+  </p:clrMapOvr>
+</p:sld>
+</file>
+
+<file path=ppt/slides/slide2.xml><?xml version="1.0" encoding="utf-8"?>
+<p:sld xmlns:a="http://schemas.openxmlformats.org/drawingml/2006/main" xmlns:r="http://schemas.openxmlformats.org/officeDocument/2006/relationships" xmlns:p="http://schemas.openxmlformats.org/presentationml/2006/main">
+  <p:cSld name="Slide 2">
+    <p:spTree>
+      <p:nvGrpSpPr>
+        <p:cNvPr id="1" name=""/>
+        <p:cNvGrpSpPr/>
+        <p:nvPr/>
+      </p:nvGrpSpPr>
+      <p:grpSpPr>
+        <a:xfrm>
+          <a:off x="0" y="0"/>
+          <a:ext cx="0" cy="0"/>
+          <a:chOff x="0" y="0"/>
+          <a:chExt cx="0" cy="0"/>
+        </a:xfrm>
+      </p:grpSpPr>
+      <p:sp>
+        <p:nvSpPr>
+          <p:cNvPr id="2" name="Text 0"/>
+          <p:cNvSpPr/>
+          <p:nvPr/>
+        </p:nvSpPr>
+        <p:spPr>
+          <a:xfrm>
+            <a:off x="457200" y="237744"/>
+            <a:ext cx="9765792" cy="566928"/>
+          </a:xfrm>
+          <a:prstGeom prst="rect">
+            <a:avLst/>
+          </a:prstGeom>
+          <a:noFill/>
+          <a:ln/>
+        </p:spPr>
+        <p:txBody>
+          <a:bodyPr wrap="square" lIns="0" tIns="0" rIns="0" bIns="0" rtlCol="0" anchor="ctr"/>
+          <a:lstStyle/>
+          <a:p>
+            <a:pPr indent="0" marL="0">
+              <a:buNone/>
+            </a:pPr>
+            <a:r>
+              <a:rPr lang="en-US" sz="3200" b="1" dirty="0">
+                <a:solidFill>
+                  <a:srgbClr val="17313B"/>
+                </a:solidFill>
+                <a:latin typeface="Malgun Gothic" pitchFamily="34" charset="0"/>
+                <a:ea typeface="Malgun Gothic" pitchFamily="34" charset="-122"/>
+                <a:cs typeface="Malgun Gothic" pitchFamily="34" charset="-120"/>
+              </a:rPr>
+              <a:t>KV Cache: 요구 내구성은 현 제품의 2~10배</a:t>
+            </a:r>
+            <a:endParaRPr lang="en-US" sz="3200" dirty="0"/>
+          </a:p>
+        </p:txBody>
+      </p:sp>
+      <p:sp>
+        <p:nvSpPr>
+          <p:cNvPr id="3" name="Text 1"/>
+          <p:cNvSpPr/>
+          <p:nvPr/>
+        </p:nvSpPr>
+        <p:spPr>
+          <a:xfrm>
+            <a:off x="10268712" y="310896"/>
+            <a:ext cx="1463040" cy="420624"/>
+          </a:xfrm>
+          <a:prstGeom prst="roundRect">
+            <a:avLst>
+              <a:gd name="adj" fmla="val 21739"/>
+            </a:avLst>
+          </a:prstGeom>
+          <a:solidFill>
+            <a:srgbClr val="EFF3F5"/>
+          </a:solidFill>
+          <a:ln/>
+        </p:spPr>
+        <p:txBody>
+          <a:bodyPr wrap="square" lIns="0" tIns="0" rIns="0" bIns="0" rtlCol="0" anchor="ctr"/>
+          <a:lstStyle/>
+          <a:p>
+            <a:pPr algn="ctr" indent="0" marL="0">
+              <a:buNone/>
+            </a:pPr>
+            <a:r>
+              <a:rPr lang="en-US" sz="1400" b="1" dirty="0">
+                <a:solidFill>
+                  <a:srgbClr val="5A7184"/>
+                </a:solidFill>
+                <a:latin typeface="Malgun Gothic" pitchFamily="34" charset="0"/>
+                <a:ea typeface="Malgun Gothic" pitchFamily="34" charset="-122"/>
+                <a:cs typeface="Malgun Gothic" pitchFamily="34" charset="-120"/>
+              </a:rPr>
+              <a:t>배경 ②</a:t>
+            </a:r>
+            <a:endParaRPr lang="en-US" sz="1400" dirty="0"/>
+          </a:p>
+        </p:txBody>
+      </p:sp>
+      <p:sp>
+        <p:nvSpPr>
+          <p:cNvPr id="4" name="Text 2"/>
+          <p:cNvSpPr/>
+          <p:nvPr/>
+        </p:nvSpPr>
+        <p:spPr>
+          <a:xfrm>
+            <a:off x="457200" y="6510528"/>
+            <a:ext cx="6949440" cy="256032"/>
+          </a:xfrm>
+          <a:prstGeom prst="rect">
+            <a:avLst/>
+          </a:prstGeom>
+          <a:noFill/>
+          <a:ln/>
+        </p:spPr>
+        <p:txBody>
+          <a:bodyPr wrap="square" lIns="0" tIns="0" rIns="0" bIns="0" rtlCol="0" anchor="ctr"/>
+          <a:lstStyle/>
+          <a:p>
+            <a:pPr indent="0" marL="0">
+              <a:buNone/>
+            </a:pPr>
+            <a:r>
+              <a:rPr lang="en-US" sz="1000" dirty="0">
+                <a:solidFill>
+                  <a:srgbClr val="5A7184"/>
+                </a:solidFill>
+                <a:latin typeface="Malgun Gothic" pitchFamily="34" charset="0"/>
+                <a:ea typeface="Malgun Gothic" pitchFamily="34" charset="-122"/>
+                <a:cs typeface="Malgun Gothic" pitchFamily="34" charset="-120"/>
+              </a:rPr>
+              <a:t>삼성전자 메모리사업부 · 개발실 체질 전환 전략 요약 · 2026-07-24</a:t>
+            </a:r>
+            <a:endParaRPr lang="en-US" sz="1000" dirty="0"/>
+          </a:p>
+        </p:txBody>
+      </p:sp>
+      <p:sp>
+        <p:nvSpPr>
+          <p:cNvPr id="5" name="Text 3"/>
+          <p:cNvSpPr/>
+          <p:nvPr/>
+        </p:nvSpPr>
+        <p:spPr>
+          <a:xfrm>
+            <a:off x="7589520" y="6510528"/>
+            <a:ext cx="4142232" cy="256032"/>
+          </a:xfrm>
+          <a:prstGeom prst="rect">
+            <a:avLst/>
+          </a:prstGeom>
+          <a:noFill/>
+          <a:ln/>
+        </p:spPr>
+        <p:txBody>
+          <a:bodyPr wrap="square" lIns="0" tIns="0" rIns="0" bIns="0" rtlCol="0" anchor="ctr"/>
+          <a:lstStyle/>
+          <a:p>
+            <a:pPr algn="r" indent="0" marL="0">
+              <a:buNone/>
+            </a:pPr>
+            <a:r>
+              <a:rPr lang="en-US" sz="1000" dirty="0">
+                <a:solidFill>
+                  <a:srgbClr val="5A7184"/>
+                </a:solidFill>
+                <a:latin typeface="Malgun Gothic" pitchFamily="34" charset="0"/>
+                <a:ea typeface="Malgun Gothic" pitchFamily="34" charset="-122"/>
+                <a:cs typeface="Malgun Gothic" pitchFamily="34" charset="-120"/>
+              </a:rPr>
+              <a:t>원천: wiki/strategies/fdp-host-ssd-platform.md</a:t>
+            </a:r>
+            <a:endParaRPr lang="en-US" sz="1000" dirty="0"/>
+          </a:p>
+        </p:txBody>
+      </p:sp>
+      <p:sp>
+        <p:nvSpPr>
+          <p:cNvPr id="6" name="Text 4"/>
+          <p:cNvSpPr/>
+          <p:nvPr/>
+        </p:nvSpPr>
+        <p:spPr>
+          <a:xfrm>
+            <a:off x="457200" y="822960"/>
+            <a:ext cx="11274552" cy="274320"/>
+          </a:xfrm>
+          <a:prstGeom prst="rect">
+            <a:avLst/>
+          </a:prstGeom>
+          <a:noFill/>
+          <a:ln/>
+        </p:spPr>
+        <p:txBody>
+          <a:bodyPr wrap="square" lIns="0" tIns="0" rIns="0" bIns="0" rtlCol="0" anchor="ctr"/>
+          <a:lstStyle/>
+          <a:p>
+            <a:pPr indent="0" marL="0">
+              <a:buNone/>
+            </a:pPr>
+            <a:r>
+              <a:rPr lang="en-US" sz="1300" b="1" dirty="0">
+                <a:solidFill>
+                  <a:srgbClr val="1428A0"/>
+                </a:solidFill>
+                <a:latin typeface="Malgun Gothic" pitchFamily="34" charset="0"/>
+                <a:ea typeface="Malgun Gothic" pitchFamily="34" charset="-122"/>
+                <a:cs typeface="Malgun Gothic" pitchFamily="34" charset="-120"/>
+              </a:rPr>
+              <a:t>니즈  </a:t>
+            </a:r>
+            <a:pPr indent="0" marL="0">
+              <a:buNone/>
+            </a:pPr>
+            <a:r>
+              <a:rPr lang="en-US" sz="1300" dirty="0">
+                <a:solidFill>
+                  <a:srgbClr val="555555"/>
+                </a:solidFill>
+                <a:latin typeface="Malgun Gothic" pitchFamily="34" charset="0"/>
+                <a:ea typeface="Malgun Gothic" pitchFamily="34" charset="-122"/>
+                <a:cs typeface="Malgun Gothic" pitchFamily="34" charset="-120"/>
+              </a:rPr>
+              <a:t>스토리지가 추론의 캐시 계층으로 승격된다: 수요는 폭증하고, 쓰기 내구성 요구는 현행 TLC·QLC 제품군을 넘는다</a:t>
+            </a:r>
+            <a:endParaRPr lang="en-US" sz="1300" dirty="0"/>
+          </a:p>
+        </p:txBody>
+      </p:sp>
+      <p:sp>
+        <p:nvSpPr>
+          <p:cNvPr id="7" name="Text 5"/>
+          <p:cNvSpPr/>
+          <p:nvPr/>
+        </p:nvSpPr>
+        <p:spPr>
+          <a:xfrm>
+            <a:off x="457200" y="1188720"/>
+            <a:ext cx="310896" cy="310896"/>
+          </a:xfrm>
+          <a:prstGeom prst="ellipse">
+            <a:avLst/>
+          </a:prstGeom>
+          <a:solidFill>
+            <a:srgbClr val="1428A0"/>
+          </a:solidFill>
+          <a:ln/>
+        </p:spPr>
+        <p:txBody>
+          <a:bodyPr wrap="square" lIns="0" tIns="0" rIns="0" bIns="0" rtlCol="0" anchor="ctr"/>
+          <a:lstStyle/>
+          <a:p>
+            <a:pPr algn="ctr" indent="0" marL="0">
+              <a:buNone/>
+            </a:pPr>
+            <a:r>
+              <a:rPr lang="en-US" sz="1400" b="1" dirty="0">
+                <a:solidFill>
+                  <a:srgbClr val="FFFFFF"/>
+                </a:solidFill>
+                <a:latin typeface="Malgun Gothic" pitchFamily="34" charset="0"/>
+                <a:ea typeface="Malgun Gothic" pitchFamily="34" charset="-122"/>
+                <a:cs typeface="Malgun Gothic" pitchFamily="34" charset="-120"/>
+              </a:rPr>
+              <a:t>1</a:t>
+            </a:r>
+            <a:endParaRPr lang="en-US" sz="1400" dirty="0"/>
+          </a:p>
+        </p:txBody>
+      </p:sp>
+      <p:sp>
+        <p:nvSpPr>
+          <p:cNvPr id="8" name="Text 6"/>
+          <p:cNvSpPr/>
+          <p:nvPr/>
+        </p:nvSpPr>
+        <p:spPr>
+          <a:xfrm>
+            <a:off x="859536" y="1170432"/>
+            <a:ext cx="3200400" cy="347472"/>
+          </a:xfrm>
+          <a:prstGeom prst="rect">
+            <a:avLst/>
+          </a:prstGeom>
+          <a:noFill/>
+          <a:ln/>
+        </p:spPr>
+        <p:txBody>
+          <a:bodyPr wrap="square" lIns="0" tIns="0" rIns="0" bIns="0" rtlCol="0" anchor="ctr"/>
+          <a:lstStyle/>
+          <a:p>
+            <a:pPr indent="0" marL="0">
+              <a:buNone/>
+            </a:pPr>
+            <a:r>
+              <a:rPr lang="en-US" sz="1350" b="1" dirty="0">
+                <a:solidFill>
+                  <a:srgbClr val="1A1A1A"/>
+                </a:solidFill>
+                <a:latin typeface="Malgun Gothic" pitchFamily="34" charset="0"/>
+                <a:ea typeface="Malgun Gothic" pitchFamily="34" charset="-122"/>
+                <a:cs typeface="Malgun Gothic" pitchFamily="34" charset="-120"/>
+              </a:rPr>
+              <a:t>신규 수요: KV Cache Offloading</a:t>
+            </a:r>
+            <a:endParaRPr lang="en-US" sz="1350" dirty="0"/>
+          </a:p>
+        </p:txBody>
+      </p:sp>
+      <p:sp>
+        <p:nvSpPr>
+          <p:cNvPr id="9" name="Shape 7"/>
+          <p:cNvSpPr/>
+          <p:nvPr/>
+        </p:nvSpPr>
+        <p:spPr>
+          <a:xfrm>
+            <a:off x="457200" y="1627632"/>
+            <a:ext cx="3602736" cy="4626864"/>
+          </a:xfrm>
+          <a:prstGeom prst="roundRect">
+            <a:avLst>
+              <a:gd name="adj" fmla="val 2030"/>
+            </a:avLst>
+          </a:prstGeom>
+          <a:solidFill>
+            <a:srgbClr val="FFFFFF"/>
+          </a:solidFill>
+          <a:ln w="12700">
+            <a:solidFill>
+              <a:srgbClr val="D9D9D9"/>
+            </a:solidFill>
+            <a:prstDash val="solid"/>
+          </a:ln>
+        </p:spPr>
+      </p:sp>
+      <p:sp>
+        <p:nvSpPr>
+          <p:cNvPr id="10" name="Text 8"/>
+          <p:cNvSpPr/>
+          <p:nvPr/>
+        </p:nvSpPr>
+        <p:spPr>
+          <a:xfrm>
+            <a:off x="4297680" y="1188720"/>
+            <a:ext cx="310896" cy="310896"/>
+          </a:xfrm>
+          <a:prstGeom prst="ellipse">
+            <a:avLst/>
+          </a:prstGeom>
+          <a:solidFill>
+            <a:srgbClr val="1428A0"/>
+          </a:solidFill>
+          <a:ln/>
+        </p:spPr>
+        <p:txBody>
+          <a:bodyPr wrap="square" lIns="0" tIns="0" rIns="0" bIns="0" rtlCol="0" anchor="ctr"/>
+          <a:lstStyle/>
+          <a:p>
+            <a:pPr algn="ctr" indent="0" marL="0">
+              <a:buNone/>
+            </a:pPr>
+            <a:r>
+              <a:rPr lang="en-US" sz="1400" b="1" dirty="0">
+                <a:solidFill>
+                  <a:srgbClr val="FFFFFF"/>
+                </a:solidFill>
+                <a:latin typeface="Malgun Gothic" pitchFamily="34" charset="0"/>
+                <a:ea typeface="Malgun Gothic" pitchFamily="34" charset="-122"/>
+                <a:cs typeface="Malgun Gothic" pitchFamily="34" charset="-120"/>
+              </a:rPr>
+              <a:t>2</a:t>
+            </a:r>
+            <a:endParaRPr lang="en-US" sz="1400" dirty="0"/>
+          </a:p>
+        </p:txBody>
+      </p:sp>
+      <p:sp>
+        <p:nvSpPr>
+          <p:cNvPr id="11" name="Text 9"/>
+          <p:cNvSpPr/>
+          <p:nvPr/>
+        </p:nvSpPr>
+        <p:spPr>
+          <a:xfrm>
+            <a:off x="4700016" y="1170432"/>
+            <a:ext cx="3200400" cy="347472"/>
+          </a:xfrm>
+          <a:prstGeom prst="rect">
+            <a:avLst/>
+          </a:prstGeom>
+          <a:noFill/>
+          <a:ln/>
+        </p:spPr>
+        <p:txBody>
+          <a:bodyPr wrap="square" lIns="0" tIns="0" rIns="0" bIns="0" rtlCol="0" anchor="ctr"/>
+          <a:lstStyle/>
+          <a:p>
+            <a:pPr indent="0" marL="0">
+              <a:buNone/>
+            </a:pPr>
+            <a:r>
+              <a:rPr lang="en-US" sz="1350" b="1" dirty="0">
+                <a:solidFill>
+                  <a:srgbClr val="1A1A1A"/>
+                </a:solidFill>
+                <a:latin typeface="Malgun Gothic" pitchFamily="34" charset="0"/>
+                <a:ea typeface="Malgun Gothic" pitchFamily="34" charset="-122"/>
+                <a:cs typeface="Malgun Gothic" pitchFamily="34" charset="-120"/>
+              </a:rPr>
+              <a:t>왜 write-intensive인가</a:t>
+            </a:r>
+            <a:endParaRPr lang="en-US" sz="1350" dirty="0"/>
+          </a:p>
+        </p:txBody>
+      </p:sp>
+      <p:sp>
+        <p:nvSpPr>
+          <p:cNvPr id="12" name="Shape 10"/>
+          <p:cNvSpPr/>
+          <p:nvPr/>
+        </p:nvSpPr>
+        <p:spPr>
+          <a:xfrm>
+            <a:off x="4297680" y="1627632"/>
+            <a:ext cx="3602736" cy="4626864"/>
+          </a:xfrm>
+          <a:prstGeom prst="roundRect">
+            <a:avLst>
+              <a:gd name="adj" fmla="val 2030"/>
+            </a:avLst>
+          </a:prstGeom>
+          <a:solidFill>
+            <a:srgbClr val="FFFFFF"/>
+          </a:solidFill>
+          <a:ln w="12700">
+            <a:solidFill>
+              <a:srgbClr val="D9D9D9"/>
+            </a:solidFill>
+            <a:prstDash val="solid"/>
+          </a:ln>
+        </p:spPr>
+      </p:sp>
+      <p:sp>
+        <p:nvSpPr>
+          <p:cNvPr id="13" name="Text 11"/>
+          <p:cNvSpPr/>
+          <p:nvPr/>
+        </p:nvSpPr>
+        <p:spPr>
+          <a:xfrm>
+            <a:off x="8129016" y="1188720"/>
+            <a:ext cx="310896" cy="310896"/>
+          </a:xfrm>
+          <a:prstGeom prst="ellipse">
+            <a:avLst/>
+          </a:prstGeom>
+          <a:solidFill>
+            <a:srgbClr val="1428A0"/>
+          </a:solidFill>
+          <a:ln/>
+        </p:spPr>
+        <p:txBody>
+          <a:bodyPr wrap="square" lIns="0" tIns="0" rIns="0" bIns="0" rtlCol="0" anchor="ctr"/>
+          <a:lstStyle/>
+          <a:p>
+            <a:pPr algn="ctr" indent="0" marL="0">
+              <a:buNone/>
+            </a:pPr>
+            <a:r>
+              <a:rPr lang="en-US" sz="1400" b="1" dirty="0">
+                <a:solidFill>
+                  <a:srgbClr val="FFFFFF"/>
+                </a:solidFill>
+                <a:latin typeface="Malgun Gothic" pitchFamily="34" charset="0"/>
+                <a:ea typeface="Malgun Gothic" pitchFamily="34" charset="-122"/>
+                <a:cs typeface="Malgun Gothic" pitchFamily="34" charset="-120"/>
+              </a:rPr>
+              <a:t>3</a:t>
+            </a:r>
+            <a:endParaRPr lang="en-US" sz="1400" dirty="0"/>
+          </a:p>
+        </p:txBody>
+      </p:sp>
+      <p:sp>
+        <p:nvSpPr>
+          <p:cNvPr id="14" name="Text 12"/>
+          <p:cNvSpPr/>
+          <p:nvPr/>
+        </p:nvSpPr>
+        <p:spPr>
+          <a:xfrm>
+            <a:off x="8531352" y="1170432"/>
+            <a:ext cx="3200400" cy="347472"/>
+          </a:xfrm>
+          <a:prstGeom prst="rect">
+            <a:avLst/>
+          </a:prstGeom>
+          <a:noFill/>
+          <a:ln/>
+        </p:spPr>
+        <p:txBody>
+          <a:bodyPr wrap="square" lIns="0" tIns="0" rIns="0" bIns="0" rtlCol="0" anchor="ctr"/>
+          <a:lstStyle/>
+          <a:p>
+            <a:pPr indent="0" marL="0">
+              <a:buNone/>
+            </a:pPr>
+            <a:r>
+              <a:rPr lang="en-US" sz="1350" b="1" dirty="0">
+                <a:solidFill>
+                  <a:srgbClr val="1A1A1A"/>
+                </a:solidFill>
+                <a:latin typeface="Malgun Gothic" pitchFamily="34" charset="0"/>
+                <a:ea typeface="Malgun Gothic" pitchFamily="34" charset="-122"/>
+                <a:cs typeface="Malgun Gothic" pitchFamily="34" charset="-120"/>
+              </a:rPr>
+              <a:t>DWPD 갭: 새 전략의 근거</a:t>
+            </a:r>
+            <a:endParaRPr lang="en-US" sz="1350" dirty="0"/>
+          </a:p>
+        </p:txBody>
+      </p:sp>
+      <p:sp>
+        <p:nvSpPr>
+          <p:cNvPr id="15" name="Shape 13"/>
+          <p:cNvSpPr/>
+          <p:nvPr/>
+        </p:nvSpPr>
+        <p:spPr>
+          <a:xfrm>
+            <a:off x="8129016" y="1627632"/>
+            <a:ext cx="3602736" cy="4626864"/>
+          </a:xfrm>
+          <a:prstGeom prst="roundRect">
+            <a:avLst>
+              <a:gd name="adj" fmla="val 2030"/>
+            </a:avLst>
+          </a:prstGeom>
+          <a:solidFill>
+            <a:srgbClr val="FFFFFF"/>
+          </a:solidFill>
+          <a:ln w="12700">
+            <a:solidFill>
+              <a:srgbClr val="D9D9D9"/>
+            </a:solidFill>
+            <a:prstDash val="solid"/>
+          </a:ln>
+        </p:spPr>
+      </p:sp>
+      <p:sp>
+        <p:nvSpPr>
+          <p:cNvPr id="16" name="Shape 14"/>
+          <p:cNvSpPr/>
+          <p:nvPr/>
+        </p:nvSpPr>
+        <p:spPr>
+          <a:xfrm>
+            <a:off x="1207008" y="1792224"/>
+            <a:ext cx="2103120" cy="292608"/>
+          </a:xfrm>
+          <a:prstGeom prst="roundRect">
+            <a:avLst>
+              <a:gd name="adj" fmla="val 12500"/>
+            </a:avLst>
+          </a:prstGeom>
+          <a:solidFill>
+            <a:srgbClr val="F4F4F6"/>
+          </a:solidFill>
+          <a:ln/>
+        </p:spPr>
+      </p:sp>
+      <p:sp>
+        <p:nvSpPr>
+          <p:cNvPr id="17" name="Text 15"/>
+          <p:cNvSpPr/>
+          <p:nvPr/>
+        </p:nvSpPr>
+        <p:spPr>
+          <a:xfrm>
+            <a:off x="1207008" y="1792224"/>
+            <a:ext cx="2103120" cy="292608"/>
+          </a:xfrm>
+          <a:prstGeom prst="rect">
+            <a:avLst/>
+          </a:prstGeom>
+          <a:noFill/>
+          <a:ln/>
+        </p:spPr>
+        <p:txBody>
+          <a:bodyPr wrap="square" lIns="0" tIns="0" rIns="0" bIns="0" rtlCol="0" anchor="ctr"/>
+          <a:lstStyle/>
+          <a:p>
+            <a:pPr algn="ctr" indent="0" marL="0">
+              <a:buNone/>
+            </a:pPr>
+            <a:r>
+              <a:rPr lang="en-US" sz="1000" dirty="0">
+                <a:solidFill>
+                  <a:srgbClr val="555555"/>
+                </a:solidFill>
+                <a:latin typeface="Malgun Gothic" pitchFamily="34" charset="0"/>
+                <a:ea typeface="Malgun Gothic" pitchFamily="34" charset="-122"/>
+                <a:cs typeface="Malgun Gothic" pitchFamily="34" charset="-120"/>
+              </a:rPr>
+              <a:t>GPU HBM</a:t>
+            </a:r>
+            <a:endParaRPr lang="en-US" sz="1000" dirty="0"/>
+          </a:p>
+        </p:txBody>
+      </p:sp>
+      <p:sp>
+        <p:nvSpPr>
+          <p:cNvPr id="18" name="Text 16"/>
+          <p:cNvSpPr/>
+          <p:nvPr/>
+        </p:nvSpPr>
+        <p:spPr>
+          <a:xfrm>
+            <a:off x="2121408" y="2066544"/>
+            <a:ext cx="274320" cy="146304"/>
+          </a:xfrm>
+          <a:prstGeom prst="rect">
+            <a:avLst/>
+          </a:prstGeom>
+          <a:noFill/>
+          <a:ln/>
+        </p:spPr>
+        <p:txBody>
+          <a:bodyPr wrap="square" lIns="0" tIns="0" rIns="0" bIns="0" rtlCol="0" anchor="ctr"/>
+          <a:lstStyle/>
+          <a:p>
+            <a:pPr algn="ctr" indent="0" marL="0">
+              <a:buNone/>
+            </a:pPr>
+            <a:r>
+              <a:rPr lang="en-US" sz="900" dirty="0">
+                <a:solidFill>
+                  <a:srgbClr val="555555"/>
+                </a:solidFill>
+                <a:latin typeface="Malgun Gothic" pitchFamily="34" charset="0"/>
+                <a:ea typeface="Malgun Gothic" pitchFamily="34" charset="-122"/>
+                <a:cs typeface="Malgun Gothic" pitchFamily="34" charset="-120"/>
+              </a:rPr>
+              <a:t>↓</a:t>
+            </a:r>
+            <a:endParaRPr lang="en-US" sz="900" dirty="0"/>
+          </a:p>
+        </p:txBody>
+      </p:sp>
+      <p:sp>
+        <p:nvSpPr>
+          <p:cNvPr id="19" name="Shape 17"/>
+          <p:cNvSpPr/>
+          <p:nvPr/>
+        </p:nvSpPr>
+        <p:spPr>
+          <a:xfrm>
+            <a:off x="1207008" y="2194560"/>
+            <a:ext cx="2103120" cy="292608"/>
+          </a:xfrm>
+          <a:prstGeom prst="roundRect">
+            <a:avLst>
+              <a:gd name="adj" fmla="val 12500"/>
+            </a:avLst>
+          </a:prstGeom>
+          <a:solidFill>
+            <a:srgbClr val="E5E9F2"/>
+          </a:solidFill>
+          <a:ln/>
+        </p:spPr>
+      </p:sp>
+      <p:sp>
+        <p:nvSpPr>
+          <p:cNvPr id="20" name="Text 18"/>
+          <p:cNvSpPr/>
+          <p:nvPr/>
+        </p:nvSpPr>
+        <p:spPr>
+          <a:xfrm>
+            <a:off x="1207008" y="2194560"/>
+            <a:ext cx="2103120" cy="292608"/>
+          </a:xfrm>
+          <a:prstGeom prst="rect">
+            <a:avLst/>
+          </a:prstGeom>
+          <a:noFill/>
+          <a:ln/>
+        </p:spPr>
+        <p:txBody>
+          <a:bodyPr wrap="square" lIns="0" tIns="0" rIns="0" bIns="0" rtlCol="0" anchor="ctr"/>
+          <a:lstStyle/>
+          <a:p>
+            <a:pPr algn="ctr" indent="0" marL="0">
+              <a:buNone/>
+            </a:pPr>
+            <a:r>
+              <a:rPr lang="en-US" sz="1000" dirty="0">
+                <a:solidFill>
+                  <a:srgbClr val="1A1A1A"/>
+                </a:solidFill>
+                <a:latin typeface="Malgun Gothic" pitchFamily="34" charset="0"/>
+                <a:ea typeface="Malgun Gothic" pitchFamily="34" charset="-122"/>
+                <a:cs typeface="Malgun Gothic" pitchFamily="34" charset="-120"/>
+              </a:rPr>
+              <a:t>호스트 DRAM</a:t>
+            </a:r>
+            <a:endParaRPr lang="en-US" sz="1000" dirty="0"/>
+          </a:p>
+        </p:txBody>
+      </p:sp>
+      <p:sp>
+        <p:nvSpPr>
+          <p:cNvPr id="21" name="Text 19"/>
+          <p:cNvSpPr/>
+          <p:nvPr/>
+        </p:nvSpPr>
+        <p:spPr>
+          <a:xfrm>
+            <a:off x="2121408" y="2468880"/>
+            <a:ext cx="274320" cy="146304"/>
+          </a:xfrm>
+          <a:prstGeom prst="rect">
+            <a:avLst/>
+          </a:prstGeom>
+          <a:noFill/>
+          <a:ln/>
+        </p:spPr>
+        <p:txBody>
+          <a:bodyPr wrap="square" lIns="0" tIns="0" rIns="0" bIns="0" rtlCol="0" anchor="ctr"/>
+          <a:lstStyle/>
+          <a:p>
+            <a:pPr algn="ctr" indent="0" marL="0">
+              <a:buNone/>
+            </a:pPr>
+            <a:r>
+              <a:rPr lang="en-US" sz="900" dirty="0">
+                <a:solidFill>
+                  <a:srgbClr val="555555"/>
+                </a:solidFill>
+                <a:latin typeface="Malgun Gothic" pitchFamily="34" charset="0"/>
+                <a:ea typeface="Malgun Gothic" pitchFamily="34" charset="-122"/>
+                <a:cs typeface="Malgun Gothic" pitchFamily="34" charset="-120"/>
+              </a:rPr>
+              <a:t>↓</a:t>
+            </a:r>
+            <a:endParaRPr lang="en-US" sz="900" dirty="0"/>
+          </a:p>
+        </p:txBody>
+      </p:sp>
+      <p:sp>
+        <p:nvSpPr>
+          <p:cNvPr id="22" name="Shape 20"/>
+          <p:cNvSpPr/>
+          <p:nvPr/>
+        </p:nvSpPr>
+        <p:spPr>
+          <a:xfrm>
+            <a:off x="1207008" y="2596896"/>
+            <a:ext cx="2103120" cy="292608"/>
+          </a:xfrm>
+          <a:prstGeom prst="roundRect">
+            <a:avLst>
+              <a:gd name="adj" fmla="val 12500"/>
+            </a:avLst>
+          </a:prstGeom>
+          <a:solidFill>
+            <a:srgbClr val="1428A0"/>
+          </a:solidFill>
+          <a:ln/>
+        </p:spPr>
+      </p:sp>
+      <p:sp>
+        <p:nvSpPr>
+          <p:cNvPr id="23" name="Text 21"/>
+          <p:cNvSpPr/>
+          <p:nvPr/>
+        </p:nvSpPr>
+        <p:spPr>
+          <a:xfrm>
+            <a:off x="1207008" y="2596896"/>
+            <a:ext cx="2103120" cy="292608"/>
+          </a:xfrm>
+          <a:prstGeom prst="rect">
+            <a:avLst/>
+          </a:prstGeom>
+          <a:noFill/>
+          <a:ln/>
+        </p:spPr>
+        <p:txBody>
+          <a:bodyPr wrap="square" lIns="0" tIns="0" rIns="0" bIns="0" rtlCol="0" anchor="ctr"/>
+          <a:lstStyle/>
+          <a:p>
+            <a:pPr algn="ctr" indent="0" marL="0">
+              <a:buNone/>
+            </a:pPr>
+            <a:r>
+              <a:rPr lang="en-US" sz="1000" b="1" dirty="0">
+                <a:solidFill>
+                  <a:srgbClr val="FFFFFF"/>
+                </a:solidFill>
+                <a:latin typeface="Malgun Gothic" pitchFamily="34" charset="0"/>
+                <a:ea typeface="Malgun Gothic" pitchFamily="34" charset="-122"/>
+                <a:cs typeface="Malgun Gothic" pitchFamily="34" charset="-120"/>
+              </a:rPr>
+              <a:t>SSD: KV 캐시 계층</a:t>
+            </a:r>
+            <a:endParaRPr lang="en-US" sz="1000" dirty="0"/>
+          </a:p>
+        </p:txBody>
+      </p:sp>
+      <p:sp>
+        <p:nvSpPr>
+          <p:cNvPr id="24" name="Text 22"/>
+          <p:cNvSpPr/>
+          <p:nvPr/>
+        </p:nvSpPr>
+        <p:spPr>
+          <a:xfrm>
+            <a:off x="658368" y="3054096"/>
+            <a:ext cx="3200400" cy="237744"/>
+          </a:xfrm>
+          <a:prstGeom prst="rect">
+            <a:avLst/>
+          </a:prstGeom>
+          <a:noFill/>
+          <a:ln/>
+        </p:spPr>
+        <p:txBody>
+          <a:bodyPr wrap="square" lIns="0" tIns="0" rIns="0" bIns="0" rtlCol="0" anchor="ctr"/>
+          <a:lstStyle/>
+          <a:p>
+            <a:pPr algn="ctr" indent="0" marL="0">
+              <a:buNone/>
+            </a:pPr>
+            <a:r>
+              <a:rPr lang="en-US" sz="900" dirty="0">
+                <a:solidFill>
+                  <a:srgbClr val="555555"/>
+                </a:solidFill>
+                <a:latin typeface="Malgun Gothic" pitchFamily="34" charset="0"/>
+                <a:ea typeface="Malgun Gothic" pitchFamily="34" charset="-122"/>
+                <a:cs typeface="Malgun Gothic" pitchFamily="34" charset="-120"/>
+              </a:rPr>
+              <a:t>Dynamo·CMX·LMCache·Mooncake가 SSD 계층 공식 지원</a:t>
+            </a:r>
+            <a:endParaRPr lang="en-US" sz="900" dirty="0"/>
+          </a:p>
+        </p:txBody>
+      </p:sp>
+      <p:sp>
+        <p:nvSpPr>
+          <p:cNvPr id="25" name="Shape 23"/>
+          <p:cNvSpPr/>
+          <p:nvPr/>
+        </p:nvSpPr>
+        <p:spPr>
+          <a:xfrm>
+            <a:off x="841248" y="4828032"/>
+            <a:ext cx="2651760" cy="0"/>
+          </a:xfrm>
+          <a:prstGeom prst="line">
+            <a:avLst/>
+          </a:prstGeom>
+          <a:noFill/>
+          <a:ln w="12700">
+            <a:solidFill>
+              <a:srgbClr val="555555"/>
+            </a:solidFill>
+            <a:prstDash val="solid"/>
+          </a:ln>
+        </p:spPr>
+      </p:sp>
+      <p:sp>
+        <p:nvSpPr>
+          <p:cNvPr id="26" name="Shape 24"/>
+          <p:cNvSpPr/>
+          <p:nvPr/>
+        </p:nvSpPr>
+        <p:spPr>
+          <a:xfrm>
+            <a:off x="1234440" y="4325112"/>
+            <a:ext cx="640080" cy="125730"/>
+          </a:xfrm>
+          <a:prstGeom prst="rect">
+            <a:avLst/>
+          </a:prstGeom>
+          <a:solidFill>
+            <a:srgbClr val="8FA0DC"/>
+          </a:solidFill>
+          <a:ln/>
+        </p:spPr>
+      </p:sp>
+      <p:sp>
+        <p:nvSpPr>
+          <p:cNvPr id="27" name="Shape 25"/>
+          <p:cNvSpPr/>
+          <p:nvPr/>
+        </p:nvSpPr>
+        <p:spPr>
+          <a:xfrm>
+            <a:off x="1234440" y="4450842"/>
+            <a:ext cx="640080" cy="377190"/>
+          </a:xfrm>
+          <a:prstGeom prst="rect">
+            <a:avLst/>
+          </a:prstGeom>
+          <a:solidFill>
+            <a:srgbClr val="1428A0"/>
+          </a:solidFill>
+          <a:ln/>
+        </p:spPr>
+      </p:sp>
+      <p:sp>
+        <p:nvSpPr>
+          <p:cNvPr id="28" name="Text 26"/>
+          <p:cNvSpPr/>
+          <p:nvPr/>
+        </p:nvSpPr>
+        <p:spPr>
+          <a:xfrm>
+            <a:off x="914400" y="4069080"/>
+            <a:ext cx="1280160" cy="237744"/>
+          </a:xfrm>
+          <a:prstGeom prst="rect">
+            <a:avLst/>
+          </a:prstGeom>
+          <a:noFill/>
+          <a:ln/>
+        </p:spPr>
+        <p:txBody>
+          <a:bodyPr wrap="square" lIns="0" tIns="0" rIns="0" bIns="0" rtlCol="0" anchor="ctr"/>
+          <a:lstStyle/>
+          <a:p>
+            <a:pPr algn="ctr" indent="0" marL="0">
+              <a:buNone/>
+            </a:pPr>
+            <a:r>
+              <a:rPr lang="en-US" sz="1050" b="1" dirty="0">
+                <a:solidFill>
+                  <a:srgbClr val="1428A0"/>
+                </a:solidFill>
+                <a:latin typeface="Malgun Gothic" pitchFamily="34" charset="0"/>
+                <a:ea typeface="Malgun Gothic" pitchFamily="34" charset="-122"/>
+                <a:cs typeface="Malgun Gothic" pitchFamily="34" charset="-120"/>
+              </a:rPr>
+              <a:t>75~100EB</a:t>
+            </a:r>
+            <a:endParaRPr lang="en-US" sz="1050" dirty="0"/>
+          </a:p>
+        </p:txBody>
+      </p:sp>
+      <p:sp>
+        <p:nvSpPr>
+          <p:cNvPr id="29" name="Text 27"/>
+          <p:cNvSpPr/>
+          <p:nvPr/>
+        </p:nvSpPr>
+        <p:spPr>
+          <a:xfrm>
+            <a:off x="1097280" y="4864608"/>
+            <a:ext cx="914400" cy="219456"/>
+          </a:xfrm>
+          <a:prstGeom prst="rect">
+            <a:avLst/>
+          </a:prstGeom>
+          <a:noFill/>
+          <a:ln/>
+        </p:spPr>
+        <p:txBody>
+          <a:bodyPr wrap="square" lIns="0" tIns="0" rIns="0" bIns="0" rtlCol="0" anchor="ctr"/>
+          <a:lstStyle/>
+          <a:p>
+            <a:pPr algn="ctr" indent="0" marL="0">
+              <a:buNone/>
+            </a:pPr>
+            <a:r>
+              <a:rPr lang="en-US" sz="1000" dirty="0">
+                <a:solidFill>
+                  <a:srgbClr val="1A1A1A"/>
+                </a:solidFill>
+                <a:latin typeface="Malgun Gothic" pitchFamily="34" charset="0"/>
+                <a:ea typeface="Malgun Gothic" pitchFamily="34" charset="-122"/>
+                <a:cs typeface="Malgun Gothic" pitchFamily="34" charset="-120"/>
+              </a:rPr>
+              <a:t>2027</a:t>
+            </a:r>
+            <a:endParaRPr lang="en-US" sz="1000" dirty="0"/>
+          </a:p>
+        </p:txBody>
+      </p:sp>
+      <p:sp>
+        <p:nvSpPr>
+          <p:cNvPr id="30" name="Shape 28"/>
+          <p:cNvSpPr/>
+          <p:nvPr/>
+        </p:nvSpPr>
+        <p:spPr>
+          <a:xfrm>
+            <a:off x="2468880" y="3822192"/>
+            <a:ext cx="640080" cy="251460"/>
+          </a:xfrm>
+          <a:prstGeom prst="rect">
+            <a:avLst/>
+          </a:prstGeom>
+          <a:solidFill>
+            <a:srgbClr val="8FA0DC"/>
+          </a:solidFill>
+          <a:ln/>
+        </p:spPr>
+      </p:sp>
+      <p:sp>
+        <p:nvSpPr>
+          <p:cNvPr id="31" name="Shape 29"/>
+          <p:cNvSpPr/>
+          <p:nvPr/>
+        </p:nvSpPr>
+        <p:spPr>
+          <a:xfrm>
+            <a:off x="2468880" y="4073652"/>
+            <a:ext cx="640080" cy="754380"/>
+          </a:xfrm>
+          <a:prstGeom prst="rect">
+            <a:avLst/>
+          </a:prstGeom>
+          <a:solidFill>
+            <a:srgbClr val="1428A0"/>
+          </a:solidFill>
+          <a:ln/>
+        </p:spPr>
+      </p:sp>
+      <p:sp>
+        <p:nvSpPr>
+          <p:cNvPr id="32" name="Text 30"/>
+          <p:cNvSpPr/>
+          <p:nvPr/>
+        </p:nvSpPr>
+        <p:spPr>
+          <a:xfrm>
+            <a:off x="2148840" y="3566160"/>
+            <a:ext cx="1280160" cy="237744"/>
+          </a:xfrm>
+          <a:prstGeom prst="rect">
+            <a:avLst/>
+          </a:prstGeom>
+          <a:noFill/>
+          <a:ln/>
+        </p:spPr>
+        <p:txBody>
+          <a:bodyPr wrap="square" lIns="0" tIns="0" rIns="0" bIns="0" rtlCol="0" anchor="ctr"/>
+          <a:lstStyle/>
+          <a:p>
+            <a:pPr algn="ctr" indent="0" marL="0">
+              <a:buNone/>
+            </a:pPr>
+            <a:r>
+              <a:rPr lang="en-US" sz="1050" b="1" dirty="0">
+                <a:solidFill>
+                  <a:srgbClr val="1428A0"/>
+                </a:solidFill>
+                <a:latin typeface="Malgun Gothic" pitchFamily="34" charset="0"/>
+                <a:ea typeface="Malgun Gothic" pitchFamily="34" charset="-122"/>
+                <a:cs typeface="Malgun Gothic" pitchFamily="34" charset="-120"/>
+              </a:rPr>
+              <a:t>150~200EB</a:t>
+            </a:r>
+            <a:endParaRPr lang="en-US" sz="1050" dirty="0"/>
+          </a:p>
+        </p:txBody>
+      </p:sp>
+      <p:sp>
+        <p:nvSpPr>
+          <p:cNvPr id="33" name="Text 31"/>
+          <p:cNvSpPr/>
+          <p:nvPr/>
+        </p:nvSpPr>
+        <p:spPr>
+          <a:xfrm>
+            <a:off x="2331720" y="4864608"/>
+            <a:ext cx="914400" cy="219456"/>
+          </a:xfrm>
+          <a:prstGeom prst="rect">
+            <a:avLst/>
+          </a:prstGeom>
+          <a:noFill/>
+          <a:ln/>
+        </p:spPr>
+        <p:txBody>
+          <a:bodyPr wrap="square" lIns="0" tIns="0" rIns="0" bIns="0" rtlCol="0" anchor="ctr"/>
+          <a:lstStyle/>
+          <a:p>
+            <a:pPr algn="ctr" indent="0" marL="0">
+              <a:buNone/>
+            </a:pPr>
+            <a:r>
+              <a:rPr lang="en-US" sz="1000" dirty="0">
+                <a:solidFill>
+                  <a:srgbClr val="1A1A1A"/>
+                </a:solidFill>
+                <a:latin typeface="Malgun Gothic" pitchFamily="34" charset="0"/>
+                <a:ea typeface="Malgun Gothic" pitchFamily="34" charset="-122"/>
+                <a:cs typeface="Malgun Gothic" pitchFamily="34" charset="-120"/>
+              </a:rPr>
+              <a:t>2028</a:t>
+            </a:r>
+            <a:endParaRPr lang="en-US" sz="1000" dirty="0"/>
+          </a:p>
+        </p:txBody>
+      </p:sp>
+      <p:sp>
+        <p:nvSpPr>
+          <p:cNvPr id="34" name="Text 32"/>
+          <p:cNvSpPr/>
+          <p:nvPr/>
+        </p:nvSpPr>
+        <p:spPr>
+          <a:xfrm>
+            <a:off x="658368" y="3218688"/>
+            <a:ext cx="3200400" cy="237744"/>
+          </a:xfrm>
+          <a:prstGeom prst="rect">
+            <a:avLst/>
+          </a:prstGeom>
+          <a:noFill/>
+          <a:ln/>
+        </p:spPr>
+        <p:txBody>
+          <a:bodyPr wrap="square" lIns="0" tIns="0" rIns="0" bIns="0" rtlCol="0" anchor="ctr"/>
+          <a:lstStyle/>
+          <a:p>
+            <a:pPr indent="0" marL="0">
+              <a:buNone/>
+            </a:pPr>
+            <a:r>
+              <a:rPr lang="en-US" sz="1050" b="1" dirty="0">
+                <a:solidFill>
+                  <a:srgbClr val="1428A0"/>
+                </a:solidFill>
+                <a:latin typeface="Malgun Gothic" pitchFamily="34" charset="0"/>
+                <a:ea typeface="Malgun Gothic" pitchFamily="34" charset="-122"/>
+                <a:cs typeface="Malgun Gothic" pitchFamily="34" charset="-120"/>
+              </a:rPr>
+              <a:t>KV cache 단독 NAND 추가 수요</a:t>
+            </a:r>
+            <a:endParaRPr lang="en-US" sz="1050" dirty="0"/>
+          </a:p>
+        </p:txBody>
+      </p:sp>
+      <p:sp>
+        <p:nvSpPr>
+          <p:cNvPr id="35" name="Text 33"/>
+          <p:cNvSpPr/>
+          <p:nvPr/>
+        </p:nvSpPr>
+        <p:spPr>
+          <a:xfrm>
+            <a:off x="658368" y="5230368"/>
+            <a:ext cx="3200400" cy="859536"/>
+          </a:xfrm>
+          <a:prstGeom prst="rect">
+            <a:avLst/>
+          </a:prstGeom>
+          <a:noFill/>
+          <a:ln/>
+        </p:spPr>
+        <p:txBody>
+          <a:bodyPr wrap="square" lIns="0" tIns="0" rIns="0" bIns="0" rtlCol="0" anchor="ctr"/>
+          <a:lstStyle/>
+          <a:p>
+            <a:pPr indent="0" marL="0">
+              <a:lnSpc>
+                <a:spcPct val="112000"/>
+              </a:lnSpc>
+              <a:buNone/>
+            </a:pPr>
+            <a:r>
+              <a:rPr lang="en-US" sz="2000" b="1" dirty="0">
+                <a:solidFill>
+                  <a:srgbClr val="1428A0"/>
+                </a:solidFill>
+                <a:latin typeface="Malgun Gothic" pitchFamily="34" charset="0"/>
+                <a:ea typeface="Malgun Gothic" pitchFamily="34" charset="-122"/>
+                <a:cs typeface="Malgun Gothic" pitchFamily="34" charset="-120"/>
+              </a:rPr>
+              <a:t>35%  </a:t>
+            </a:r>
+            <a:pPr indent="0" marL="0">
+              <a:lnSpc>
+                <a:spcPct val="112000"/>
+              </a:lnSpc>
+              <a:buNone/>
+            </a:pPr>
+            <a:r>
+              <a:rPr lang="en-US" sz="950" dirty="0">
+                <a:solidFill>
+                  <a:srgbClr val="555555"/>
+                </a:solidFill>
+                <a:latin typeface="Malgun Gothic" pitchFamily="34" charset="0"/>
+                <a:ea typeface="Malgun Gothic" pitchFamily="34" charset="-122"/>
+                <a:cs typeface="Malgun Gothic" pitchFamily="34" charset="-120"/>
+              </a:rPr>
+              <a:t>2030년 AI DC NAND 워크로드 중 KV cache 비중 (SanDisk, FMS 2026) · NVL144 랙 연 5만 대 기준 연 ~0.44EB</a:t>
+            </a:r>
+            <a:endParaRPr lang="en-US" sz="2000" dirty="0"/>
+          </a:p>
+        </p:txBody>
+      </p:sp>
+      <p:sp>
+        <p:nvSpPr>
+          <p:cNvPr id="36" name="Shape 34"/>
+          <p:cNvSpPr/>
+          <p:nvPr/>
+        </p:nvSpPr>
+        <p:spPr>
+          <a:xfrm>
+            <a:off x="4498848" y="1856232"/>
+            <a:ext cx="128016" cy="128016"/>
+          </a:xfrm>
+          <a:prstGeom prst="rect">
+            <a:avLst/>
+          </a:prstGeom>
+          <a:solidFill>
+            <a:srgbClr val="1428A0"/>
+          </a:solidFill>
+          <a:ln/>
+        </p:spPr>
+      </p:sp>
+      <p:sp>
+        <p:nvSpPr>
+          <p:cNvPr id="37" name="Text 35"/>
+          <p:cNvSpPr/>
+          <p:nvPr/>
+        </p:nvSpPr>
+        <p:spPr>
+          <a:xfrm>
+            <a:off x="4736592" y="1755648"/>
+            <a:ext cx="3017520" cy="731520"/>
+          </a:xfrm>
+          <a:prstGeom prst="rect">
+            <a:avLst/>
+          </a:prstGeom>
+          <a:noFill/>
+          <a:ln/>
+        </p:spPr>
+        <p:txBody>
+          <a:bodyPr wrap="square" lIns="0" tIns="0" rIns="0" bIns="0" rtlCol="0" anchor="t"/>
+          <a:lstStyle/>
+          <a:p>
+            <a:pPr indent="0" marL="0">
+              <a:lnSpc>
+                <a:spcPct val="112000"/>
+              </a:lnSpc>
+              <a:buNone/>
+            </a:pPr>
+            <a:r>
+              <a:rPr lang="en-US" sz="1100" b="1" dirty="0">
+                <a:solidFill>
+                  <a:srgbClr val="1A1A1A"/>
+                </a:solidFill>
+                <a:latin typeface="Malgun Gothic" pitchFamily="34" charset="0"/>
+                <a:ea typeface="Malgun Gothic" pitchFamily="34" charset="-122"/>
+                <a:cs typeface="Malgun Gothic" pitchFamily="34" charset="-120"/>
+              </a:rPr>
+              <a:t>세션마다 생성·갱신</a:t>
+            </a:r>
+            <a:endParaRPr lang="en-US" sz="1100" dirty="0"/>
+          </a:p>
+          <a:p>
+            <a:pPr indent="0" marL="0">
+              <a:lnSpc>
+                <a:spcPct val="112000"/>
+              </a:lnSpc>
+              <a:buNone/>
+            </a:pPr>
+            <a:r>
+              <a:rPr lang="en-US" sz="1000" dirty="0">
+                <a:solidFill>
+                  <a:srgbClr val="555555"/>
+                </a:solidFill>
+                <a:latin typeface="Malgun Gothic" pitchFamily="34" charset="0"/>
+                <a:ea typeface="Malgun Gothic" pitchFamily="34" charset="-122"/>
+                <a:cs typeface="Malgun Gothic" pitchFamily="34" charset="-120"/>
+              </a:rPr>
+              <a:t>요청이 곧 쓰기: 연속적 쓰기 부하</a:t>
+            </a:r>
+            <a:endParaRPr lang="en-US" sz="1100" dirty="0"/>
+          </a:p>
+        </p:txBody>
+      </p:sp>
+      <p:sp>
+        <p:nvSpPr>
+          <p:cNvPr id="38" name="Shape 36"/>
+          <p:cNvSpPr/>
+          <p:nvPr/>
+        </p:nvSpPr>
+        <p:spPr>
+          <a:xfrm>
+            <a:off x="4498848" y="2642616"/>
+            <a:ext cx="128016" cy="128016"/>
+          </a:xfrm>
+          <a:prstGeom prst="rect">
+            <a:avLst/>
+          </a:prstGeom>
+          <a:solidFill>
+            <a:srgbClr val="1428A0"/>
+          </a:solidFill>
+          <a:ln/>
+        </p:spPr>
+      </p:sp>
+      <p:sp>
+        <p:nvSpPr>
+          <p:cNvPr id="39" name="Text 37"/>
+          <p:cNvSpPr/>
+          <p:nvPr/>
+        </p:nvSpPr>
+        <p:spPr>
+          <a:xfrm>
+            <a:off x="4736592" y="2542032"/>
+            <a:ext cx="3017520" cy="731520"/>
+          </a:xfrm>
+          <a:prstGeom prst="rect">
+            <a:avLst/>
+          </a:prstGeom>
+          <a:noFill/>
+          <a:ln/>
+        </p:spPr>
+        <p:txBody>
+          <a:bodyPr wrap="square" lIns="0" tIns="0" rIns="0" bIns="0" rtlCol="0" anchor="t"/>
+          <a:lstStyle/>
+          <a:p>
+            <a:pPr indent="0" marL="0">
+              <a:lnSpc>
+                <a:spcPct val="112000"/>
+              </a:lnSpc>
+              <a:buNone/>
+            </a:pPr>
+            <a:r>
+              <a:rPr lang="en-US" sz="1100" b="1" dirty="0">
+                <a:solidFill>
+                  <a:srgbClr val="1A1A1A"/>
+                </a:solidFill>
+                <a:latin typeface="Malgun Gothic" pitchFamily="34" charset="0"/>
+                <a:ea typeface="Malgun Gothic" pitchFamily="34" charset="-122"/>
+                <a:cs typeface="Malgun Gothic" pitchFamily="34" charset="-120"/>
+              </a:rPr>
+              <a:t>짧고 제각각인 수명</a:t>
+            </a:r>
+            <a:endParaRPr lang="en-US" sz="1100" dirty="0"/>
+          </a:p>
+          <a:p>
+            <a:pPr indent="0" marL="0">
+              <a:lnSpc>
+                <a:spcPct val="112000"/>
+              </a:lnSpc>
+              <a:buNone/>
+            </a:pPr>
+            <a:r>
+              <a:rPr lang="en-US" sz="1000" dirty="0">
+                <a:solidFill>
+                  <a:srgbClr val="555555"/>
+                </a:solidFill>
+                <a:latin typeface="Malgun Gothic" pitchFamily="34" charset="0"/>
+                <a:ea typeface="Malgun Gothic" pitchFamily="34" charset="-122"/>
+                <a:cs typeface="Malgun Gothic" pitchFamily="34" charset="-120"/>
+              </a:rPr>
+              <a:t>블록별 라이프사이클이 모두 다르다</a:t>
+            </a:r>
+            <a:endParaRPr lang="en-US" sz="1100" dirty="0"/>
+          </a:p>
+        </p:txBody>
+      </p:sp>
+      <p:sp>
+        <p:nvSpPr>
+          <p:cNvPr id="40" name="Shape 38"/>
+          <p:cNvSpPr/>
+          <p:nvPr/>
+        </p:nvSpPr>
+        <p:spPr>
+          <a:xfrm>
+            <a:off x="4498848" y="3429000"/>
+            <a:ext cx="128016" cy="128016"/>
+          </a:xfrm>
+          <a:prstGeom prst="rect">
+            <a:avLst/>
+          </a:prstGeom>
+          <a:solidFill>
+            <a:srgbClr val="1428A0"/>
+          </a:solidFill>
+          <a:ln/>
+        </p:spPr>
+      </p:sp>
+      <p:sp>
+        <p:nvSpPr>
+          <p:cNvPr id="41" name="Text 39"/>
+          <p:cNvSpPr/>
+          <p:nvPr/>
+        </p:nvSpPr>
+        <p:spPr>
+          <a:xfrm>
+            <a:off x="4736592" y="3328416"/>
+            <a:ext cx="3017520" cy="731520"/>
+          </a:xfrm>
+          <a:prstGeom prst="rect">
+            <a:avLst/>
+          </a:prstGeom>
+          <a:noFill/>
+          <a:ln/>
+        </p:spPr>
+        <p:txBody>
+          <a:bodyPr wrap="square" lIns="0" tIns="0" rIns="0" bIns="0" rtlCol="0" anchor="t"/>
+          <a:lstStyle/>
+          <a:p>
+            <a:pPr indent="0" marL="0">
+              <a:lnSpc>
+                <a:spcPct val="112000"/>
+              </a:lnSpc>
+              <a:buNone/>
+            </a:pPr>
+            <a:r>
+              <a:rPr lang="en-US" sz="1100" b="1" dirty="0">
+                <a:solidFill>
+                  <a:srgbClr val="1A1A1A"/>
+                </a:solidFill>
+                <a:latin typeface="Malgun Gothic" pitchFamily="34" charset="0"/>
+                <a:ea typeface="Malgun Gothic" pitchFamily="34" charset="-122"/>
+                <a:cs typeface="Malgun Gothic" pitchFamily="34" charset="-120"/>
+              </a:rPr>
+              <a:t>비동기 무효화·재적재</a:t>
+            </a:r>
+            <a:endParaRPr lang="en-US" sz="1100" dirty="0"/>
+          </a:p>
+          <a:p>
+            <a:pPr indent="0" marL="0">
+              <a:lnSpc>
+                <a:spcPct val="112000"/>
+              </a:lnSpc>
+              <a:buNone/>
+            </a:pPr>
+            <a:r>
+              <a:rPr lang="en-US" sz="1000" dirty="0">
+                <a:solidFill>
+                  <a:srgbClr val="555555"/>
+                </a:solidFill>
+                <a:latin typeface="Malgun Gothic" pitchFamily="34" charset="0"/>
+                <a:ea typeface="Malgun Gothic" pitchFamily="34" charset="-122"/>
+                <a:cs typeface="Malgun Gothic" pitchFamily="34" charset="-120"/>
+              </a:rPr>
+              <a:t>퇴출과 재활성이 상시 반복</a:t>
+            </a:r>
+            <a:endParaRPr lang="en-US" sz="1100" dirty="0"/>
+          </a:p>
+        </p:txBody>
+      </p:sp>
+      <p:sp>
+        <p:nvSpPr>
+          <p:cNvPr id="42" name="Shape 40"/>
+          <p:cNvSpPr/>
+          <p:nvPr/>
+        </p:nvSpPr>
+        <p:spPr>
+          <a:xfrm>
+            <a:off x="4498848" y="4215384"/>
+            <a:ext cx="128016" cy="128016"/>
+          </a:xfrm>
+          <a:prstGeom prst="rect">
+            <a:avLst/>
+          </a:prstGeom>
+          <a:solidFill>
+            <a:srgbClr val="1428A0"/>
+          </a:solidFill>
+          <a:ln/>
+        </p:spPr>
+      </p:sp>
+      <p:sp>
+        <p:nvSpPr>
+          <p:cNvPr id="43" name="Text 41"/>
+          <p:cNvSpPr/>
+          <p:nvPr/>
+        </p:nvSpPr>
+        <p:spPr>
+          <a:xfrm>
+            <a:off x="4736592" y="4114800"/>
+            <a:ext cx="3017520" cy="731520"/>
+          </a:xfrm>
+          <a:prstGeom prst="rect">
+            <a:avLst/>
+          </a:prstGeom>
+          <a:noFill/>
+          <a:ln/>
+        </p:spPr>
+        <p:txBody>
+          <a:bodyPr wrap="square" lIns="0" tIns="0" rIns="0" bIns="0" rtlCol="0" anchor="t"/>
+          <a:lstStyle/>
+          <a:p>
+            <a:pPr indent="0" marL="0">
+              <a:lnSpc>
+                <a:spcPct val="112000"/>
+              </a:lnSpc>
+              <a:buNone/>
+            </a:pPr>
+            <a:r>
+              <a:rPr lang="en-US" sz="1100" b="1" dirty="0">
+                <a:solidFill>
+                  <a:srgbClr val="1A1A1A"/>
+                </a:solidFill>
+                <a:latin typeface="Malgun Gothic" pitchFamily="34" charset="0"/>
+                <a:ea typeface="Malgun Gothic" pitchFamily="34" charset="-122"/>
+                <a:cs typeface="Malgun Gothic" pitchFamily="34" charset="-120"/>
+              </a:rPr>
+              <a:t>멀티테넌트 혼합</a:t>
+            </a:r>
+            <a:endParaRPr lang="en-US" sz="1100" dirty="0"/>
+          </a:p>
+          <a:p>
+            <a:pPr indent="0" marL="0">
+              <a:lnSpc>
+                <a:spcPct val="112000"/>
+              </a:lnSpc>
+              <a:buNone/>
+            </a:pPr>
+            <a:r>
+              <a:rPr lang="en-US" sz="1000" dirty="0">
+                <a:solidFill>
+                  <a:srgbClr val="555555"/>
+                </a:solidFill>
+                <a:latin typeface="Malgun Gothic" pitchFamily="34" charset="0"/>
+                <a:ea typeface="Malgun Gothic" pitchFamily="34" charset="-122"/>
+                <a:cs typeface="Malgun Gothic" pitchFamily="34" charset="-120"/>
+              </a:rPr>
+              <a:t>GC 간섭으로 WAF 증폭</a:t>
+            </a:r>
+            <a:endParaRPr lang="en-US" sz="1100" dirty="0"/>
+          </a:p>
+        </p:txBody>
+      </p:sp>
+      <p:sp>
+        <p:nvSpPr>
+          <p:cNvPr id="44" name="Text 42"/>
+          <p:cNvSpPr/>
+          <p:nvPr/>
+        </p:nvSpPr>
+        <p:spPr>
+          <a:xfrm>
+            <a:off x="4498848" y="5029200"/>
+            <a:ext cx="3200400" cy="566928"/>
+          </a:xfrm>
+          <a:prstGeom prst="roundRect">
+            <a:avLst>
+              <a:gd name="adj" fmla="val 8065"/>
+            </a:avLst>
+          </a:prstGeom>
+          <a:solidFill>
+            <a:srgbClr val="F4F4F6"/>
+          </a:solidFill>
+          <a:ln/>
+        </p:spPr>
+        <p:txBody>
+          <a:bodyPr wrap="square" lIns="1016" tIns="1016" rIns="1016" bIns="1016" rtlCol="0" anchor="ctr"/>
+          <a:lstStyle/>
+          <a:p>
+            <a:pPr indent="0" marL="0">
+              <a:lnSpc>
+                <a:spcPct val="110000"/>
+              </a:lnSpc>
+              <a:buNone/>
+            </a:pPr>
+            <a:r>
+              <a:rPr lang="en-US" sz="1050" b="1" dirty="0">
+                <a:solidFill>
+                  <a:srgbClr val="1428A0"/>
+                </a:solidFill>
+                <a:latin typeface="Malgun Gothic" pitchFamily="34" charset="0"/>
+                <a:ea typeface="Malgun Gothic" pitchFamily="34" charset="-122"/>
+                <a:cs typeface="Malgun Gothic" pitchFamily="34" charset="-120"/>
+              </a:rPr>
+              <a:t>결과  </a:t>
+            </a:r>
+            <a:pPr indent="0" marL="0">
+              <a:lnSpc>
+                <a:spcPct val="110000"/>
+              </a:lnSpc>
+              <a:buNone/>
+            </a:pPr>
+            <a:r>
+              <a:rPr lang="en-US" sz="1050" dirty="0">
+                <a:solidFill>
+                  <a:srgbClr val="1A1A1A"/>
+                </a:solidFill>
+                <a:latin typeface="Malgun Gothic" pitchFamily="34" charset="0"/>
+                <a:ea typeface="Malgun Gothic" pitchFamily="34" charset="-122"/>
+                <a:cs typeface="Malgun Gothic" pitchFamily="34" charset="-120"/>
+              </a:rPr>
+              <a:t>일반 서버 앱 대비 월등한 쓰기 밀도: mixed-use 등급을 넘는 내구성 요구</a:t>
+            </a:r>
+            <a:endParaRPr lang="en-US" sz="1050" dirty="0"/>
+          </a:p>
+        </p:txBody>
+      </p:sp>
+      <p:sp>
+        <p:nvSpPr>
+          <p:cNvPr id="45" name="Text 43"/>
+          <p:cNvSpPr/>
+          <p:nvPr/>
+        </p:nvSpPr>
+        <p:spPr>
+          <a:xfrm>
+            <a:off x="4498848" y="5870448"/>
+            <a:ext cx="3200400" cy="237744"/>
+          </a:xfrm>
+          <a:prstGeom prst="rect">
+            <a:avLst/>
+          </a:prstGeom>
+          <a:noFill/>
+          <a:ln/>
+        </p:spPr>
+        <p:txBody>
+          <a:bodyPr wrap="square" lIns="0" tIns="0" rIns="0" bIns="0" rtlCol="0" anchor="ctr"/>
+          <a:lstStyle/>
+          <a:p>
+            <a:pPr indent="0" marL="0">
+              <a:buNone/>
+            </a:pPr>
+            <a:r>
+              <a:rPr lang="en-US" sz="900" dirty="0">
+                <a:solidFill>
+                  <a:srgbClr val="555555"/>
+                </a:solidFill>
+                <a:latin typeface="Malgun Gothic" pitchFamily="34" charset="0"/>
+                <a:ea typeface="Malgun Gothic" pitchFamily="34" charset="-122"/>
+                <a:cs typeface="Malgun Gothic" pitchFamily="34" charset="-120"/>
+              </a:rPr>
+              <a:t>출처: ScaleFlux 발표 · NVIDIA Dynamo 문서</a:t>
+            </a:r>
+            <a:endParaRPr lang="en-US" sz="900" dirty="0"/>
+          </a:p>
+        </p:txBody>
+      </p:sp>
+      <p:sp>
+        <p:nvSpPr>
+          <p:cNvPr id="46" name="Text 44"/>
+          <p:cNvSpPr/>
+          <p:nvPr/>
+        </p:nvSpPr>
+        <p:spPr>
+          <a:xfrm>
+            <a:off x="8330184" y="1773936"/>
+            <a:ext cx="3200400" cy="256032"/>
+          </a:xfrm>
+          <a:prstGeom prst="rect">
+            <a:avLst/>
+          </a:prstGeom>
+          <a:noFill/>
+          <a:ln/>
+        </p:spPr>
+        <p:txBody>
+          <a:bodyPr wrap="square" lIns="0" tIns="0" rIns="0" bIns="0" rtlCol="0" anchor="ctr"/>
+          <a:lstStyle/>
+          <a:p>
+            <a:pPr indent="0" marL="0">
+              <a:buNone/>
+            </a:pPr>
+            <a:r>
+              <a:rPr lang="en-US" sz="1050" b="1" dirty="0">
+                <a:solidFill>
+                  <a:srgbClr val="1428A0"/>
+                </a:solidFill>
+                <a:latin typeface="Malgun Gothic" pitchFamily="34" charset="0"/>
+                <a:ea typeface="Malgun Gothic" pitchFamily="34" charset="-122"/>
+                <a:cs typeface="Malgun Gothic" pitchFamily="34" charset="-120"/>
+              </a:rPr>
+              <a:t>요구 대비 2~10배 갭 (5년 보증 기준 DWPD)</a:t>
+            </a:r>
+            <a:endParaRPr lang="en-US" sz="1050" dirty="0"/>
+          </a:p>
+        </p:txBody>
+      </p:sp>
+      <p:sp>
+        <p:nvSpPr>
+          <p:cNvPr id="47" name="Shape 45"/>
+          <p:cNvSpPr/>
+          <p:nvPr/>
+        </p:nvSpPr>
+        <p:spPr>
+          <a:xfrm>
+            <a:off x="8275320" y="4370832"/>
+            <a:ext cx="3246120" cy="0"/>
+          </a:xfrm>
+          <a:prstGeom prst="line">
+            <a:avLst/>
+          </a:prstGeom>
+          <a:noFill/>
+          <a:ln w="12700">
+            <a:solidFill>
+              <a:srgbClr val="555555"/>
+            </a:solidFill>
+            <a:prstDash val="solid"/>
+          </a:ln>
+        </p:spPr>
+      </p:sp>
+      <p:sp>
+        <p:nvSpPr>
+          <p:cNvPr id="48" name="Shape 46"/>
+          <p:cNvSpPr/>
+          <p:nvPr/>
+        </p:nvSpPr>
+        <p:spPr>
+          <a:xfrm>
+            <a:off x="8412480" y="4244645"/>
+            <a:ext cx="566928" cy="126187"/>
+          </a:xfrm>
+          <a:prstGeom prst="rect">
+            <a:avLst/>
+          </a:prstGeom>
+          <a:solidFill>
+            <a:srgbClr val="B9C2D0"/>
+          </a:solidFill>
+          <a:ln/>
+        </p:spPr>
+      </p:sp>
+      <p:sp>
+        <p:nvSpPr>
+          <p:cNvPr id="49" name="Text 47"/>
+          <p:cNvSpPr/>
+          <p:nvPr/>
+        </p:nvSpPr>
+        <p:spPr>
+          <a:xfrm>
+            <a:off x="8229600" y="3988613"/>
+            <a:ext cx="914400" cy="237744"/>
+          </a:xfrm>
+          <a:prstGeom prst="rect">
+            <a:avLst/>
+          </a:prstGeom>
+          <a:noFill/>
+          <a:ln/>
+        </p:spPr>
+        <p:txBody>
+          <a:bodyPr wrap="square" lIns="0" tIns="0" rIns="0" bIns="0" rtlCol="0" anchor="ctr"/>
+          <a:lstStyle/>
+          <a:p>
+            <a:pPr algn="ctr" indent="0" marL="0">
+              <a:buNone/>
+            </a:pPr>
+            <a:r>
+              <a:rPr lang="en-US" sz="1100" b="1" dirty="0">
+                <a:solidFill>
+                  <a:srgbClr val="555555"/>
+                </a:solidFill>
+                <a:latin typeface="Malgun Gothic" pitchFamily="34" charset="0"/>
+                <a:ea typeface="Malgun Gothic" pitchFamily="34" charset="-122"/>
+                <a:cs typeface="Malgun Gothic" pitchFamily="34" charset="-120"/>
+              </a:rPr>
+              <a:t>0.6</a:t>
+            </a:r>
+            <a:endParaRPr lang="en-US" sz="1100" dirty="0"/>
+          </a:p>
+        </p:txBody>
+      </p:sp>
+      <p:sp>
+        <p:nvSpPr>
+          <p:cNvPr id="50" name="Text 48"/>
+          <p:cNvSpPr/>
+          <p:nvPr/>
+        </p:nvSpPr>
+        <p:spPr>
+          <a:xfrm>
+            <a:off x="8211312" y="4407408"/>
+            <a:ext cx="969264" cy="402336"/>
+          </a:xfrm>
+          <a:prstGeom prst="rect">
+            <a:avLst/>
+          </a:prstGeom>
+          <a:noFill/>
+          <a:ln/>
+        </p:spPr>
+        <p:txBody>
+          <a:bodyPr wrap="square" lIns="0" tIns="0" rIns="0" bIns="0" rtlCol="0" anchor="ctr"/>
+          <a:lstStyle/>
+          <a:p>
+            <a:pPr algn="ctr" indent="0" marL="0">
+              <a:lnSpc>
+                <a:spcPct val="100000"/>
+              </a:lnSpc>
+              <a:buNone/>
+            </a:pPr>
+            <a:r>
+              <a:rPr lang="en-US" sz="900" dirty="0">
+                <a:solidFill>
+                  <a:srgbClr val="1A1A1A"/>
+                </a:solidFill>
+                <a:latin typeface="Malgun Gothic" pitchFamily="34" charset="0"/>
+                <a:ea typeface="Malgun Gothic" pitchFamily="34" charset="-122"/>
+                <a:cs typeface="Malgun Gothic" pitchFamily="34" charset="-120"/>
+              </a:rPr>
+              <a:t>고용량 QLC</a:t>
+            </a:r>
+            <a:endParaRPr lang="en-US" sz="900" dirty="0"/>
+          </a:p>
+        </p:txBody>
+      </p:sp>
+      <p:sp>
+        <p:nvSpPr>
+          <p:cNvPr id="51" name="Shape 49"/>
+          <p:cNvSpPr/>
+          <p:nvPr/>
+        </p:nvSpPr>
+        <p:spPr>
+          <a:xfrm>
+            <a:off x="9208008" y="4160520"/>
+            <a:ext cx="566928" cy="210312"/>
+          </a:xfrm>
+          <a:prstGeom prst="rect">
+            <a:avLst/>
+          </a:prstGeom>
+          <a:solidFill>
+            <a:srgbClr val="B9C2D0"/>
+          </a:solidFill>
+          <a:ln/>
+        </p:spPr>
+      </p:sp>
+      <p:sp>
+        <p:nvSpPr>
+          <p:cNvPr id="52" name="Text 50"/>
+          <p:cNvSpPr/>
+          <p:nvPr/>
+        </p:nvSpPr>
+        <p:spPr>
+          <a:xfrm>
+            <a:off x="9025128" y="3904488"/>
+            <a:ext cx="914400" cy="237744"/>
+          </a:xfrm>
+          <a:prstGeom prst="rect">
+            <a:avLst/>
+          </a:prstGeom>
+          <a:noFill/>
+          <a:ln/>
+        </p:spPr>
+        <p:txBody>
+          <a:bodyPr wrap="square" lIns="0" tIns="0" rIns="0" bIns="0" rtlCol="0" anchor="ctr"/>
+          <a:lstStyle/>
+          <a:p>
+            <a:pPr algn="ctr" indent="0" marL="0">
+              <a:buNone/>
+            </a:pPr>
+            <a:r>
+              <a:rPr lang="en-US" sz="1100" b="1" dirty="0">
+                <a:solidFill>
+                  <a:srgbClr val="555555"/>
+                </a:solidFill>
+                <a:latin typeface="Malgun Gothic" pitchFamily="34" charset="0"/>
+                <a:ea typeface="Malgun Gothic" pitchFamily="34" charset="-122"/>
+                <a:cs typeface="Malgun Gothic" pitchFamily="34" charset="-120"/>
+              </a:rPr>
+              <a:t>1</a:t>
+            </a:r>
+            <a:endParaRPr lang="en-US" sz="1100" dirty="0"/>
+          </a:p>
+        </p:txBody>
+      </p:sp>
+      <p:sp>
+        <p:nvSpPr>
+          <p:cNvPr id="53" name="Text 51"/>
+          <p:cNvSpPr/>
+          <p:nvPr/>
+        </p:nvSpPr>
+        <p:spPr>
+          <a:xfrm>
+            <a:off x="9006840" y="4407408"/>
+            <a:ext cx="969264" cy="402336"/>
+          </a:xfrm>
+          <a:prstGeom prst="rect">
+            <a:avLst/>
+          </a:prstGeom>
+          <a:noFill/>
+          <a:ln/>
+        </p:spPr>
+        <p:txBody>
+          <a:bodyPr wrap="square" lIns="0" tIns="0" rIns="0" bIns="0" rtlCol="0" anchor="ctr"/>
+          <a:lstStyle/>
+          <a:p>
+            <a:pPr algn="ctr" indent="0" marL="0">
+              <a:lnSpc>
+                <a:spcPct val="100000"/>
+              </a:lnSpc>
+              <a:buNone/>
+            </a:pPr>
+            <a:r>
+              <a:rPr lang="en-US" sz="900" dirty="0">
+                <a:solidFill>
+                  <a:srgbClr val="1A1A1A"/>
+                </a:solidFill>
+                <a:latin typeface="Malgun Gothic" pitchFamily="34" charset="0"/>
+                <a:ea typeface="Malgun Gothic" pitchFamily="34" charset="-122"/>
+                <a:cs typeface="Malgun Gothic" pitchFamily="34" charset="-120"/>
+              </a:rPr>
+              <a:t>TLC RI</a:t>
+            </a:r>
+            <a:endParaRPr lang="en-US" sz="900" dirty="0"/>
+          </a:p>
+        </p:txBody>
+      </p:sp>
+      <p:sp>
+        <p:nvSpPr>
+          <p:cNvPr id="54" name="Shape 52"/>
+          <p:cNvSpPr/>
+          <p:nvPr/>
+        </p:nvSpPr>
+        <p:spPr>
+          <a:xfrm>
+            <a:off x="10003536" y="3739896"/>
+            <a:ext cx="566928" cy="630936"/>
+          </a:xfrm>
+          <a:prstGeom prst="rect">
+            <a:avLst/>
+          </a:prstGeom>
+          <a:solidFill>
+            <a:srgbClr val="B9C2D0"/>
+          </a:solidFill>
+          <a:ln/>
+        </p:spPr>
+      </p:sp>
+      <p:sp>
+        <p:nvSpPr>
+          <p:cNvPr id="55" name="Text 53"/>
+          <p:cNvSpPr/>
+          <p:nvPr/>
+        </p:nvSpPr>
+        <p:spPr>
+          <a:xfrm>
+            <a:off x="9820656" y="3483864"/>
+            <a:ext cx="914400" cy="237744"/>
+          </a:xfrm>
+          <a:prstGeom prst="rect">
+            <a:avLst/>
+          </a:prstGeom>
+          <a:noFill/>
+          <a:ln/>
+        </p:spPr>
+        <p:txBody>
+          <a:bodyPr wrap="square" lIns="0" tIns="0" rIns="0" bIns="0" rtlCol="0" anchor="ctr"/>
+          <a:lstStyle/>
+          <a:p>
+            <a:pPr algn="ctr" indent="0" marL="0">
+              <a:buNone/>
+            </a:pPr>
+            <a:r>
+              <a:rPr lang="en-US" sz="1100" b="1" dirty="0">
+                <a:solidFill>
+                  <a:srgbClr val="555555"/>
+                </a:solidFill>
+                <a:latin typeface="Malgun Gothic" pitchFamily="34" charset="0"/>
+                <a:ea typeface="Malgun Gothic" pitchFamily="34" charset="-122"/>
+                <a:cs typeface="Malgun Gothic" pitchFamily="34" charset="-120"/>
+              </a:rPr>
+              <a:t>3</a:t>
+            </a:r>
+            <a:endParaRPr lang="en-US" sz="1100" dirty="0"/>
+          </a:p>
+        </p:txBody>
+      </p:sp>
+      <p:sp>
+        <p:nvSpPr>
+          <p:cNvPr id="56" name="Text 54"/>
+          <p:cNvSpPr/>
+          <p:nvPr/>
+        </p:nvSpPr>
+        <p:spPr>
+          <a:xfrm>
+            <a:off x="9802368" y="4407408"/>
+            <a:ext cx="969264" cy="402336"/>
+          </a:xfrm>
+          <a:prstGeom prst="rect">
+            <a:avLst/>
+          </a:prstGeom>
+          <a:noFill/>
+          <a:ln/>
+        </p:spPr>
+        <p:txBody>
+          <a:bodyPr wrap="square" lIns="0" tIns="0" rIns="0" bIns="0" rtlCol="0" anchor="ctr"/>
+          <a:lstStyle/>
+          <a:p>
+            <a:pPr algn="ctr" indent="0" marL="0">
+              <a:lnSpc>
+                <a:spcPct val="100000"/>
+              </a:lnSpc>
+              <a:buNone/>
+            </a:pPr>
+            <a:r>
+              <a:rPr lang="en-US" sz="900" dirty="0">
+                <a:solidFill>
+                  <a:srgbClr val="1A1A1A"/>
+                </a:solidFill>
+                <a:latin typeface="Malgun Gothic" pitchFamily="34" charset="0"/>
+                <a:ea typeface="Malgun Gothic" pitchFamily="34" charset="-122"/>
+                <a:cs typeface="Malgun Gothic" pitchFamily="34" charset="-120"/>
+              </a:rPr>
+              <a:t>TLC MU</a:t>
+            </a:r>
+            <a:endParaRPr lang="en-US" sz="900" dirty="0"/>
+          </a:p>
+        </p:txBody>
+      </p:sp>
+      <p:sp>
+        <p:nvSpPr>
+          <p:cNvPr id="57" name="Shape 55"/>
+          <p:cNvSpPr/>
+          <p:nvPr/>
+        </p:nvSpPr>
+        <p:spPr>
+          <a:xfrm>
+            <a:off x="10799064" y="2267712"/>
+            <a:ext cx="566928" cy="630936"/>
+          </a:xfrm>
+          <a:prstGeom prst="rect">
+            <a:avLst/>
+          </a:prstGeom>
+          <a:solidFill>
+            <a:srgbClr val="8FA0DC"/>
+          </a:solidFill>
+          <a:ln/>
+        </p:spPr>
+      </p:sp>
+      <p:sp>
+        <p:nvSpPr>
+          <p:cNvPr id="58" name="Shape 56"/>
+          <p:cNvSpPr/>
+          <p:nvPr/>
+        </p:nvSpPr>
+        <p:spPr>
+          <a:xfrm>
+            <a:off x="10799064" y="2898648"/>
+            <a:ext cx="566928" cy="1472184"/>
+          </a:xfrm>
+          <a:prstGeom prst="rect">
+            <a:avLst/>
+          </a:prstGeom>
+          <a:solidFill>
+            <a:srgbClr val="1428A0"/>
+          </a:solidFill>
+          <a:ln/>
+        </p:spPr>
+      </p:sp>
+      <p:sp>
+        <p:nvSpPr>
+          <p:cNvPr id="59" name="Text 57"/>
+          <p:cNvSpPr/>
+          <p:nvPr/>
+        </p:nvSpPr>
+        <p:spPr>
+          <a:xfrm>
+            <a:off x="10616184" y="2011680"/>
+            <a:ext cx="914400" cy="237744"/>
+          </a:xfrm>
+          <a:prstGeom prst="rect">
+            <a:avLst/>
+          </a:prstGeom>
+          <a:noFill/>
+          <a:ln/>
+        </p:spPr>
+        <p:txBody>
+          <a:bodyPr wrap="square" lIns="0" tIns="0" rIns="0" bIns="0" rtlCol="0" anchor="ctr"/>
+          <a:lstStyle/>
+          <a:p>
+            <a:pPr algn="ctr" indent="0" marL="0">
+              <a:buNone/>
+            </a:pPr>
+            <a:r>
+              <a:rPr lang="en-US" sz="1100" b="1" dirty="0">
+                <a:solidFill>
+                  <a:srgbClr val="1428A0"/>
+                </a:solidFill>
+                <a:latin typeface="Malgun Gothic" pitchFamily="34" charset="0"/>
+                <a:ea typeface="Malgun Gothic" pitchFamily="34" charset="-122"/>
+                <a:cs typeface="Malgun Gothic" pitchFamily="34" charset="-120"/>
+              </a:rPr>
+              <a:t>7~10+</a:t>
+            </a:r>
+            <a:endParaRPr lang="en-US" sz="1100" dirty="0"/>
+          </a:p>
+        </p:txBody>
+      </p:sp>
+      <p:sp>
+        <p:nvSpPr>
+          <p:cNvPr id="60" name="Text 58"/>
+          <p:cNvSpPr/>
+          <p:nvPr/>
+        </p:nvSpPr>
+        <p:spPr>
+          <a:xfrm>
+            <a:off x="10597896" y="4407408"/>
+            <a:ext cx="969264" cy="402336"/>
+          </a:xfrm>
+          <a:prstGeom prst="rect">
+            <a:avLst/>
+          </a:prstGeom>
+          <a:noFill/>
+          <a:ln/>
+        </p:spPr>
+        <p:txBody>
+          <a:bodyPr wrap="square" lIns="0" tIns="0" rIns="0" bIns="0" rtlCol="0" anchor="ctr"/>
+          <a:lstStyle/>
+          <a:p>
+            <a:pPr algn="ctr" indent="0" marL="0">
+              <a:lnSpc>
+                <a:spcPct val="100000"/>
+              </a:lnSpc>
+              <a:buNone/>
+            </a:pPr>
+            <a:r>
+              <a:rPr lang="en-US" sz="900" dirty="0">
+                <a:solidFill>
+                  <a:srgbClr val="1A1A1A"/>
+                </a:solidFill>
+                <a:latin typeface="Malgun Gothic" pitchFamily="34" charset="0"/>
+                <a:ea typeface="Malgun Gothic" pitchFamily="34" charset="-122"/>
+                <a:cs typeface="Malgun Gothic" pitchFamily="34" charset="-120"/>
+              </a:rPr>
+              <a:t>KV cache 요구</a:t>
+            </a:r>
+            <a:endParaRPr lang="en-US" sz="900" dirty="0"/>
+          </a:p>
+        </p:txBody>
+      </p:sp>
+      <p:sp>
+        <p:nvSpPr>
+          <p:cNvPr id="61" name="Shape 59"/>
+          <p:cNvSpPr/>
+          <p:nvPr/>
+        </p:nvSpPr>
+        <p:spPr>
+          <a:xfrm>
+            <a:off x="8311896" y="5029200"/>
+            <a:ext cx="3236976" cy="1225296"/>
+          </a:xfrm>
+          <a:prstGeom prst="roundRect">
+            <a:avLst>
+              <a:gd name="adj" fmla="val 5224"/>
+            </a:avLst>
+          </a:prstGeom>
+          <a:solidFill>
+            <a:srgbClr val="EEF1FA"/>
+          </a:solidFill>
+          <a:ln w="15875">
+            <a:solidFill>
+              <a:srgbClr val="1428A0"/>
+            </a:solidFill>
+            <a:prstDash val="solid"/>
+          </a:ln>
+        </p:spPr>
+      </p:sp>
+      <p:sp>
+        <p:nvSpPr>
+          <p:cNvPr id="62" name="Text 60"/>
+          <p:cNvSpPr/>
+          <p:nvPr/>
+        </p:nvSpPr>
+        <p:spPr>
+          <a:xfrm>
+            <a:off x="8476488" y="5102352"/>
+            <a:ext cx="2926080" cy="1097280"/>
+          </a:xfrm>
+          <a:prstGeom prst="rect">
+            <a:avLst/>
+          </a:prstGeom>
+          <a:noFill/>
+          <a:ln/>
+        </p:spPr>
+        <p:txBody>
+          <a:bodyPr wrap="square" lIns="0" tIns="0" rIns="0" bIns="0" rtlCol="0" anchor="t"/>
+          <a:lstStyle/>
+          <a:p>
+            <a:pPr indent="0" marL="0">
+              <a:lnSpc>
+                <a:spcPct val="114000"/>
+              </a:lnSpc>
+              <a:buNone/>
+            </a:pPr>
+            <a:r>
+              <a:rPr lang="en-US" sz="1100" b="1" dirty="0">
+                <a:solidFill>
+                  <a:srgbClr val="1428A0"/>
+                </a:solidFill>
+                <a:latin typeface="Malgun Gothic" pitchFamily="34" charset="0"/>
+                <a:ea typeface="Malgun Gothic" pitchFamily="34" charset="-122"/>
+                <a:cs typeface="Malgun Gothic" pitchFamily="34" charset="-120"/>
+              </a:rPr>
+              <a:t>갭의 해법이 곧 전략</a:t>
+            </a:r>
+            <a:endParaRPr lang="en-US" sz="1100" dirty="0"/>
+          </a:p>
+          <a:p>
+            <a:pPr indent="0" marL="0">
+              <a:lnSpc>
+                <a:spcPct val="114000"/>
+              </a:lnSpc>
+              <a:buNone/>
+            </a:pPr>
+            <a:r>
+              <a:rPr lang="en-US" sz="950" dirty="0">
+                <a:solidFill>
+                  <a:srgbClr val="1A1A1A"/>
+                </a:solidFill>
+                <a:latin typeface="Malgun Gothic" pitchFamily="34" charset="0"/>
+                <a:ea typeface="Malgun Gothic" pitchFamily="34" charset="-122"/>
+                <a:cs typeface="Malgun Gothic" pitchFamily="34" charset="-120"/>
+              </a:rPr>
+              <a:t>FDP로 수명별 RUH 분리·WAF 절감 = 유효 DWPD 확보 (ScaleFlux도 FDP 200+ 스트림으로 7~10 DWPD 달성) + 고내구 설계. NVIDIA CMX 생태계와 직결</a:t>
+            </a:r>
+            <a:endParaRPr lang="en-US" sz="1100" dirty="0"/>
+          </a:p>
+        </p:txBody>
+      </p:sp>
+    </p:spTree>
+  </p:cSld>
+  <p:clrMapOvr>
+    <a:masterClrMapping/>
+  </p:clrMapOvr>
+</p:sld>
+</file>
+
+<file path=ppt/slides/slide3.xml><?xml version="1.0" encoding="utf-8"?>
+<p:sld xmlns:a="http://schemas.openxmlformats.org/drawingml/2006/main" xmlns:r="http://schemas.openxmlformats.org/officeDocument/2006/relationships" xmlns:p="http://schemas.openxmlformats.org/presentationml/2006/main">
+  <p:cSld name="Slide 3">
     <p:spTree>
       <p:nvGrpSpPr>
         <p:cNvPr id="1" name=""/>

</xml_diff>